<commit_message>
Confirm FlyPig AI team name across application materials
</commit_message>
<xml_diff>
--- a/deliverables/OnDemand-World-Observatory-Proposal.pptx
+++ b/deliverables/OnDemand-World-Observatory-Proposal.pptx
@@ -2,26 +2,26 @@
 <file path=ppt/presentation.xml><?xml version="1.0" encoding="utf-8"?>
 <p:presentation xmlns:p="http://schemas.openxmlformats.org/presentationml/2006/main">
   <p:sldMasterIdLst>
-    <p:sldMasterId xmlns:r="http://schemas.openxmlformats.org/officeDocument/2006/relationships" id="2147483648" r:id="R86f286611a6d4ca3"/>
+    <p:sldMasterId xmlns:r="http://schemas.openxmlformats.org/officeDocument/2006/relationships" id="2147483648" r:id="Rcd9a411546d94d90"/>
   </p:sldMasterIdLst>
   <p:notesMasterIdLst>
-    <p:notesMasterId xmlns:r="http://schemas.openxmlformats.org/officeDocument/2006/relationships" r:id="R486ec68ad39d45fd"/>
+    <p:notesMasterId xmlns:r="http://schemas.openxmlformats.org/officeDocument/2006/relationships" r:id="R414db99e2d6942ca"/>
   </p:notesMasterIdLst>
   <p:sldIdLst>
-    <p:sldId xmlns:r="http://schemas.openxmlformats.org/officeDocument/2006/relationships" id="256" r:id="Ra3099004d21340d1"/>
-    <p:sldId xmlns:r="http://schemas.openxmlformats.org/officeDocument/2006/relationships" id="257" r:id="R98fb56bc44ce476c"/>
-    <p:sldId xmlns:r="http://schemas.openxmlformats.org/officeDocument/2006/relationships" id="258" r:id="R19f64ebe049e40d5"/>
-    <p:sldId xmlns:r="http://schemas.openxmlformats.org/officeDocument/2006/relationships" id="259" r:id="R0600e9b1e4ee4c7e"/>
-    <p:sldId xmlns:r="http://schemas.openxmlformats.org/officeDocument/2006/relationships" id="260" r:id="Rd8664d1c302e4c8e"/>
-    <p:sldId xmlns:r="http://schemas.openxmlformats.org/officeDocument/2006/relationships" id="261" r:id="Rfa367697b3f6450f"/>
-    <p:sldId xmlns:r="http://schemas.openxmlformats.org/officeDocument/2006/relationships" id="262" r:id="R4628b22074bd4a0a"/>
-    <p:sldId xmlns:r="http://schemas.openxmlformats.org/officeDocument/2006/relationships" id="263" r:id="Rc16bcd9363bf4ae6"/>
-    <p:sldId xmlns:r="http://schemas.openxmlformats.org/officeDocument/2006/relationships" id="264" r:id="R646dca2ec69743a4"/>
-    <p:sldId xmlns:r="http://schemas.openxmlformats.org/officeDocument/2006/relationships" id="265" r:id="R7b4f6cb6a4bc4668"/>
-    <p:sldId xmlns:r="http://schemas.openxmlformats.org/officeDocument/2006/relationships" id="266" r:id="R19842754c2934289"/>
-    <p:sldId xmlns:r="http://schemas.openxmlformats.org/officeDocument/2006/relationships" id="267" r:id="R163b1a76d17c4735"/>
-    <p:sldId xmlns:r="http://schemas.openxmlformats.org/officeDocument/2006/relationships" id="268" r:id="Ra2c6449857a047f7"/>
-    <p:sldId xmlns:r="http://schemas.openxmlformats.org/officeDocument/2006/relationships" id="269" r:id="R10aef2ad3e3d4557"/>
+    <p:sldId xmlns:r="http://schemas.openxmlformats.org/officeDocument/2006/relationships" id="256" r:id="R9a86ca8d40c640a6"/>
+    <p:sldId xmlns:r="http://schemas.openxmlformats.org/officeDocument/2006/relationships" id="257" r:id="Ra6e076d61eec4d16"/>
+    <p:sldId xmlns:r="http://schemas.openxmlformats.org/officeDocument/2006/relationships" id="258" r:id="R800f39eaa55d4638"/>
+    <p:sldId xmlns:r="http://schemas.openxmlformats.org/officeDocument/2006/relationships" id="259" r:id="Rd4afae73dda74888"/>
+    <p:sldId xmlns:r="http://schemas.openxmlformats.org/officeDocument/2006/relationships" id="260" r:id="R96056755c2704aa1"/>
+    <p:sldId xmlns:r="http://schemas.openxmlformats.org/officeDocument/2006/relationships" id="261" r:id="Rd9d79e814f3d4861"/>
+    <p:sldId xmlns:r="http://schemas.openxmlformats.org/officeDocument/2006/relationships" id="262" r:id="R915c7e20a5514e93"/>
+    <p:sldId xmlns:r="http://schemas.openxmlformats.org/officeDocument/2006/relationships" id="263" r:id="R59a9f2dcc0704d0b"/>
+    <p:sldId xmlns:r="http://schemas.openxmlformats.org/officeDocument/2006/relationships" id="264" r:id="R946eeeca8c084517"/>
+    <p:sldId xmlns:r="http://schemas.openxmlformats.org/officeDocument/2006/relationships" id="265" r:id="Rd74b02ac6818434c"/>
+    <p:sldId xmlns:r="http://schemas.openxmlformats.org/officeDocument/2006/relationships" id="266" r:id="Rf3aa32bf7ac44f5b"/>
+    <p:sldId xmlns:r="http://schemas.openxmlformats.org/officeDocument/2006/relationships" id="267" r:id="R4cf56d2cb9864854"/>
+    <p:sldId xmlns:r="http://schemas.openxmlformats.org/officeDocument/2006/relationships" id="268" r:id="Rc0dd566f6cd84295"/>
+    <p:sldId xmlns:r="http://schemas.openxmlformats.org/officeDocument/2006/relationships" id="269" r:id="R49ad7dae8069443e"/>
   </p:sldIdLst>
   <p:sldSz cx="12192000" cy="6858000"/>
   <p:notesSz cx="6858000" cy="9144000"/>
@@ -455,7 +455,7 @@
           <a:lstStyle xmlns:a="http://schemas.openxmlformats.org/drawingml/2006/main"/>
           <a:p xmlns:a="http://schemas.openxmlformats.org/drawingml/2006/main">
             <a:r>
-              <a:t>New proposal and interface drafts only. No generated-on-open prototype or hardware result. Author credit M.K. Hsu. Product definition from author instruction, 28 Oct 2026. Official track: https://contest.bhuntr.com/tw/39jg9vimiynrhlksze/home/</a:t>
+              <a:t>New proposal and interface drafts only. No generated-on-open prototype or hardware result. Team: FlyPig AI. Author credit M.K. Hsu. Product definition from author instruction, 28 Oct 2026. Official track: https://contest.bhuntr.com/tw/39jg9vimiynrhlksze/home/</a:t>
             </a:r>
           </a:p>
         </p:txBody>
@@ -1412,7 +1412,7 @@
           <p:cNvPr id="3" name="Title">
             <a:extLst xmlns:a="http://schemas.openxmlformats.org/drawingml/2006/main">
               <a:ext uri="{FF2B5EF4-FFF2-40B4-BE49-F238E27FC236}">
-                <a16:creationId xmlns:a16="http://schemas.microsoft.com/office/drawing/2014/main" id="{690D0298-ABFB-4A6B-BE78-16FFBAC50426}"/>
+                <a16:creationId xmlns:a16="http://schemas.microsoft.com/office/drawing/2014/main" id="{597A1FD8-33D8-4725-B4C4-04F7A966C74A}"/>
               </a:ext>
             </a:extLst>
           </p:cNvPr>
@@ -1641,7 +1641,7 @@
           <p:cNvPr id="2" name="Subtitle">
             <a:extLst xmlns:a="http://schemas.openxmlformats.org/drawingml/2006/main">
               <a:ext uri="{FF2B5EF4-FFF2-40B4-BE49-F238E27FC236}">
-                <a16:creationId xmlns:a16="http://schemas.microsoft.com/office/drawing/2014/main" id="{21B8AF40-2B01-4832-ACB3-FF3F67EE492A}"/>
+                <a16:creationId xmlns:a16="http://schemas.microsoft.com/office/drawing/2014/main" id="{8A58E861-8921-4F4D-8B59-5B75E22FAAAA}"/>
               </a:ext>
             </a:extLst>
           </p:cNvPr>
@@ -1887,7 +1887,7 @@
           <p:cNvPr id="2" name="Section title">
             <a:extLst xmlns:a="http://schemas.openxmlformats.org/drawingml/2006/main">
               <a:ext uri="{FF2B5EF4-FFF2-40B4-BE49-F238E27FC236}">
-                <a16:creationId xmlns:a16="http://schemas.microsoft.com/office/drawing/2014/main" id="{439712D2-712A-4B56-9F5C-2334B44BCFFA}"/>
+                <a16:creationId xmlns:a16="http://schemas.microsoft.com/office/drawing/2014/main" id="{9BFF3040-1396-4297-8487-03AD99F49A67}"/>
               </a:ext>
             </a:extLst>
           </p:cNvPr>
@@ -2133,7 +2133,7 @@
           <p:cNvPr id="3" name="Title">
             <a:extLst xmlns:a="http://schemas.openxmlformats.org/drawingml/2006/main">
               <a:ext uri="{FF2B5EF4-FFF2-40B4-BE49-F238E27FC236}">
-                <a16:creationId xmlns:a16="http://schemas.microsoft.com/office/drawing/2014/main" id="{6FACDF2B-B34B-4B57-AF3D-1FD5885DBD5F}"/>
+                <a16:creationId xmlns:a16="http://schemas.microsoft.com/office/drawing/2014/main" id="{C5F15EF0-D549-4181-82F9-D6C59BAE414F}"/>
               </a:ext>
             </a:extLst>
           </p:cNvPr>
@@ -2362,7 +2362,7 @@
           <p:cNvPr id="2" name="Body">
             <a:extLst xmlns:a="http://schemas.openxmlformats.org/drawingml/2006/main">
               <a:ext uri="{FF2B5EF4-FFF2-40B4-BE49-F238E27FC236}">
-                <a16:creationId xmlns:a16="http://schemas.microsoft.com/office/drawing/2014/main" id="{C3748F5E-3662-4EF0-8AEC-93C8A3817E6A}"/>
+                <a16:creationId xmlns:a16="http://schemas.microsoft.com/office/drawing/2014/main" id="{69E7A3C8-68A2-4858-ADEB-CFF3AD4B110F}"/>
               </a:ext>
             </a:extLst>
           </p:cNvPr>
@@ -2608,7 +2608,7 @@
           <p:cNvPr id="4" name="Title">
             <a:extLst xmlns:a="http://schemas.openxmlformats.org/drawingml/2006/main">
               <a:ext uri="{FF2B5EF4-FFF2-40B4-BE49-F238E27FC236}">
-                <a16:creationId xmlns:a16="http://schemas.microsoft.com/office/drawing/2014/main" id="{73244156-1B06-45B9-A156-8EDA3A76E218}"/>
+                <a16:creationId xmlns:a16="http://schemas.microsoft.com/office/drawing/2014/main" id="{D4101E2A-4BB1-44C4-816D-131089DA0CE6}"/>
               </a:ext>
             </a:extLst>
           </p:cNvPr>
@@ -2837,7 +2837,7 @@
           <p:cNvPr id="2" name="Left column">
             <a:extLst xmlns:a="http://schemas.openxmlformats.org/drawingml/2006/main">
               <a:ext uri="{FF2B5EF4-FFF2-40B4-BE49-F238E27FC236}">
-                <a16:creationId xmlns:a16="http://schemas.microsoft.com/office/drawing/2014/main" id="{1C8E953B-6884-422D-882A-6E3F270FC4C8}"/>
+                <a16:creationId xmlns:a16="http://schemas.microsoft.com/office/drawing/2014/main" id="{A5F6F9BD-7118-402A-96F2-2225B3EDBE24}"/>
               </a:ext>
             </a:extLst>
           </p:cNvPr>
@@ -3066,7 +3066,7 @@
           <p:cNvPr id="3" name="Right column">
             <a:extLst xmlns:a="http://schemas.openxmlformats.org/drawingml/2006/main">
               <a:ext uri="{FF2B5EF4-FFF2-40B4-BE49-F238E27FC236}">
-                <a16:creationId xmlns:a16="http://schemas.microsoft.com/office/drawing/2014/main" id="{90CA558E-8662-4FD2-9D44-4A82A838A9BC}"/>
+                <a16:creationId xmlns:a16="http://schemas.microsoft.com/office/drawing/2014/main" id="{24153F99-38A4-44A4-9E40-94C00F9C7456}"/>
               </a:ext>
             </a:extLst>
           </p:cNvPr>
@@ -3312,7 +3312,7 @@
           <p:cNvPr id="3" name="Title">
             <a:extLst xmlns:a="http://schemas.openxmlformats.org/drawingml/2006/main">
               <a:ext uri="{FF2B5EF4-FFF2-40B4-BE49-F238E27FC236}">
-                <a16:creationId xmlns:a16="http://schemas.microsoft.com/office/drawing/2014/main" id="{913598FC-5A3B-46F7-9E44-BA5496383610}"/>
+                <a16:creationId xmlns:a16="http://schemas.microsoft.com/office/drawing/2014/main" id="{B01B39BC-1E04-4882-92FA-00D7EE0AAE18}"/>
               </a:ext>
             </a:extLst>
           </p:cNvPr>
@@ -3541,7 +3541,7 @@
           <p:cNvPr id="2" name="Left column">
             <a:extLst xmlns:a="http://schemas.openxmlformats.org/drawingml/2006/main">
               <a:ext uri="{FF2B5EF4-FFF2-40B4-BE49-F238E27FC236}">
-                <a16:creationId xmlns:a16="http://schemas.microsoft.com/office/drawing/2014/main" id="{F48B6E33-CC61-4F9E-919D-7B072C02AB5F}"/>
+                <a16:creationId xmlns:a16="http://schemas.microsoft.com/office/drawing/2014/main" id="{4C1F3E4E-B8A1-4FD7-AF9F-909EBF8A4D35}"/>
               </a:ext>
             </a:extLst>
           </p:cNvPr>
@@ -3808,12 +3808,12 @@
   </p:cSld>
   <p:clrMap bg1="lt1" tx1="dk1" bg2="lt2" tx2="dk2" accent1="accent1" accent2="accent2" accent3="accent3" accent4="accent4" accent5="accent5" accent6="accent6" hlink="hlink" folHlink="folHlink"/>
   <p:sldLayoutIdLst>
-    <p:sldLayoutId xmlns:r="http://schemas.openxmlformats.org/officeDocument/2006/relationships" id="2147483649" r:id="R2732efe61f1c47ea"/>
-    <p:sldLayoutId xmlns:r="http://schemas.openxmlformats.org/officeDocument/2006/relationships" id="2147483650" r:id="R0e99ad94a2154e52"/>
-    <p:sldLayoutId xmlns:r="http://schemas.openxmlformats.org/officeDocument/2006/relationships" id="2147483651" r:id="R2fa42facce454fbe"/>
-    <p:sldLayoutId xmlns:r="http://schemas.openxmlformats.org/officeDocument/2006/relationships" id="2147483652" r:id="Rc8b1d38cb22143fd"/>
-    <p:sldLayoutId xmlns:r="http://schemas.openxmlformats.org/officeDocument/2006/relationships" id="2147483653" r:id="R8388ed174029456f"/>
-    <p:sldLayoutId xmlns:r="http://schemas.openxmlformats.org/officeDocument/2006/relationships" id="2147483654" r:id="Rc4f7bc6de2224b98"/>
+    <p:sldLayoutId xmlns:r="http://schemas.openxmlformats.org/officeDocument/2006/relationships" id="2147483649" r:id="Rd8c3866676d44713"/>
+    <p:sldLayoutId xmlns:r="http://schemas.openxmlformats.org/officeDocument/2006/relationships" id="2147483650" r:id="Raa7f3baa8fe64393"/>
+    <p:sldLayoutId xmlns:r="http://schemas.openxmlformats.org/officeDocument/2006/relationships" id="2147483651" r:id="R31766046f5254d6b"/>
+    <p:sldLayoutId xmlns:r="http://schemas.openxmlformats.org/officeDocument/2006/relationships" id="2147483652" r:id="R449782dc46524f7b"/>
+    <p:sldLayoutId xmlns:r="http://schemas.openxmlformats.org/officeDocument/2006/relationships" id="2147483653" r:id="Rfba53311e49a4f06"/>
+    <p:sldLayoutId xmlns:r="http://schemas.openxmlformats.org/officeDocument/2006/relationships" id="2147483654" r:id="R01e3c14cf04c4bef"/>
   </p:sldLayoutIdLst>
   <p:txStyles>
     <p:titleStyle>
@@ -4364,7 +4364,7 @@
           <p:cNvPr id="13" name="">
             <a:extLst xmlns:a="http://schemas.openxmlformats.org/drawingml/2006/main">
               <a:ext uri="{FF2B5EF4-FFF2-40B4-BE49-F238E27FC236}">
-                <a16:creationId xmlns:a16="http://schemas.microsoft.com/office/drawing/2014/main" id="{6FD6F9CF-91A5-4E7A-BB3E-911ADA9499B3}"/>
+                <a16:creationId xmlns:a16="http://schemas.microsoft.com/office/drawing/2014/main" id="{E0BF122B-40BB-40CA-86B3-47EAE712415F}"/>
               </a:ext>
             </a:extLst>
           </p:cNvPr>
@@ -4544,7 +4544,7 @@
           <p:cNvPr id="2" name="">
             <a:extLst xmlns:a="http://schemas.openxmlformats.org/drawingml/2006/main">
               <a:ext uri="{FF2B5EF4-FFF2-40B4-BE49-F238E27FC236}">
-                <a16:creationId xmlns:a16="http://schemas.microsoft.com/office/drawing/2014/main" id="{0AC0913F-8560-4413-83FC-FB88757C71CF}"/>
+                <a16:creationId xmlns:a16="http://schemas.microsoft.com/office/drawing/2014/main" id="{83EFB94C-4DF6-454A-A031-F92E29543AFC}"/>
               </a:ext>
             </a:extLst>
           </p:cNvPr>
@@ -4575,7 +4575,7 @@
           <p:cNvPr id="3" name="">
             <a:extLst xmlns:a="http://schemas.openxmlformats.org/drawingml/2006/main">
               <a:ext uri="{FF2B5EF4-FFF2-40B4-BE49-F238E27FC236}">
-                <a16:creationId xmlns:a16="http://schemas.microsoft.com/office/drawing/2014/main" id="{2632BF14-4349-4E7E-BE10-645B5B83AA84}"/>
+                <a16:creationId xmlns:a16="http://schemas.microsoft.com/office/drawing/2014/main" id="{33CAD395-1ED3-4028-AC35-EC4C22F22CA3}"/>
               </a:ext>
             </a:extLst>
           </p:cNvPr>
@@ -4732,7 +4732,7 @@
           <p:cNvPr id="4" name="">
             <a:extLst xmlns:a="http://schemas.openxmlformats.org/drawingml/2006/main">
               <a:ext uri="{FF2B5EF4-FFF2-40B4-BE49-F238E27FC236}">
-                <a16:creationId xmlns:a16="http://schemas.microsoft.com/office/drawing/2014/main" id="{9F243F94-6878-4289-B937-265C98242032}"/>
+                <a16:creationId xmlns:a16="http://schemas.microsoft.com/office/drawing/2014/main" id="{1411AB15-1F78-4269-8C32-54BEAFCD72E3}"/>
               </a:ext>
             </a:extLst>
           </p:cNvPr>
@@ -4889,7 +4889,7 @@
           <p:cNvPr id="5" name="">
             <a:extLst xmlns:a="http://schemas.openxmlformats.org/drawingml/2006/main">
               <a:ext uri="{FF2B5EF4-FFF2-40B4-BE49-F238E27FC236}">
-                <a16:creationId xmlns:a16="http://schemas.microsoft.com/office/drawing/2014/main" id="{FAFB20E2-528A-45B2-A830-EF98C73D4FF2}"/>
+                <a16:creationId xmlns:a16="http://schemas.microsoft.com/office/drawing/2014/main" id="{E5B3D4C0-8457-4DAD-8F6C-0A9795FBD10D}"/>
               </a:ext>
             </a:extLst>
           </p:cNvPr>
@@ -5069,7 +5069,7 @@
           <p:cNvPr id="6" name="">
             <a:extLst xmlns:a="http://schemas.openxmlformats.org/drawingml/2006/main">
               <a:ext uri="{FF2B5EF4-FFF2-40B4-BE49-F238E27FC236}">
-                <a16:creationId xmlns:a16="http://schemas.microsoft.com/office/drawing/2014/main" id="{71F312AF-6333-4E9F-876E-409FC293BEA3}"/>
+                <a16:creationId xmlns:a16="http://schemas.microsoft.com/office/drawing/2014/main" id="{41863175-FC9D-4541-A477-2E07CE465ADE}"/>
               </a:ext>
             </a:extLst>
           </p:cNvPr>
@@ -5216,7 +5216,7 @@
                 <a:ea typeface="Helvetica Neue"/>
                 <a:cs typeface="Helvetica Neue"/>
               </a:rPr>
-              <a:t>M.K. Hsu</a:t>
+              <a:t>Team: FlyPig AI / Author: M.K. Hsu</a:t>
             </a:r>
           </a:p>
           <a:p xmlns:a="http://schemas.openxmlformats.org/drawingml/2006/main">
@@ -5249,7 +5249,7 @@
           <p:cNvPr id="7" name="">
             <a:extLst xmlns:a="http://schemas.openxmlformats.org/drawingml/2006/main">
               <a:ext uri="{FF2B5EF4-FFF2-40B4-BE49-F238E27FC236}">
-                <a16:creationId xmlns:a16="http://schemas.microsoft.com/office/drawing/2014/main" id="{6B040AF5-E867-45A4-BEB6-CE858CE11015}"/>
+                <a16:creationId xmlns:a16="http://schemas.microsoft.com/office/drawing/2014/main" id="{DBED829E-7A82-425D-B8AA-706DAE7F3EB9}"/>
               </a:ext>
             </a:extLst>
           </p:cNvPr>
@@ -5406,7 +5406,7 @@
           <p:cNvPr id="8" name="">
             <a:extLst xmlns:a="http://schemas.openxmlformats.org/drawingml/2006/main">
               <a:ext uri="{FF2B5EF4-FFF2-40B4-BE49-F238E27FC236}">
-                <a16:creationId xmlns:a16="http://schemas.microsoft.com/office/drawing/2014/main" id="{930A0BAC-6153-460E-B6C9-BE531F4A26D9}"/>
+                <a16:creationId xmlns:a16="http://schemas.microsoft.com/office/drawing/2014/main" id="{FE55F64E-F6F4-4E0A-8B87-9EF925EB9102}"/>
               </a:ext>
             </a:extLst>
           </p:cNvPr>
@@ -5437,7 +5437,7 @@
           <p:cNvPr id="9" name="">
             <a:extLst xmlns:a="http://schemas.openxmlformats.org/drawingml/2006/main">
               <a:ext uri="{FF2B5EF4-FFF2-40B4-BE49-F238E27FC236}">
-                <a16:creationId xmlns:a16="http://schemas.microsoft.com/office/drawing/2014/main" id="{7CB4E4D6-05B0-4BA5-8795-779038F345AA}"/>
+                <a16:creationId xmlns:a16="http://schemas.microsoft.com/office/drawing/2014/main" id="{B32E1827-6004-4C8D-9DEE-801C50BCE9F4}"/>
               </a:ext>
             </a:extLst>
           </p:cNvPr>
@@ -5468,7 +5468,7 @@
           <p:cNvPr id="10" name="">
             <a:extLst xmlns:a="http://schemas.openxmlformats.org/drawingml/2006/main">
               <a:ext uri="{FF2B5EF4-FFF2-40B4-BE49-F238E27FC236}">
-                <a16:creationId xmlns:a16="http://schemas.microsoft.com/office/drawing/2014/main" id="{E78E46CC-162E-4560-B41E-210B8810A263}"/>
+                <a16:creationId xmlns:a16="http://schemas.microsoft.com/office/drawing/2014/main" id="{1FB64EB4-B718-4219-9AE4-B541379270B9}"/>
               </a:ext>
             </a:extLst>
           </p:cNvPr>
@@ -5499,7 +5499,7 @@
           <p:cNvPr id="11" name="">
             <a:extLst xmlns:a="http://schemas.openxmlformats.org/drawingml/2006/main">
               <a:ext uri="{FF2B5EF4-FFF2-40B4-BE49-F238E27FC236}">
-                <a16:creationId xmlns:a16="http://schemas.microsoft.com/office/drawing/2014/main" id="{84636F79-FBCA-4522-A4BD-C7A1C795DC7F}"/>
+                <a16:creationId xmlns:a16="http://schemas.microsoft.com/office/drawing/2014/main" id="{D90F98F9-E189-44E8-AFD6-5A3F958D2116}"/>
               </a:ext>
             </a:extLst>
           </p:cNvPr>
@@ -5530,7 +5530,7 @@
           <p:cNvPr id="12" name="">
             <a:extLst xmlns:a="http://schemas.openxmlformats.org/drawingml/2006/main">
               <a:ext uri="{FF2B5EF4-FFF2-40B4-BE49-F238E27FC236}">
-                <a16:creationId xmlns:a16="http://schemas.microsoft.com/office/drawing/2014/main" id="{783DB596-5682-4724-BC99-7639C200388D}"/>
+                <a16:creationId xmlns:a16="http://schemas.microsoft.com/office/drawing/2014/main" id="{E2BE8CE3-3D6B-4505-9CAB-9FEDBA9A2EB4}"/>
               </a:ext>
             </a:extLst>
           </p:cNvPr>
@@ -5708,7 +5708,7 @@
     </p:spTree>
     <p:extLst>
       <p:ext uri="{BB962C8B-B14F-4D97-AF65-F5344CB8AC3E}">
-        <p14:creationId xmlns:p14="http://schemas.microsoft.com/office/powerpoint/2010/main" val="34131768"/>
+        <p14:creationId xmlns:p14="http://schemas.microsoft.com/office/powerpoint/2010/main" val="1401389185"/>
       </p:ext>
     </p:extLst>
   </p:cSld>
@@ -5739,7 +5739,7 @@
           <p:cNvPr id="13" name="">
             <a:extLst xmlns:a="http://schemas.openxmlformats.org/drawingml/2006/main">
               <a:ext uri="{FF2B5EF4-FFF2-40B4-BE49-F238E27FC236}">
-                <a16:creationId xmlns:a16="http://schemas.microsoft.com/office/drawing/2014/main" id="{8873FDCF-CEEF-4877-93BD-1A4F28F87330}"/>
+                <a16:creationId xmlns:a16="http://schemas.microsoft.com/office/drawing/2014/main" id="{917BDDA8-216B-4A5F-8442-5117E5F952B9}"/>
               </a:ext>
             </a:extLst>
           </p:cNvPr>
@@ -5896,7 +5896,7 @@
           <p:cNvPr id="2" name="">
             <a:extLst xmlns:a="http://schemas.openxmlformats.org/drawingml/2006/main">
               <a:ext uri="{FF2B5EF4-FFF2-40B4-BE49-F238E27FC236}">
-                <a16:creationId xmlns:a16="http://schemas.microsoft.com/office/drawing/2014/main" id="{A89D4E0D-5B0D-45DE-B540-4540E4C696BD}"/>
+                <a16:creationId xmlns:a16="http://schemas.microsoft.com/office/drawing/2014/main" id="{A2BB70D5-9E84-4B09-AC5F-9E41F2C3AC1E}"/>
               </a:ext>
             </a:extLst>
           </p:cNvPr>
@@ -5927,7 +5927,7 @@
           <p:cNvPr id="3" name="">
             <a:extLst xmlns:a="http://schemas.openxmlformats.org/drawingml/2006/main">
               <a:ext uri="{FF2B5EF4-FFF2-40B4-BE49-F238E27FC236}">
-                <a16:creationId xmlns:a16="http://schemas.microsoft.com/office/drawing/2014/main" id="{16B5FEC2-AD90-405E-B352-457FDCE600E5}"/>
+                <a16:creationId xmlns:a16="http://schemas.microsoft.com/office/drawing/2014/main" id="{A12B8A1E-54FB-4540-B409-3A2AD29C96E9}"/>
               </a:ext>
             </a:extLst>
           </p:cNvPr>
@@ -6084,7 +6084,7 @@
           <p:cNvPr id="4" name="">
             <a:extLst xmlns:a="http://schemas.openxmlformats.org/drawingml/2006/main">
               <a:ext uri="{FF2B5EF4-FFF2-40B4-BE49-F238E27FC236}">
-                <a16:creationId xmlns:a16="http://schemas.microsoft.com/office/drawing/2014/main" id="{86883878-021C-4743-9726-1D9C2BD949B5}"/>
+                <a16:creationId xmlns:a16="http://schemas.microsoft.com/office/drawing/2014/main" id="{480920B0-53D4-4BE4-96C8-9B4AFF68307C}"/>
               </a:ext>
             </a:extLst>
           </p:cNvPr>
@@ -6241,7 +6241,7 @@
           <p:cNvPr id="5" name="">
             <a:extLst xmlns:a="http://schemas.openxmlformats.org/drawingml/2006/main">
               <a:ext uri="{FF2B5EF4-FFF2-40B4-BE49-F238E27FC236}">
-                <a16:creationId xmlns:a16="http://schemas.microsoft.com/office/drawing/2014/main" id="{CA823630-305E-4933-BA30-DCDC92C86464}"/>
+                <a16:creationId xmlns:a16="http://schemas.microsoft.com/office/drawing/2014/main" id="{58DF88DD-057F-48DE-A455-58079E838005}"/>
               </a:ext>
             </a:extLst>
           </p:cNvPr>
@@ -6398,7 +6398,7 @@
           <p:cNvPr id="6" name="">
             <a:extLst xmlns:a="http://schemas.openxmlformats.org/drawingml/2006/main">
               <a:ext uri="{FF2B5EF4-FFF2-40B4-BE49-F238E27FC236}">
-                <a16:creationId xmlns:a16="http://schemas.microsoft.com/office/drawing/2014/main" id="{2ED0B5C9-1A2E-4DF2-9E36-E6462D8AD2F0}"/>
+                <a16:creationId xmlns:a16="http://schemas.microsoft.com/office/drawing/2014/main" id="{6A2E6D98-DE23-4748-AEFC-B9448EECA5E5}"/>
               </a:ext>
             </a:extLst>
           </p:cNvPr>
@@ -6601,7 +6601,7 @@
           <p:cNvPr id="7" name="">
             <a:extLst xmlns:a="http://schemas.openxmlformats.org/drawingml/2006/main">
               <a:ext uri="{FF2B5EF4-FFF2-40B4-BE49-F238E27FC236}">
-                <a16:creationId xmlns:a16="http://schemas.microsoft.com/office/drawing/2014/main" id="{927E5512-12D6-41F0-8886-3DDAB97BD802}"/>
+                <a16:creationId xmlns:a16="http://schemas.microsoft.com/office/drawing/2014/main" id="{B3931811-2DE1-4897-9284-C40D6EB2368E}"/>
               </a:ext>
             </a:extLst>
           </p:cNvPr>
@@ -6758,7 +6758,7 @@
           <p:cNvPr id="8" name="">
             <a:extLst xmlns:a="http://schemas.openxmlformats.org/drawingml/2006/main">
               <a:ext uri="{FF2B5EF4-FFF2-40B4-BE49-F238E27FC236}">
-                <a16:creationId xmlns:a16="http://schemas.microsoft.com/office/drawing/2014/main" id="{15B362B4-1AD0-4089-81A2-BA73EB51EBB2}"/>
+                <a16:creationId xmlns:a16="http://schemas.microsoft.com/office/drawing/2014/main" id="{39B234F2-6FCB-42B2-9650-FDDF5318A095}"/>
               </a:ext>
             </a:extLst>
           </p:cNvPr>
@@ -6961,7 +6961,7 @@
           <p:cNvPr id="9" name="">
             <a:extLst xmlns:a="http://schemas.openxmlformats.org/drawingml/2006/main">
               <a:ext uri="{FF2B5EF4-FFF2-40B4-BE49-F238E27FC236}">
-                <a16:creationId xmlns:a16="http://schemas.microsoft.com/office/drawing/2014/main" id="{0BA302F2-B3B3-4C98-A024-3ABF4A617D0E}"/>
+                <a16:creationId xmlns:a16="http://schemas.microsoft.com/office/drawing/2014/main" id="{C343A9CB-46F5-4E6A-B80D-778381008462}"/>
               </a:ext>
             </a:extLst>
           </p:cNvPr>
@@ -7118,7 +7118,7 @@
           <p:cNvPr id="10" name="">
             <a:extLst xmlns:a="http://schemas.openxmlformats.org/drawingml/2006/main">
               <a:ext uri="{FF2B5EF4-FFF2-40B4-BE49-F238E27FC236}">
-                <a16:creationId xmlns:a16="http://schemas.microsoft.com/office/drawing/2014/main" id="{22F87A53-0066-4DC8-903F-200E9A4716F4}"/>
+                <a16:creationId xmlns:a16="http://schemas.microsoft.com/office/drawing/2014/main" id="{F11C41EF-E76F-45B3-917E-70A51388BE05}"/>
               </a:ext>
             </a:extLst>
           </p:cNvPr>
@@ -7321,7 +7321,7 @@
           <p:cNvPr id="11" name="">
             <a:extLst xmlns:a="http://schemas.openxmlformats.org/drawingml/2006/main">
               <a:ext uri="{FF2B5EF4-FFF2-40B4-BE49-F238E27FC236}">
-                <a16:creationId xmlns:a16="http://schemas.microsoft.com/office/drawing/2014/main" id="{EF8921FF-249C-49C0-91DE-57F9A31CA5AC}"/>
+                <a16:creationId xmlns:a16="http://schemas.microsoft.com/office/drawing/2014/main" id="{D524493B-2629-4136-9004-9872B2F60DAA}"/>
               </a:ext>
             </a:extLst>
           </p:cNvPr>
@@ -7352,7 +7352,7 @@
           <p:cNvPr id="12" name="">
             <a:extLst xmlns:a="http://schemas.openxmlformats.org/drawingml/2006/main">
               <a:ext uri="{FF2B5EF4-FFF2-40B4-BE49-F238E27FC236}">
-                <a16:creationId xmlns:a16="http://schemas.microsoft.com/office/drawing/2014/main" id="{6CAA71CC-C74A-40E2-AF90-CE0EFB394D65}"/>
+                <a16:creationId xmlns:a16="http://schemas.microsoft.com/office/drawing/2014/main" id="{4F27FDE0-06BA-46E1-BDC5-F3AD7769CE8D}"/>
               </a:ext>
             </a:extLst>
           </p:cNvPr>
@@ -7507,7 +7507,7 @@
     </p:spTree>
     <p:extLst>
       <p:ext uri="{BB962C8B-B14F-4D97-AF65-F5344CB8AC3E}">
-        <p14:creationId xmlns:p14="http://schemas.microsoft.com/office/powerpoint/2010/main" val="610998715"/>
+        <p14:creationId xmlns:p14="http://schemas.microsoft.com/office/powerpoint/2010/main" val="1701835291"/>
       </p:ext>
     </p:extLst>
   </p:cSld>
@@ -7538,7 +7538,7 @@
           <p:cNvPr id="12" name="">
             <a:extLst xmlns:a="http://schemas.openxmlformats.org/drawingml/2006/main">
               <a:ext uri="{FF2B5EF4-FFF2-40B4-BE49-F238E27FC236}">
-                <a16:creationId xmlns:a16="http://schemas.microsoft.com/office/drawing/2014/main" id="{0C6DF67A-BE2A-4661-B154-140016E18E10}"/>
+                <a16:creationId xmlns:a16="http://schemas.microsoft.com/office/drawing/2014/main" id="{7E9366AC-8046-4F3D-A20D-FF0C939E370D}"/>
               </a:ext>
             </a:extLst>
           </p:cNvPr>
@@ -7695,7 +7695,7 @@
           <p:cNvPr id="2" name="">
             <a:extLst xmlns:a="http://schemas.openxmlformats.org/drawingml/2006/main">
               <a:ext uri="{FF2B5EF4-FFF2-40B4-BE49-F238E27FC236}">
-                <a16:creationId xmlns:a16="http://schemas.microsoft.com/office/drawing/2014/main" id="{C6D1BE05-3005-421E-A72B-9FF8CF35897D}"/>
+                <a16:creationId xmlns:a16="http://schemas.microsoft.com/office/drawing/2014/main" id="{35413D7F-EC88-45C2-BD7D-8B82B9F83D7C}"/>
               </a:ext>
             </a:extLst>
           </p:cNvPr>
@@ -7726,7 +7726,7 @@
           <p:cNvPr id="3" name="">
             <a:extLst xmlns:a="http://schemas.openxmlformats.org/drawingml/2006/main">
               <a:ext uri="{FF2B5EF4-FFF2-40B4-BE49-F238E27FC236}">
-                <a16:creationId xmlns:a16="http://schemas.microsoft.com/office/drawing/2014/main" id="{8DBA4CDF-333F-41C1-A1B9-32B1201C9871}"/>
+                <a16:creationId xmlns:a16="http://schemas.microsoft.com/office/drawing/2014/main" id="{0500E34E-034F-47CE-A0B4-582F3E365C66}"/>
               </a:ext>
             </a:extLst>
           </p:cNvPr>
@@ -7883,7 +7883,7 @@
           <p:cNvPr id="4" name="">
             <a:extLst xmlns:a="http://schemas.openxmlformats.org/drawingml/2006/main">
               <a:ext uri="{FF2B5EF4-FFF2-40B4-BE49-F238E27FC236}">
-                <a16:creationId xmlns:a16="http://schemas.microsoft.com/office/drawing/2014/main" id="{C7096870-7201-4B70-B8BE-D1A06E9CE9D2}"/>
+                <a16:creationId xmlns:a16="http://schemas.microsoft.com/office/drawing/2014/main" id="{AF86D5DD-1848-496E-8AA5-1579775571C1}"/>
               </a:ext>
             </a:extLst>
           </p:cNvPr>
@@ -8040,7 +8040,7 @@
           <p:cNvPr id="5" name="">
             <a:extLst xmlns:a="http://schemas.openxmlformats.org/drawingml/2006/main">
               <a:ext uri="{FF2B5EF4-FFF2-40B4-BE49-F238E27FC236}">
-                <a16:creationId xmlns:a16="http://schemas.microsoft.com/office/drawing/2014/main" id="{69C52078-6A01-4F93-BB9E-03B1E5F907C3}"/>
+                <a16:creationId xmlns:a16="http://schemas.microsoft.com/office/drawing/2014/main" id="{4A6F6BAB-98C3-408E-B307-FBF0ECBC57C0}"/>
               </a:ext>
             </a:extLst>
           </p:cNvPr>
@@ -8197,7 +8197,7 @@
           <p:cNvPr id="6" name="">
             <a:extLst xmlns:a="http://schemas.openxmlformats.org/drawingml/2006/main">
               <a:ext uri="{FF2B5EF4-FFF2-40B4-BE49-F238E27FC236}">
-                <a16:creationId xmlns:a16="http://schemas.microsoft.com/office/drawing/2014/main" id="{2A0688CC-A00C-4BCE-940C-850AAAC4A314}"/>
+                <a16:creationId xmlns:a16="http://schemas.microsoft.com/office/drawing/2014/main" id="{70C42880-7176-4067-8D2B-9068B1FAAAAA}"/>
               </a:ext>
             </a:extLst>
           </p:cNvPr>
@@ -8354,7 +8354,7 @@
           <p:cNvPr id="7" name="">
             <a:extLst xmlns:a="http://schemas.openxmlformats.org/drawingml/2006/main">
               <a:ext uri="{FF2B5EF4-FFF2-40B4-BE49-F238E27FC236}">
-                <a16:creationId xmlns:a16="http://schemas.microsoft.com/office/drawing/2014/main" id="{D8424276-D9B4-4D99-9203-098E92F1FAEE}"/>
+                <a16:creationId xmlns:a16="http://schemas.microsoft.com/office/drawing/2014/main" id="{88953821-2EA2-4546-85A5-AEB997F3F436}"/>
               </a:ext>
             </a:extLst>
           </p:cNvPr>
@@ -8511,7 +8511,7 @@
           <p:cNvPr id="8" name="">
             <a:extLst xmlns:a="http://schemas.openxmlformats.org/drawingml/2006/main">
               <a:ext uri="{FF2B5EF4-FFF2-40B4-BE49-F238E27FC236}">
-                <a16:creationId xmlns:a16="http://schemas.microsoft.com/office/drawing/2014/main" id="{6281BCA6-738A-4AAB-863D-0EC20E782943}"/>
+                <a16:creationId xmlns:a16="http://schemas.microsoft.com/office/drawing/2014/main" id="{573A8525-417D-4103-ACC9-39CB9AD6D8FE}"/>
               </a:ext>
             </a:extLst>
           </p:cNvPr>
@@ -8668,7 +8668,7 @@
           <p:cNvPr id="9" name="">
             <a:extLst xmlns:a="http://schemas.openxmlformats.org/drawingml/2006/main">
               <a:ext uri="{FF2B5EF4-FFF2-40B4-BE49-F238E27FC236}">
-                <a16:creationId xmlns:a16="http://schemas.microsoft.com/office/drawing/2014/main" id="{BE1D5FEC-704D-4E04-98CD-337C230344E8}"/>
+                <a16:creationId xmlns:a16="http://schemas.microsoft.com/office/drawing/2014/main" id="{357649D5-E360-406F-8C85-EE543E201990}"/>
               </a:ext>
             </a:extLst>
           </p:cNvPr>
@@ -8825,7 +8825,7 @@
           <p:cNvPr id="10" name="">
             <a:extLst xmlns:a="http://schemas.openxmlformats.org/drawingml/2006/main">
               <a:ext uri="{FF2B5EF4-FFF2-40B4-BE49-F238E27FC236}">
-                <a16:creationId xmlns:a16="http://schemas.microsoft.com/office/drawing/2014/main" id="{D73F83CE-23B9-4CD7-93B1-72785D0CA173}"/>
+                <a16:creationId xmlns:a16="http://schemas.microsoft.com/office/drawing/2014/main" id="{D770FBDC-C940-42F5-8D0E-2E25C1380079}"/>
               </a:ext>
             </a:extLst>
           </p:cNvPr>
@@ -8982,7 +8982,7 @@
           <p:cNvPr id="11" name="">
             <a:extLst xmlns:a="http://schemas.openxmlformats.org/drawingml/2006/main">
               <a:ext uri="{FF2B5EF4-FFF2-40B4-BE49-F238E27FC236}">
-                <a16:creationId xmlns:a16="http://schemas.microsoft.com/office/drawing/2014/main" id="{65AB189E-E382-4516-B8D1-62235CC28297}"/>
+                <a16:creationId xmlns:a16="http://schemas.microsoft.com/office/drawing/2014/main" id="{F6C61562-537E-4A26-8DA0-883865E08432}"/>
               </a:ext>
             </a:extLst>
           </p:cNvPr>
@@ -9137,7 +9137,7 @@
     </p:spTree>
     <p:extLst>
       <p:ext uri="{BB962C8B-B14F-4D97-AF65-F5344CB8AC3E}">
-        <p14:creationId xmlns:p14="http://schemas.microsoft.com/office/powerpoint/2010/main" val="348140213"/>
+        <p14:creationId xmlns:p14="http://schemas.microsoft.com/office/powerpoint/2010/main" val="1212128919"/>
       </p:ext>
     </p:extLst>
   </p:cSld>
@@ -9168,7 +9168,7 @@
           <p:cNvPr id="16" name="">
             <a:extLst xmlns:a="http://schemas.openxmlformats.org/drawingml/2006/main">
               <a:ext uri="{FF2B5EF4-FFF2-40B4-BE49-F238E27FC236}">
-                <a16:creationId xmlns:a16="http://schemas.microsoft.com/office/drawing/2014/main" id="{F4F24A91-5FB1-4DF8-877C-6DA09F01EC25}"/>
+                <a16:creationId xmlns:a16="http://schemas.microsoft.com/office/drawing/2014/main" id="{A345DECE-6C12-43B8-A1F9-0C71B9328C0C}"/>
               </a:ext>
             </a:extLst>
           </p:cNvPr>
@@ -9325,7 +9325,7 @@
           <p:cNvPr id="2" name="">
             <a:extLst xmlns:a="http://schemas.openxmlformats.org/drawingml/2006/main">
               <a:ext uri="{FF2B5EF4-FFF2-40B4-BE49-F238E27FC236}">
-                <a16:creationId xmlns:a16="http://schemas.microsoft.com/office/drawing/2014/main" id="{D5D0B796-347C-4ACB-B76C-990991BB528C}"/>
+                <a16:creationId xmlns:a16="http://schemas.microsoft.com/office/drawing/2014/main" id="{71D753B9-5261-4A3F-9425-44DD4B04C0E2}"/>
               </a:ext>
             </a:extLst>
           </p:cNvPr>
@@ -9356,7 +9356,7 @@
           <p:cNvPr id="3" name="">
             <a:extLst xmlns:a="http://schemas.openxmlformats.org/drawingml/2006/main">
               <a:ext uri="{FF2B5EF4-FFF2-40B4-BE49-F238E27FC236}">
-                <a16:creationId xmlns:a16="http://schemas.microsoft.com/office/drawing/2014/main" id="{6E983AB0-C59C-4DCF-A911-B53F94A22252}"/>
+                <a16:creationId xmlns:a16="http://schemas.microsoft.com/office/drawing/2014/main" id="{AA19963B-86F5-4C9B-8843-3BD1C0D5BE3C}"/>
               </a:ext>
             </a:extLst>
           </p:cNvPr>
@@ -9513,7 +9513,7 @@
           <p:cNvPr id="4" name="">
             <a:extLst xmlns:a="http://schemas.openxmlformats.org/drawingml/2006/main">
               <a:ext uri="{FF2B5EF4-FFF2-40B4-BE49-F238E27FC236}">
-                <a16:creationId xmlns:a16="http://schemas.microsoft.com/office/drawing/2014/main" id="{AFA66527-EE1A-4EFF-936C-4594DC65DEF2}"/>
+                <a16:creationId xmlns:a16="http://schemas.microsoft.com/office/drawing/2014/main" id="{247A90DE-45E5-44DE-A64D-BB5B52441305}"/>
               </a:ext>
             </a:extLst>
           </p:cNvPr>
@@ -9670,7 +9670,7 @@
           <p:cNvPr id="5" name="">
             <a:extLst xmlns:a="http://schemas.openxmlformats.org/drawingml/2006/main">
               <a:ext uri="{FF2B5EF4-FFF2-40B4-BE49-F238E27FC236}">
-                <a16:creationId xmlns:a16="http://schemas.microsoft.com/office/drawing/2014/main" id="{3FFA15FB-2EBF-40D4-AFE1-6DDC45BF2F65}"/>
+                <a16:creationId xmlns:a16="http://schemas.microsoft.com/office/drawing/2014/main" id="{21535CC9-E783-4264-BE8B-0A113F073F96}"/>
               </a:ext>
             </a:extLst>
           </p:cNvPr>
@@ -9827,7 +9827,7 @@
           <p:cNvPr id="6" name="">
             <a:extLst xmlns:a="http://schemas.openxmlformats.org/drawingml/2006/main">
               <a:ext uri="{FF2B5EF4-FFF2-40B4-BE49-F238E27FC236}">
-                <a16:creationId xmlns:a16="http://schemas.microsoft.com/office/drawing/2014/main" id="{10AC6F23-A046-489C-87BE-3FE3ED59F639}"/>
+                <a16:creationId xmlns:a16="http://schemas.microsoft.com/office/drawing/2014/main" id="{AE59A9EF-7A37-4B3A-8DD4-D8E45AD649F6}"/>
               </a:ext>
             </a:extLst>
           </p:cNvPr>
@@ -10007,7 +10007,7 @@
           <p:cNvPr id="7" name="">
             <a:extLst xmlns:a="http://schemas.openxmlformats.org/drawingml/2006/main">
               <a:ext uri="{FF2B5EF4-FFF2-40B4-BE49-F238E27FC236}">
-                <a16:creationId xmlns:a16="http://schemas.microsoft.com/office/drawing/2014/main" id="{28DFF33F-4EDC-4040-82AF-277156F54807}"/>
+                <a16:creationId xmlns:a16="http://schemas.microsoft.com/office/drawing/2014/main" id="{74A61201-CCFF-48DA-BC00-245EA0829148}"/>
               </a:ext>
             </a:extLst>
           </p:cNvPr>
@@ -10038,7 +10038,7 @@
           <p:cNvPr id="8" name="">
             <a:extLst xmlns:a="http://schemas.openxmlformats.org/drawingml/2006/main">
               <a:ext uri="{FF2B5EF4-FFF2-40B4-BE49-F238E27FC236}">
-                <a16:creationId xmlns:a16="http://schemas.microsoft.com/office/drawing/2014/main" id="{262E1202-3134-4DB9-9310-60B96536539B}"/>
+                <a16:creationId xmlns:a16="http://schemas.microsoft.com/office/drawing/2014/main" id="{BA18973C-A96B-40D5-9618-00EC4D55D9A3}"/>
               </a:ext>
             </a:extLst>
           </p:cNvPr>
@@ -10195,7 +10195,7 @@
           <p:cNvPr id="9" name="">
             <a:extLst xmlns:a="http://schemas.openxmlformats.org/drawingml/2006/main">
               <a:ext uri="{FF2B5EF4-FFF2-40B4-BE49-F238E27FC236}">
-                <a16:creationId xmlns:a16="http://schemas.microsoft.com/office/drawing/2014/main" id="{F08322FF-734F-465A-A5A0-348FFA575A25}"/>
+                <a16:creationId xmlns:a16="http://schemas.microsoft.com/office/drawing/2014/main" id="{A67146B5-D0E0-4A13-86E4-9173B966EF83}"/>
               </a:ext>
             </a:extLst>
           </p:cNvPr>
@@ -10375,7 +10375,7 @@
           <p:cNvPr id="10" name="">
             <a:extLst xmlns:a="http://schemas.openxmlformats.org/drawingml/2006/main">
               <a:ext uri="{FF2B5EF4-FFF2-40B4-BE49-F238E27FC236}">
-                <a16:creationId xmlns:a16="http://schemas.microsoft.com/office/drawing/2014/main" id="{9D446F3B-0CD3-4C88-AB1D-A0D1CB846BFB}"/>
+                <a16:creationId xmlns:a16="http://schemas.microsoft.com/office/drawing/2014/main" id="{8F33D30A-1761-4DCD-9CBB-86D6EC9781B5}"/>
               </a:ext>
             </a:extLst>
           </p:cNvPr>
@@ -10406,7 +10406,7 @@
           <p:cNvPr id="11" name="">
             <a:extLst xmlns:a="http://schemas.openxmlformats.org/drawingml/2006/main">
               <a:ext uri="{FF2B5EF4-FFF2-40B4-BE49-F238E27FC236}">
-                <a16:creationId xmlns:a16="http://schemas.microsoft.com/office/drawing/2014/main" id="{B93D1A74-1582-4AE0-AFA7-27D556DFA806}"/>
+                <a16:creationId xmlns:a16="http://schemas.microsoft.com/office/drawing/2014/main" id="{78A0E4D1-B6EA-412F-A8E1-CA340BC00E9F}"/>
               </a:ext>
             </a:extLst>
           </p:cNvPr>
@@ -10563,7 +10563,7 @@
           <p:cNvPr id="12" name="">
             <a:extLst xmlns:a="http://schemas.openxmlformats.org/drawingml/2006/main">
               <a:ext uri="{FF2B5EF4-FFF2-40B4-BE49-F238E27FC236}">
-                <a16:creationId xmlns:a16="http://schemas.microsoft.com/office/drawing/2014/main" id="{5B746DF8-9276-44D6-A760-6B5166671F6C}"/>
+                <a16:creationId xmlns:a16="http://schemas.microsoft.com/office/drawing/2014/main" id="{41F3D74C-79FD-42F1-B1D1-498519518BC0}"/>
               </a:ext>
             </a:extLst>
           </p:cNvPr>
@@ -10743,7 +10743,7 @@
           <p:cNvPr id="13" name="">
             <a:extLst xmlns:a="http://schemas.openxmlformats.org/drawingml/2006/main">
               <a:ext uri="{FF2B5EF4-FFF2-40B4-BE49-F238E27FC236}">
-                <a16:creationId xmlns:a16="http://schemas.microsoft.com/office/drawing/2014/main" id="{2141236B-E02E-4322-B5B4-D8FF614B8737}"/>
+                <a16:creationId xmlns:a16="http://schemas.microsoft.com/office/drawing/2014/main" id="{E29EEFA1-9624-49D9-8CE5-655BBE36BE41}"/>
               </a:ext>
             </a:extLst>
           </p:cNvPr>
@@ -10774,7 +10774,7 @@
           <p:cNvPr id="14" name="">
             <a:extLst xmlns:a="http://schemas.openxmlformats.org/drawingml/2006/main">
               <a:ext uri="{FF2B5EF4-FFF2-40B4-BE49-F238E27FC236}">
-                <a16:creationId xmlns:a16="http://schemas.microsoft.com/office/drawing/2014/main" id="{7C954AD9-0A45-4793-B03D-87C538C77EB1}"/>
+                <a16:creationId xmlns:a16="http://schemas.microsoft.com/office/drawing/2014/main" id="{51F0B5DD-DC96-4001-9FF8-108F364DE214}"/>
               </a:ext>
             </a:extLst>
           </p:cNvPr>
@@ -10931,7 +10931,7 @@
           <p:cNvPr id="15" name="">
             <a:extLst xmlns:a="http://schemas.openxmlformats.org/drawingml/2006/main">
               <a:ext uri="{FF2B5EF4-FFF2-40B4-BE49-F238E27FC236}">
-                <a16:creationId xmlns:a16="http://schemas.microsoft.com/office/drawing/2014/main" id="{E832EA3E-59D8-4878-AA66-A085039A14CC}"/>
+                <a16:creationId xmlns:a16="http://schemas.microsoft.com/office/drawing/2014/main" id="{4B54DB74-730E-4319-98EE-49ED1D0B7402}"/>
               </a:ext>
             </a:extLst>
           </p:cNvPr>
@@ -11109,7 +11109,7 @@
     </p:spTree>
     <p:extLst>
       <p:ext uri="{BB962C8B-B14F-4D97-AF65-F5344CB8AC3E}">
-        <p14:creationId xmlns:p14="http://schemas.microsoft.com/office/powerpoint/2010/main" val="1527508182"/>
+        <p14:creationId xmlns:p14="http://schemas.microsoft.com/office/powerpoint/2010/main" val="251734852"/>
       </p:ext>
     </p:extLst>
   </p:cSld>
@@ -11140,7 +11140,7 @@
           <p:cNvPr id="14" name="">
             <a:extLst xmlns:a="http://schemas.openxmlformats.org/drawingml/2006/main">
               <a:ext uri="{FF2B5EF4-FFF2-40B4-BE49-F238E27FC236}">
-                <a16:creationId xmlns:a16="http://schemas.microsoft.com/office/drawing/2014/main" id="{D3FF5B02-E445-41BB-B621-1A87A4254647}"/>
+                <a16:creationId xmlns:a16="http://schemas.microsoft.com/office/drawing/2014/main" id="{B6DE9CAD-C311-4FE1-A7CB-BA656F16A66D}"/>
               </a:ext>
             </a:extLst>
           </p:cNvPr>
@@ -11297,7 +11297,7 @@
           <p:cNvPr id="2" name="">
             <a:extLst xmlns:a="http://schemas.openxmlformats.org/drawingml/2006/main">
               <a:ext uri="{FF2B5EF4-FFF2-40B4-BE49-F238E27FC236}">
-                <a16:creationId xmlns:a16="http://schemas.microsoft.com/office/drawing/2014/main" id="{E6724895-F92A-4056-B69A-20DB10E857AA}"/>
+                <a16:creationId xmlns:a16="http://schemas.microsoft.com/office/drawing/2014/main" id="{A66C4B8D-B89A-4D7D-8FDD-4B4D9B882C16}"/>
               </a:ext>
             </a:extLst>
           </p:cNvPr>
@@ -11328,7 +11328,7 @@
           <p:cNvPr id="3" name="">
             <a:extLst xmlns:a="http://schemas.openxmlformats.org/drawingml/2006/main">
               <a:ext uri="{FF2B5EF4-FFF2-40B4-BE49-F238E27FC236}">
-                <a16:creationId xmlns:a16="http://schemas.microsoft.com/office/drawing/2014/main" id="{2E36E042-4FB8-4CC3-A607-341CBE6A63EA}"/>
+                <a16:creationId xmlns:a16="http://schemas.microsoft.com/office/drawing/2014/main" id="{15815D5E-76FA-4F61-96D6-D86E34CD0D30}"/>
               </a:ext>
             </a:extLst>
           </p:cNvPr>
@@ -11485,7 +11485,7 @@
           <p:cNvPr id="4" name="">
             <a:extLst xmlns:a="http://schemas.openxmlformats.org/drawingml/2006/main">
               <a:ext uri="{FF2B5EF4-FFF2-40B4-BE49-F238E27FC236}">
-                <a16:creationId xmlns:a16="http://schemas.microsoft.com/office/drawing/2014/main" id="{F17474E8-BCFD-4BFD-ACF1-49161FAE8025}"/>
+                <a16:creationId xmlns:a16="http://schemas.microsoft.com/office/drawing/2014/main" id="{7817E256-6B27-4824-9233-1B4D80EE1AD4}"/>
               </a:ext>
             </a:extLst>
           </p:cNvPr>
@@ -11642,7 +11642,7 @@
           <p:cNvPr id="5" name="">
             <a:extLst xmlns:a="http://schemas.openxmlformats.org/drawingml/2006/main">
               <a:ext uri="{FF2B5EF4-FFF2-40B4-BE49-F238E27FC236}">
-                <a16:creationId xmlns:a16="http://schemas.microsoft.com/office/drawing/2014/main" id="{5C058655-DC4A-4608-9C1F-CD5302DA8F4C}"/>
+                <a16:creationId xmlns:a16="http://schemas.microsoft.com/office/drawing/2014/main" id="{1C1E0A36-625C-480F-8C1C-1CA8571E2BF0}"/>
               </a:ext>
             </a:extLst>
           </p:cNvPr>
@@ -11799,7 +11799,7 @@
           <p:cNvPr id="6" name="">
             <a:extLst xmlns:a="http://schemas.openxmlformats.org/drawingml/2006/main">
               <a:ext uri="{FF2B5EF4-FFF2-40B4-BE49-F238E27FC236}">
-                <a16:creationId xmlns:a16="http://schemas.microsoft.com/office/drawing/2014/main" id="{B927502E-D907-453F-B158-4A3EB7A3A598}"/>
+                <a16:creationId xmlns:a16="http://schemas.microsoft.com/office/drawing/2014/main" id="{9796042C-58DE-4B42-A9EB-39B7530AB96E}"/>
               </a:ext>
             </a:extLst>
           </p:cNvPr>
@@ -11956,7 +11956,7 @@
           <p:cNvPr id="7" name="">
             <a:extLst xmlns:a="http://schemas.openxmlformats.org/drawingml/2006/main">
               <a:ext uri="{FF2B5EF4-FFF2-40B4-BE49-F238E27FC236}">
-                <a16:creationId xmlns:a16="http://schemas.microsoft.com/office/drawing/2014/main" id="{DF04F782-282D-4AB2-B04C-8F7817F04117}"/>
+                <a16:creationId xmlns:a16="http://schemas.microsoft.com/office/drawing/2014/main" id="{402FFB5C-36C1-4891-B6DC-E8D791FEDB34}"/>
               </a:ext>
             </a:extLst>
           </p:cNvPr>
@@ -12113,7 +12113,7 @@
           <p:cNvPr id="8" name="">
             <a:extLst xmlns:a="http://schemas.openxmlformats.org/drawingml/2006/main">
               <a:ext uri="{FF2B5EF4-FFF2-40B4-BE49-F238E27FC236}">
-                <a16:creationId xmlns:a16="http://schemas.microsoft.com/office/drawing/2014/main" id="{6DFCCE6A-CB0E-49C2-B8AB-86233165AAFB}"/>
+                <a16:creationId xmlns:a16="http://schemas.microsoft.com/office/drawing/2014/main" id="{D2F1126B-FF04-4616-951F-4219486F9AEF}"/>
               </a:ext>
             </a:extLst>
           </p:cNvPr>
@@ -12270,7 +12270,7 @@
           <p:cNvPr id="9" name="">
             <a:extLst xmlns:a="http://schemas.openxmlformats.org/drawingml/2006/main">
               <a:ext uri="{FF2B5EF4-FFF2-40B4-BE49-F238E27FC236}">
-                <a16:creationId xmlns:a16="http://schemas.microsoft.com/office/drawing/2014/main" id="{F32BD42F-5529-412C-956C-D870E51175B5}"/>
+                <a16:creationId xmlns:a16="http://schemas.microsoft.com/office/drawing/2014/main" id="{688CE444-CA16-4AFA-A1F1-37917B975B5C}"/>
               </a:ext>
             </a:extLst>
           </p:cNvPr>
@@ -12427,7 +12427,7 @@
           <p:cNvPr id="10" name="">
             <a:extLst xmlns:a="http://schemas.openxmlformats.org/drawingml/2006/main">
               <a:ext uri="{FF2B5EF4-FFF2-40B4-BE49-F238E27FC236}">
-                <a16:creationId xmlns:a16="http://schemas.microsoft.com/office/drawing/2014/main" id="{B3E41286-AD43-4148-B96D-29A27F4C8813}"/>
+                <a16:creationId xmlns:a16="http://schemas.microsoft.com/office/drawing/2014/main" id="{71B4D528-2C9F-4B9A-8230-66FC5AD0F29C}"/>
               </a:ext>
             </a:extLst>
           </p:cNvPr>
@@ -12584,7 +12584,7 @@
           <p:cNvPr id="11" name="">
             <a:extLst xmlns:a="http://schemas.openxmlformats.org/drawingml/2006/main">
               <a:ext uri="{FF2B5EF4-FFF2-40B4-BE49-F238E27FC236}">
-                <a16:creationId xmlns:a16="http://schemas.microsoft.com/office/drawing/2014/main" id="{9A129010-C4A5-4046-AD0B-9C0B512263A2}"/>
+                <a16:creationId xmlns:a16="http://schemas.microsoft.com/office/drawing/2014/main" id="{AFDF63A7-0F47-47A2-8A6B-B10DC0B22661}"/>
               </a:ext>
             </a:extLst>
           </p:cNvPr>
@@ -12741,7 +12741,7 @@
           <p:cNvPr id="12" name="">
             <a:extLst xmlns:a="http://schemas.openxmlformats.org/drawingml/2006/main">
               <a:ext uri="{FF2B5EF4-FFF2-40B4-BE49-F238E27FC236}">
-                <a16:creationId xmlns:a16="http://schemas.microsoft.com/office/drawing/2014/main" id="{38095640-D8E3-4FCD-A979-48773F826155}"/>
+                <a16:creationId xmlns:a16="http://schemas.microsoft.com/office/drawing/2014/main" id="{59EEA3CA-4905-46F6-8977-1E1804A96993}"/>
               </a:ext>
             </a:extLst>
           </p:cNvPr>
@@ -12898,7 +12898,7 @@
           <p:cNvPr id="13" name="">
             <a:extLst xmlns:a="http://schemas.openxmlformats.org/drawingml/2006/main">
               <a:ext uri="{FF2B5EF4-FFF2-40B4-BE49-F238E27FC236}">
-                <a16:creationId xmlns:a16="http://schemas.microsoft.com/office/drawing/2014/main" id="{69068A6C-300E-4E9E-9BBE-68ADA4D1AEF7}"/>
+                <a16:creationId xmlns:a16="http://schemas.microsoft.com/office/drawing/2014/main" id="{4AB60343-B310-45AD-B1E6-8146B925365E}"/>
               </a:ext>
             </a:extLst>
           </p:cNvPr>
@@ -13053,7 +13053,7 @@
     </p:spTree>
     <p:extLst>
       <p:ext uri="{BB962C8B-B14F-4D97-AF65-F5344CB8AC3E}">
-        <p14:creationId xmlns:p14="http://schemas.microsoft.com/office/powerpoint/2010/main" val="1537232680"/>
+        <p14:creationId xmlns:p14="http://schemas.microsoft.com/office/powerpoint/2010/main" val="1958835815"/>
       </p:ext>
     </p:extLst>
   </p:cSld>
@@ -13084,7 +13084,7 @@
           <p:cNvPr id="11" name="">
             <a:extLst xmlns:a="http://schemas.openxmlformats.org/drawingml/2006/main">
               <a:ext uri="{FF2B5EF4-FFF2-40B4-BE49-F238E27FC236}">
-                <a16:creationId xmlns:a16="http://schemas.microsoft.com/office/drawing/2014/main" id="{179C04EB-68FA-4BA1-9F47-502BAB2BE54E}"/>
+                <a16:creationId xmlns:a16="http://schemas.microsoft.com/office/drawing/2014/main" id="{02EE62D6-F2DA-46D4-BC55-451D44A83836}"/>
               </a:ext>
             </a:extLst>
           </p:cNvPr>
@@ -13241,7 +13241,7 @@
           <p:cNvPr id="2" name="">
             <a:extLst xmlns:a="http://schemas.openxmlformats.org/drawingml/2006/main">
               <a:ext uri="{FF2B5EF4-FFF2-40B4-BE49-F238E27FC236}">
-                <a16:creationId xmlns:a16="http://schemas.microsoft.com/office/drawing/2014/main" id="{270A9901-F23D-4F97-949F-68945C91B76F}"/>
+                <a16:creationId xmlns:a16="http://schemas.microsoft.com/office/drawing/2014/main" id="{6498013B-0049-494D-AB7C-D1287B332904}"/>
               </a:ext>
             </a:extLst>
           </p:cNvPr>
@@ -13272,7 +13272,7 @@
           <p:cNvPr id="3" name="">
             <a:extLst xmlns:a="http://schemas.openxmlformats.org/drawingml/2006/main">
               <a:ext uri="{FF2B5EF4-FFF2-40B4-BE49-F238E27FC236}">
-                <a16:creationId xmlns:a16="http://schemas.microsoft.com/office/drawing/2014/main" id="{352CB446-A927-4C8E-94BF-BFB0F0CAA08C}"/>
+                <a16:creationId xmlns:a16="http://schemas.microsoft.com/office/drawing/2014/main" id="{67E66CD8-13DB-478C-A6C1-4459743B5632}"/>
               </a:ext>
             </a:extLst>
           </p:cNvPr>
@@ -13429,7 +13429,7 @@
           <p:cNvPr id="4" name="">
             <a:extLst xmlns:a="http://schemas.openxmlformats.org/drawingml/2006/main">
               <a:ext uri="{FF2B5EF4-FFF2-40B4-BE49-F238E27FC236}">
-                <a16:creationId xmlns:a16="http://schemas.microsoft.com/office/drawing/2014/main" id="{D39139B8-8C35-4A02-901F-1D31AFE798E8}"/>
+                <a16:creationId xmlns:a16="http://schemas.microsoft.com/office/drawing/2014/main" id="{4783FC6D-EF4C-45E4-BDA1-7C6F057D3552}"/>
               </a:ext>
             </a:extLst>
           </p:cNvPr>
@@ -13586,7 +13586,7 @@
           <p:cNvPr id="5" name="">
             <a:extLst xmlns:a="http://schemas.openxmlformats.org/drawingml/2006/main">
               <a:ext uri="{FF2B5EF4-FFF2-40B4-BE49-F238E27FC236}">
-                <a16:creationId xmlns:a16="http://schemas.microsoft.com/office/drawing/2014/main" id="{C4E2DEFC-0015-4E7E-98BA-8570337C3956}"/>
+                <a16:creationId xmlns:a16="http://schemas.microsoft.com/office/drawing/2014/main" id="{80D26B16-BCBB-414F-8CB6-E2D42A58456F}"/>
               </a:ext>
             </a:extLst>
           </p:cNvPr>
@@ -13743,7 +13743,7 @@
           <p:cNvPr id="6" name="">
             <a:extLst xmlns:a="http://schemas.openxmlformats.org/drawingml/2006/main">
               <a:ext uri="{FF2B5EF4-FFF2-40B4-BE49-F238E27FC236}">
-                <a16:creationId xmlns:a16="http://schemas.microsoft.com/office/drawing/2014/main" id="{6931400E-B7B2-4FF5-8C03-CCFC23339737}"/>
+                <a16:creationId xmlns:a16="http://schemas.microsoft.com/office/drawing/2014/main" id="{62188DA9-879A-4C84-ACBB-D3F90B2309DD}"/>
               </a:ext>
             </a:extLst>
           </p:cNvPr>
@@ -13969,7 +13969,7 @@
           <p:cNvPr id="7" name="">
             <a:extLst xmlns:a="http://schemas.openxmlformats.org/drawingml/2006/main">
               <a:ext uri="{FF2B5EF4-FFF2-40B4-BE49-F238E27FC236}">
-                <a16:creationId xmlns:a16="http://schemas.microsoft.com/office/drawing/2014/main" id="{7223220D-F1BD-48CB-BE38-022409A3AC16}"/>
+                <a16:creationId xmlns:a16="http://schemas.microsoft.com/office/drawing/2014/main" id="{135ED1A2-6D1E-4866-89AC-E8E0A903801F}"/>
               </a:ext>
             </a:extLst>
           </p:cNvPr>
@@ -14126,7 +14126,7 @@
           <p:cNvPr id="8" name="">
             <a:extLst xmlns:a="http://schemas.openxmlformats.org/drawingml/2006/main">
               <a:ext uri="{FF2B5EF4-FFF2-40B4-BE49-F238E27FC236}">
-                <a16:creationId xmlns:a16="http://schemas.microsoft.com/office/drawing/2014/main" id="{D76185F7-E785-4646-A363-7877DFE41B75}"/>
+                <a16:creationId xmlns:a16="http://schemas.microsoft.com/office/drawing/2014/main" id="{B27E60A1-D5E0-44BF-AD9F-587D14BDA836}"/>
               </a:ext>
             </a:extLst>
           </p:cNvPr>
@@ -14352,7 +14352,7 @@
           <p:cNvPr id="9" name="">
             <a:extLst xmlns:a="http://schemas.openxmlformats.org/drawingml/2006/main">
               <a:ext uri="{FF2B5EF4-FFF2-40B4-BE49-F238E27FC236}">
-                <a16:creationId xmlns:a16="http://schemas.microsoft.com/office/drawing/2014/main" id="{93581CEF-2650-4908-BEB1-DF019C467F86}"/>
+                <a16:creationId xmlns:a16="http://schemas.microsoft.com/office/drawing/2014/main" id="{1E87024E-7621-45F8-8292-27DE33A27254}"/>
               </a:ext>
             </a:extLst>
           </p:cNvPr>
@@ -14509,7 +14509,7 @@
           <p:cNvPr id="10" name="">
             <a:extLst xmlns:a="http://schemas.openxmlformats.org/drawingml/2006/main">
               <a:ext uri="{FF2B5EF4-FFF2-40B4-BE49-F238E27FC236}">
-                <a16:creationId xmlns:a16="http://schemas.microsoft.com/office/drawing/2014/main" id="{4D69067C-DA8B-4274-A351-970CD5DB142F}"/>
+                <a16:creationId xmlns:a16="http://schemas.microsoft.com/office/drawing/2014/main" id="{CE5D9AE2-300E-4DF9-8927-1DFD5E43CD3D}"/>
               </a:ext>
             </a:extLst>
           </p:cNvPr>
@@ -14664,7 +14664,7 @@
     </p:spTree>
     <p:extLst>
       <p:ext uri="{BB962C8B-B14F-4D97-AF65-F5344CB8AC3E}">
-        <p14:creationId xmlns:p14="http://schemas.microsoft.com/office/powerpoint/2010/main" val="562588738"/>
+        <p14:creationId xmlns:p14="http://schemas.microsoft.com/office/powerpoint/2010/main" val="398584023"/>
       </p:ext>
     </p:extLst>
   </p:cSld>
@@ -14695,7 +14695,7 @@
           <p:cNvPr id="12" name="">
             <a:extLst xmlns:a="http://schemas.openxmlformats.org/drawingml/2006/main">
               <a:ext uri="{FF2B5EF4-FFF2-40B4-BE49-F238E27FC236}">
-                <a16:creationId xmlns:a16="http://schemas.microsoft.com/office/drawing/2014/main" id="{B79363D2-148F-4248-BBAB-53B0303064D7}"/>
+                <a16:creationId xmlns:a16="http://schemas.microsoft.com/office/drawing/2014/main" id="{D3973CEB-3D97-4768-A978-3029E0890F9F}"/>
               </a:ext>
             </a:extLst>
           </p:cNvPr>
@@ -14852,7 +14852,7 @@
           <p:cNvPr id="2" name="">
             <a:extLst xmlns:a="http://schemas.openxmlformats.org/drawingml/2006/main">
               <a:ext uri="{FF2B5EF4-FFF2-40B4-BE49-F238E27FC236}">
-                <a16:creationId xmlns:a16="http://schemas.microsoft.com/office/drawing/2014/main" id="{11BABDDB-BDB0-4139-B3AC-1648446D5E77}"/>
+                <a16:creationId xmlns:a16="http://schemas.microsoft.com/office/drawing/2014/main" id="{072EE115-CA3E-479C-A538-6B2F924AAA81}"/>
               </a:ext>
             </a:extLst>
           </p:cNvPr>
@@ -14883,7 +14883,7 @@
           <p:cNvPr id="3" name="">
             <a:extLst xmlns:a="http://schemas.openxmlformats.org/drawingml/2006/main">
               <a:ext uri="{FF2B5EF4-FFF2-40B4-BE49-F238E27FC236}">
-                <a16:creationId xmlns:a16="http://schemas.microsoft.com/office/drawing/2014/main" id="{A8BFC8FC-CA97-4D9A-85CA-D7E11BE618A0}"/>
+                <a16:creationId xmlns:a16="http://schemas.microsoft.com/office/drawing/2014/main" id="{9BDC0BBA-6D03-4BD6-94B4-DDCEE6C9AEC0}"/>
               </a:ext>
             </a:extLst>
           </p:cNvPr>
@@ -15040,7 +15040,7 @@
           <p:cNvPr id="4" name="">
             <a:extLst xmlns:a="http://schemas.openxmlformats.org/drawingml/2006/main">
               <a:ext uri="{FF2B5EF4-FFF2-40B4-BE49-F238E27FC236}">
-                <a16:creationId xmlns:a16="http://schemas.microsoft.com/office/drawing/2014/main" id="{263C033C-6CB5-4CDB-A430-430DD8333444}"/>
+                <a16:creationId xmlns:a16="http://schemas.microsoft.com/office/drawing/2014/main" id="{5B1B62CD-E3B6-44C4-A64C-7912930D4EF7}"/>
               </a:ext>
             </a:extLst>
           </p:cNvPr>
@@ -15197,7 +15197,7 @@
           <p:cNvPr id="5" name="">
             <a:extLst xmlns:a="http://schemas.openxmlformats.org/drawingml/2006/main">
               <a:ext uri="{FF2B5EF4-FFF2-40B4-BE49-F238E27FC236}">
-                <a16:creationId xmlns:a16="http://schemas.microsoft.com/office/drawing/2014/main" id="{BD4BBAA5-427D-4077-8665-188D542DB08E}"/>
+                <a16:creationId xmlns:a16="http://schemas.microsoft.com/office/drawing/2014/main" id="{5ACE8570-F74D-4D57-9F0F-894AB9527821}"/>
               </a:ext>
             </a:extLst>
           </p:cNvPr>
@@ -15354,7 +15354,7 @@
           <p:cNvPr id="6" name="">
             <a:extLst xmlns:a="http://schemas.openxmlformats.org/drawingml/2006/main">
               <a:ext uri="{FF2B5EF4-FFF2-40B4-BE49-F238E27FC236}">
-                <a16:creationId xmlns:a16="http://schemas.microsoft.com/office/drawing/2014/main" id="{DC3FCB05-BECA-4982-8ACC-612C406F3260}"/>
+                <a16:creationId xmlns:a16="http://schemas.microsoft.com/office/drawing/2014/main" id="{3C3B1489-B337-41AB-BC50-39D1D387AC4B}"/>
               </a:ext>
             </a:extLst>
           </p:cNvPr>
@@ -15511,7 +15511,7 @@
           <p:cNvPr id="7" name="">
             <a:extLst xmlns:a="http://schemas.openxmlformats.org/drawingml/2006/main">
               <a:ext uri="{FF2B5EF4-FFF2-40B4-BE49-F238E27FC236}">
-                <a16:creationId xmlns:a16="http://schemas.microsoft.com/office/drawing/2014/main" id="{72999223-29F9-4301-8A00-D8FC908DBF91}"/>
+                <a16:creationId xmlns:a16="http://schemas.microsoft.com/office/drawing/2014/main" id="{2FD31CC8-89F8-443B-86D0-F62F0DD0132B}"/>
               </a:ext>
             </a:extLst>
           </p:cNvPr>
@@ -15668,7 +15668,7 @@
           <p:cNvPr id="8" name="">
             <a:extLst xmlns:a="http://schemas.openxmlformats.org/drawingml/2006/main">
               <a:ext uri="{FF2B5EF4-FFF2-40B4-BE49-F238E27FC236}">
-                <a16:creationId xmlns:a16="http://schemas.microsoft.com/office/drawing/2014/main" id="{BAA61104-5A8B-4CC3-9ADB-487DEE815228}"/>
+                <a16:creationId xmlns:a16="http://schemas.microsoft.com/office/drawing/2014/main" id="{A91E2863-D6F5-487C-AEF5-D66AC3D7B1B9}"/>
               </a:ext>
             </a:extLst>
           </p:cNvPr>
@@ -15825,7 +15825,7 @@
           <p:cNvPr id="9" name="">
             <a:extLst xmlns:a="http://schemas.openxmlformats.org/drawingml/2006/main">
               <a:ext uri="{FF2B5EF4-FFF2-40B4-BE49-F238E27FC236}">
-                <a16:creationId xmlns:a16="http://schemas.microsoft.com/office/drawing/2014/main" id="{06664181-E44E-4A77-92C9-250E6E472AF8}"/>
+                <a16:creationId xmlns:a16="http://schemas.microsoft.com/office/drawing/2014/main" id="{5A018F94-CF37-4077-BED2-05699C307891}"/>
               </a:ext>
             </a:extLst>
           </p:cNvPr>
@@ -15982,7 +15982,7 @@
           <p:cNvPr id="10" name="">
             <a:extLst xmlns:a="http://schemas.openxmlformats.org/drawingml/2006/main">
               <a:ext uri="{FF2B5EF4-FFF2-40B4-BE49-F238E27FC236}">
-                <a16:creationId xmlns:a16="http://schemas.microsoft.com/office/drawing/2014/main" id="{540E32DB-B6D2-46B9-AB21-94C229840607}"/>
+                <a16:creationId xmlns:a16="http://schemas.microsoft.com/office/drawing/2014/main" id="{B6C994D3-F18E-4570-AF0D-4472FEA4DB06}"/>
               </a:ext>
             </a:extLst>
           </p:cNvPr>
@@ -16139,7 +16139,7 @@
           <p:cNvPr id="11" name="">
             <a:extLst xmlns:a="http://schemas.openxmlformats.org/drawingml/2006/main">
               <a:ext uri="{FF2B5EF4-FFF2-40B4-BE49-F238E27FC236}">
-                <a16:creationId xmlns:a16="http://schemas.microsoft.com/office/drawing/2014/main" id="{6883811F-3952-4D2E-BDCA-FDD6B0257A63}"/>
+                <a16:creationId xmlns:a16="http://schemas.microsoft.com/office/drawing/2014/main" id="{28C0C077-46D2-460D-8EE2-3C6BC93F22F5}"/>
               </a:ext>
             </a:extLst>
           </p:cNvPr>
@@ -16294,7 +16294,7 @@
     </p:spTree>
     <p:extLst>
       <p:ext uri="{BB962C8B-B14F-4D97-AF65-F5344CB8AC3E}">
-        <p14:creationId xmlns:p14="http://schemas.microsoft.com/office/powerpoint/2010/main" val="359353036"/>
+        <p14:creationId xmlns:p14="http://schemas.microsoft.com/office/powerpoint/2010/main" val="873476579"/>
       </p:ext>
     </p:extLst>
   </p:cSld>
@@ -16325,7 +16325,7 @@
           <p:cNvPr id="18" name="">
             <a:extLst xmlns:a="http://schemas.openxmlformats.org/drawingml/2006/main">
               <a:ext uri="{FF2B5EF4-FFF2-40B4-BE49-F238E27FC236}">
-                <a16:creationId xmlns:a16="http://schemas.microsoft.com/office/drawing/2014/main" id="{F8CBEF6C-2253-4C3B-B36A-FAE2D299331D}"/>
+                <a16:creationId xmlns:a16="http://schemas.microsoft.com/office/drawing/2014/main" id="{D1308E5E-8C02-4EC0-A529-AA874E0534F0}"/>
               </a:ext>
             </a:extLst>
           </p:cNvPr>
@@ -16482,7 +16482,7 @@
           <p:cNvPr id="2" name="">
             <a:extLst xmlns:a="http://schemas.openxmlformats.org/drawingml/2006/main">
               <a:ext uri="{FF2B5EF4-FFF2-40B4-BE49-F238E27FC236}">
-                <a16:creationId xmlns:a16="http://schemas.microsoft.com/office/drawing/2014/main" id="{63A9D623-E0A8-4F9D-B3D1-4FD8B7600883}"/>
+                <a16:creationId xmlns:a16="http://schemas.microsoft.com/office/drawing/2014/main" id="{3441B1C6-41BB-4768-B63F-E219634A036A}"/>
               </a:ext>
             </a:extLst>
           </p:cNvPr>
@@ -16513,7 +16513,7 @@
           <p:cNvPr id="3" name="">
             <a:extLst xmlns:a="http://schemas.openxmlformats.org/drawingml/2006/main">
               <a:ext uri="{FF2B5EF4-FFF2-40B4-BE49-F238E27FC236}">
-                <a16:creationId xmlns:a16="http://schemas.microsoft.com/office/drawing/2014/main" id="{B6532777-96A4-4751-944C-2C446072FE76}"/>
+                <a16:creationId xmlns:a16="http://schemas.microsoft.com/office/drawing/2014/main" id="{48292FF1-4355-4035-BF25-BA23FFA3E95C}"/>
               </a:ext>
             </a:extLst>
           </p:cNvPr>
@@ -16670,7 +16670,7 @@
           <p:cNvPr id="4" name="">
             <a:extLst xmlns:a="http://schemas.openxmlformats.org/drawingml/2006/main">
               <a:ext uri="{FF2B5EF4-FFF2-40B4-BE49-F238E27FC236}">
-                <a16:creationId xmlns:a16="http://schemas.microsoft.com/office/drawing/2014/main" id="{24BD9332-1A27-40EF-A0F9-7FB4A24675AA}"/>
+                <a16:creationId xmlns:a16="http://schemas.microsoft.com/office/drawing/2014/main" id="{514934C9-979E-49F5-A587-F602E1009C23}"/>
               </a:ext>
             </a:extLst>
           </p:cNvPr>
@@ -16827,7 +16827,7 @@
           <p:cNvPr id="5" name="">
             <a:extLst xmlns:a="http://schemas.openxmlformats.org/drawingml/2006/main">
               <a:ext uri="{FF2B5EF4-FFF2-40B4-BE49-F238E27FC236}">
-                <a16:creationId xmlns:a16="http://schemas.microsoft.com/office/drawing/2014/main" id="{FDD96E3A-50A0-4B3A-89C1-AD2AFDAAF336}"/>
+                <a16:creationId xmlns:a16="http://schemas.microsoft.com/office/drawing/2014/main" id="{51841333-1786-42CC-803C-EBB876A4C7BD}"/>
               </a:ext>
             </a:extLst>
           </p:cNvPr>
@@ -16984,7 +16984,7 @@
           <p:cNvPr id="6" name="">
             <a:extLst xmlns:a="http://schemas.openxmlformats.org/drawingml/2006/main">
               <a:ext uri="{FF2B5EF4-FFF2-40B4-BE49-F238E27FC236}">
-                <a16:creationId xmlns:a16="http://schemas.microsoft.com/office/drawing/2014/main" id="{A17CD04C-B37B-42CA-9192-2202DF46B453}"/>
+                <a16:creationId xmlns:a16="http://schemas.microsoft.com/office/drawing/2014/main" id="{21F3426A-D1D8-4809-9959-C7808B136441}"/>
               </a:ext>
             </a:extLst>
           </p:cNvPr>
@@ -17141,7 +17141,7 @@
           <p:cNvPr id="7" name="">
             <a:extLst xmlns:a="http://schemas.openxmlformats.org/drawingml/2006/main">
               <a:ext uri="{FF2B5EF4-FFF2-40B4-BE49-F238E27FC236}">
-                <a16:creationId xmlns:a16="http://schemas.microsoft.com/office/drawing/2014/main" id="{B9A4C3AF-7E14-4D61-B2C2-EAFFB2FC6891}"/>
+                <a16:creationId xmlns:a16="http://schemas.microsoft.com/office/drawing/2014/main" id="{106803F8-B405-4C1D-98F4-487243F67F61}"/>
               </a:ext>
             </a:extLst>
           </p:cNvPr>
@@ -17172,7 +17172,7 @@
           <p:cNvPr id="8" name="">
             <a:extLst xmlns:a="http://schemas.openxmlformats.org/drawingml/2006/main">
               <a:ext uri="{FF2B5EF4-FFF2-40B4-BE49-F238E27FC236}">
-                <a16:creationId xmlns:a16="http://schemas.microsoft.com/office/drawing/2014/main" id="{295F6D0A-5ABA-407E-B751-813C075A38C5}"/>
+                <a16:creationId xmlns:a16="http://schemas.microsoft.com/office/drawing/2014/main" id="{743F3C56-0549-4E25-92BE-614C0258032A}"/>
               </a:ext>
             </a:extLst>
           </p:cNvPr>
@@ -17329,7 +17329,7 @@
           <p:cNvPr id="9" name="">
             <a:extLst xmlns:a="http://schemas.openxmlformats.org/drawingml/2006/main">
               <a:ext uri="{FF2B5EF4-FFF2-40B4-BE49-F238E27FC236}">
-                <a16:creationId xmlns:a16="http://schemas.microsoft.com/office/drawing/2014/main" id="{BE1DCFCD-D952-466C-9EE4-96D45E05A237}"/>
+                <a16:creationId xmlns:a16="http://schemas.microsoft.com/office/drawing/2014/main" id="{B83CA020-A3FA-4D1F-8218-B3495BC55A71}"/>
               </a:ext>
             </a:extLst>
           </p:cNvPr>
@@ -17486,7 +17486,7 @@
           <p:cNvPr id="10" name="">
             <a:extLst xmlns:a="http://schemas.openxmlformats.org/drawingml/2006/main">
               <a:ext uri="{FF2B5EF4-FFF2-40B4-BE49-F238E27FC236}">
-                <a16:creationId xmlns:a16="http://schemas.microsoft.com/office/drawing/2014/main" id="{8227DF89-1473-42C0-A835-A158ABCACDAB}"/>
+                <a16:creationId xmlns:a16="http://schemas.microsoft.com/office/drawing/2014/main" id="{C03E386B-59D3-4B65-BD60-42CE5D901390}"/>
               </a:ext>
             </a:extLst>
           </p:cNvPr>
@@ -17517,7 +17517,7 @@
           <p:cNvPr id="11" name="">
             <a:extLst xmlns:a="http://schemas.openxmlformats.org/drawingml/2006/main">
               <a:ext uri="{FF2B5EF4-FFF2-40B4-BE49-F238E27FC236}">
-                <a16:creationId xmlns:a16="http://schemas.microsoft.com/office/drawing/2014/main" id="{B2AF40E6-43CF-4AE8-89F7-B40ACF0B9502}"/>
+                <a16:creationId xmlns:a16="http://schemas.microsoft.com/office/drawing/2014/main" id="{1A8080DF-2405-44D4-B8D2-6689FF332921}"/>
               </a:ext>
             </a:extLst>
           </p:cNvPr>
@@ -17674,7 +17674,7 @@
           <p:cNvPr id="12" name="">
             <a:extLst xmlns:a="http://schemas.openxmlformats.org/drawingml/2006/main">
               <a:ext uri="{FF2B5EF4-FFF2-40B4-BE49-F238E27FC236}">
-                <a16:creationId xmlns:a16="http://schemas.microsoft.com/office/drawing/2014/main" id="{2FB53274-B6A5-4653-8E98-5A557E8E8B23}"/>
+                <a16:creationId xmlns:a16="http://schemas.microsoft.com/office/drawing/2014/main" id="{93D53DE3-1FBA-4635-97C5-BFBA70840F4C}"/>
               </a:ext>
             </a:extLst>
           </p:cNvPr>
@@ -17831,7 +17831,7 @@
           <p:cNvPr id="13" name="">
             <a:extLst xmlns:a="http://schemas.openxmlformats.org/drawingml/2006/main">
               <a:ext uri="{FF2B5EF4-FFF2-40B4-BE49-F238E27FC236}">
-                <a16:creationId xmlns:a16="http://schemas.microsoft.com/office/drawing/2014/main" id="{D9EBA915-CB31-43E8-BA68-D891AA9B715B}"/>
+                <a16:creationId xmlns:a16="http://schemas.microsoft.com/office/drawing/2014/main" id="{35A0BBEB-D7D2-4338-96EB-D85F5AD6E781}"/>
               </a:ext>
             </a:extLst>
           </p:cNvPr>
@@ -17862,7 +17862,7 @@
           <p:cNvPr id="14" name="">
             <a:extLst xmlns:a="http://schemas.openxmlformats.org/drawingml/2006/main">
               <a:ext uri="{FF2B5EF4-FFF2-40B4-BE49-F238E27FC236}">
-                <a16:creationId xmlns:a16="http://schemas.microsoft.com/office/drawing/2014/main" id="{B7348E24-1F10-4416-A3F4-5B00B7FEC3F8}"/>
+                <a16:creationId xmlns:a16="http://schemas.microsoft.com/office/drawing/2014/main" id="{2E223BCB-29E5-4952-A8CF-661B79732F27}"/>
               </a:ext>
             </a:extLst>
           </p:cNvPr>
@@ -18019,7 +18019,7 @@
           <p:cNvPr id="15" name="">
             <a:extLst xmlns:a="http://schemas.openxmlformats.org/drawingml/2006/main">
               <a:ext uri="{FF2B5EF4-FFF2-40B4-BE49-F238E27FC236}">
-                <a16:creationId xmlns:a16="http://schemas.microsoft.com/office/drawing/2014/main" id="{D3A10F6C-3454-479C-8B61-ECB30C2D6781}"/>
+                <a16:creationId xmlns:a16="http://schemas.microsoft.com/office/drawing/2014/main" id="{5C4188C8-2A30-43CF-8A03-7E7BFDAFB2A2}"/>
               </a:ext>
             </a:extLst>
           </p:cNvPr>
@@ -18176,7 +18176,7 @@
           <p:cNvPr id="16" name="">
             <a:extLst xmlns:a="http://schemas.openxmlformats.org/drawingml/2006/main">
               <a:ext uri="{FF2B5EF4-FFF2-40B4-BE49-F238E27FC236}">
-                <a16:creationId xmlns:a16="http://schemas.microsoft.com/office/drawing/2014/main" id="{0969C838-7630-4970-A943-476C1C2E774D}"/>
+                <a16:creationId xmlns:a16="http://schemas.microsoft.com/office/drawing/2014/main" id="{30DD48B9-252E-4CFC-A5F8-D92DDBD124D2}"/>
               </a:ext>
             </a:extLst>
           </p:cNvPr>
@@ -18333,7 +18333,7 @@
           <p:cNvPr id="17" name="">
             <a:extLst xmlns:a="http://schemas.openxmlformats.org/drawingml/2006/main">
               <a:ext uri="{FF2B5EF4-FFF2-40B4-BE49-F238E27FC236}">
-                <a16:creationId xmlns:a16="http://schemas.microsoft.com/office/drawing/2014/main" id="{032AA2A8-6E66-4F45-8AE3-7620DD066EFD}"/>
+                <a16:creationId xmlns:a16="http://schemas.microsoft.com/office/drawing/2014/main" id="{02E2BE86-7BAC-4168-8965-0A132CBB8686}"/>
               </a:ext>
             </a:extLst>
           </p:cNvPr>
@@ -18488,7 +18488,7 @@
     </p:spTree>
     <p:extLst>
       <p:ext uri="{BB962C8B-B14F-4D97-AF65-F5344CB8AC3E}">
-        <p14:creationId xmlns:p14="http://schemas.microsoft.com/office/powerpoint/2010/main" val="1006270552"/>
+        <p14:creationId xmlns:p14="http://schemas.microsoft.com/office/powerpoint/2010/main" val="1647717130"/>
       </p:ext>
     </p:extLst>
   </p:cSld>
@@ -18519,7 +18519,7 @@
           <p:cNvPr id="14" name="">
             <a:extLst xmlns:a="http://schemas.openxmlformats.org/drawingml/2006/main">
               <a:ext uri="{FF2B5EF4-FFF2-40B4-BE49-F238E27FC236}">
-                <a16:creationId xmlns:a16="http://schemas.microsoft.com/office/drawing/2014/main" id="{C7C474C5-CF2D-4F1D-876E-85FC51C9BD76}"/>
+                <a16:creationId xmlns:a16="http://schemas.microsoft.com/office/drawing/2014/main" id="{8FFC2DBC-BF33-4BDE-BF84-E83A72C06DD0}"/>
               </a:ext>
             </a:extLst>
           </p:cNvPr>
@@ -18676,7 +18676,7 @@
           <p:cNvPr id="2" name="">
             <a:extLst xmlns:a="http://schemas.openxmlformats.org/drawingml/2006/main">
               <a:ext uri="{FF2B5EF4-FFF2-40B4-BE49-F238E27FC236}">
-                <a16:creationId xmlns:a16="http://schemas.microsoft.com/office/drawing/2014/main" id="{4993B08F-5625-4733-A48B-C8D50D7B52F4}"/>
+                <a16:creationId xmlns:a16="http://schemas.microsoft.com/office/drawing/2014/main" id="{15F64DC2-34B3-4861-A1C2-117E22926A2E}"/>
               </a:ext>
             </a:extLst>
           </p:cNvPr>
@@ -18707,7 +18707,7 @@
           <p:cNvPr id="3" name="">
             <a:extLst xmlns:a="http://schemas.openxmlformats.org/drawingml/2006/main">
               <a:ext uri="{FF2B5EF4-FFF2-40B4-BE49-F238E27FC236}">
-                <a16:creationId xmlns:a16="http://schemas.microsoft.com/office/drawing/2014/main" id="{4B1E6383-27C0-449B-BE99-4299383BCED2}"/>
+                <a16:creationId xmlns:a16="http://schemas.microsoft.com/office/drawing/2014/main" id="{5A51FEB3-1BCE-4FDB-B4F5-9E21E8F596D3}"/>
               </a:ext>
             </a:extLst>
           </p:cNvPr>
@@ -18864,7 +18864,7 @@
           <p:cNvPr id="4" name="">
             <a:extLst xmlns:a="http://schemas.openxmlformats.org/drawingml/2006/main">
               <a:ext uri="{FF2B5EF4-FFF2-40B4-BE49-F238E27FC236}">
-                <a16:creationId xmlns:a16="http://schemas.microsoft.com/office/drawing/2014/main" id="{0E6D7A3E-2601-47C2-9FF1-2059DE945FE4}"/>
+                <a16:creationId xmlns:a16="http://schemas.microsoft.com/office/drawing/2014/main" id="{1882DCA7-5716-4895-B98D-EE932395D191}"/>
               </a:ext>
             </a:extLst>
           </p:cNvPr>
@@ -19021,7 +19021,7 @@
           <p:cNvPr id="5" name="">
             <a:extLst xmlns:a="http://schemas.openxmlformats.org/drawingml/2006/main">
               <a:ext uri="{FF2B5EF4-FFF2-40B4-BE49-F238E27FC236}">
-                <a16:creationId xmlns:a16="http://schemas.microsoft.com/office/drawing/2014/main" id="{D4EC9FBA-FEBE-4247-837D-175918E6AC4C}"/>
+                <a16:creationId xmlns:a16="http://schemas.microsoft.com/office/drawing/2014/main" id="{D0BBAA13-1FC2-441D-9186-93A8314EBD1D}"/>
               </a:ext>
             </a:extLst>
           </p:cNvPr>
@@ -19178,7 +19178,7 @@
           <p:cNvPr id="6" name="">
             <a:extLst xmlns:a="http://schemas.openxmlformats.org/drawingml/2006/main">
               <a:ext uri="{FF2B5EF4-FFF2-40B4-BE49-F238E27FC236}">
-                <a16:creationId xmlns:a16="http://schemas.microsoft.com/office/drawing/2014/main" id="{78D43C42-4938-4AE2-AF6C-23C1A8D86072}"/>
+                <a16:creationId xmlns:a16="http://schemas.microsoft.com/office/drawing/2014/main" id="{BEA16958-3D5C-4913-B27B-A496695B8012}"/>
               </a:ext>
             </a:extLst>
           </p:cNvPr>
@@ -19335,7 +19335,7 @@
           <p:cNvPr id="7" name="">
             <a:extLst xmlns:a="http://schemas.openxmlformats.org/drawingml/2006/main">
               <a:ext uri="{FF2B5EF4-FFF2-40B4-BE49-F238E27FC236}">
-                <a16:creationId xmlns:a16="http://schemas.microsoft.com/office/drawing/2014/main" id="{8F422695-EC00-4E7C-9FAE-EDB45D274954}"/>
+                <a16:creationId xmlns:a16="http://schemas.microsoft.com/office/drawing/2014/main" id="{62F64CDA-1FBF-4EA7-AB3F-1541873916FE}"/>
               </a:ext>
             </a:extLst>
           </p:cNvPr>
@@ -19492,7 +19492,7 @@
           <p:cNvPr id="8" name="">
             <a:extLst xmlns:a="http://schemas.openxmlformats.org/drawingml/2006/main">
               <a:ext uri="{FF2B5EF4-FFF2-40B4-BE49-F238E27FC236}">
-                <a16:creationId xmlns:a16="http://schemas.microsoft.com/office/drawing/2014/main" id="{719A2A20-0EFD-45BE-A051-B3EA06ACFE7F}"/>
+                <a16:creationId xmlns:a16="http://schemas.microsoft.com/office/drawing/2014/main" id="{8F312ED9-D870-4815-AB85-7F3E09E42119}"/>
               </a:ext>
             </a:extLst>
           </p:cNvPr>
@@ -19649,7 +19649,7 @@
           <p:cNvPr id="9" name="">
             <a:extLst xmlns:a="http://schemas.openxmlformats.org/drawingml/2006/main">
               <a:ext uri="{FF2B5EF4-FFF2-40B4-BE49-F238E27FC236}">
-                <a16:creationId xmlns:a16="http://schemas.microsoft.com/office/drawing/2014/main" id="{C90A0333-7E26-44E1-96DC-2601C1C29E9B}"/>
+                <a16:creationId xmlns:a16="http://schemas.microsoft.com/office/drawing/2014/main" id="{0309FFAD-C873-40A6-ACB5-5316C7BE7EDC}"/>
               </a:ext>
             </a:extLst>
           </p:cNvPr>
@@ -19806,7 +19806,7 @@
           <p:cNvPr id="10" name="">
             <a:extLst xmlns:a="http://schemas.openxmlformats.org/drawingml/2006/main">
               <a:ext uri="{FF2B5EF4-FFF2-40B4-BE49-F238E27FC236}">
-                <a16:creationId xmlns:a16="http://schemas.microsoft.com/office/drawing/2014/main" id="{EF5B8EE0-53F2-45B3-A67A-C2179BC94074}"/>
+                <a16:creationId xmlns:a16="http://schemas.microsoft.com/office/drawing/2014/main" id="{8AC89A71-BB19-4BF6-8557-0D51B4FC3BB6}"/>
               </a:ext>
             </a:extLst>
           </p:cNvPr>
@@ -19963,7 +19963,7 @@
           <p:cNvPr id="11" name="">
             <a:extLst xmlns:a="http://schemas.openxmlformats.org/drawingml/2006/main">
               <a:ext uri="{FF2B5EF4-FFF2-40B4-BE49-F238E27FC236}">
-                <a16:creationId xmlns:a16="http://schemas.microsoft.com/office/drawing/2014/main" id="{6B510EC0-4906-431C-9C89-5FB7DC8E2B31}"/>
+                <a16:creationId xmlns:a16="http://schemas.microsoft.com/office/drawing/2014/main" id="{E7FD43EB-0B1A-4659-B282-4A8DBC9CFCF3}"/>
               </a:ext>
             </a:extLst>
           </p:cNvPr>
@@ -20120,7 +20120,7 @@
           <p:cNvPr id="12" name="">
             <a:extLst xmlns:a="http://schemas.openxmlformats.org/drawingml/2006/main">
               <a:ext uri="{FF2B5EF4-FFF2-40B4-BE49-F238E27FC236}">
-                <a16:creationId xmlns:a16="http://schemas.microsoft.com/office/drawing/2014/main" id="{749B720B-70EC-4130-A4B8-9509FBB83F81}"/>
+                <a16:creationId xmlns:a16="http://schemas.microsoft.com/office/drawing/2014/main" id="{B4AD39E1-12D7-4D46-9BD3-B7F90DDF9092}"/>
               </a:ext>
             </a:extLst>
           </p:cNvPr>
@@ -20277,7 +20277,7 @@
           <p:cNvPr id="13" name="">
             <a:extLst xmlns:a="http://schemas.openxmlformats.org/drawingml/2006/main">
               <a:ext uri="{FF2B5EF4-FFF2-40B4-BE49-F238E27FC236}">
-                <a16:creationId xmlns:a16="http://schemas.microsoft.com/office/drawing/2014/main" id="{E2429F0B-73F0-4576-A9B4-2EDB0AADA84C}"/>
+                <a16:creationId xmlns:a16="http://schemas.microsoft.com/office/drawing/2014/main" id="{00778B26-E1D3-4A93-A96F-5F4B57BD597B}"/>
               </a:ext>
             </a:extLst>
           </p:cNvPr>
@@ -20432,7 +20432,7 @@
     </p:spTree>
     <p:extLst>
       <p:ext uri="{BB962C8B-B14F-4D97-AF65-F5344CB8AC3E}">
-        <p14:creationId xmlns:p14="http://schemas.microsoft.com/office/powerpoint/2010/main" val="1580183520"/>
+        <p14:creationId xmlns:p14="http://schemas.microsoft.com/office/powerpoint/2010/main" val="230101687"/>
       </p:ext>
     </p:extLst>
   </p:cSld>
@@ -20463,7 +20463,7 @@
           <p:cNvPr id="9" name="">
             <a:extLst xmlns:a="http://schemas.openxmlformats.org/drawingml/2006/main">
               <a:ext uri="{FF2B5EF4-FFF2-40B4-BE49-F238E27FC236}">
-                <a16:creationId xmlns:a16="http://schemas.microsoft.com/office/drawing/2014/main" id="{ABBBE7F5-0F14-4DC1-B723-D26077428EC6}"/>
+                <a16:creationId xmlns:a16="http://schemas.microsoft.com/office/drawing/2014/main" id="{2E6A6760-3291-44B7-9631-9F8EA5B56D84}"/>
               </a:ext>
             </a:extLst>
           </p:cNvPr>
@@ -20620,7 +20620,7 @@
           <p:cNvPr id="2" name="">
             <a:extLst xmlns:a="http://schemas.openxmlformats.org/drawingml/2006/main">
               <a:ext uri="{FF2B5EF4-FFF2-40B4-BE49-F238E27FC236}">
-                <a16:creationId xmlns:a16="http://schemas.microsoft.com/office/drawing/2014/main" id="{6D0F139F-0D39-4339-A196-AABD5BB5857A}"/>
+                <a16:creationId xmlns:a16="http://schemas.microsoft.com/office/drawing/2014/main" id="{FD488387-97BD-4CEC-9E8D-34CD1E295E1B}"/>
               </a:ext>
             </a:extLst>
           </p:cNvPr>
@@ -20651,7 +20651,7 @@
           <p:cNvPr id="3" name="">
             <a:extLst xmlns:a="http://schemas.openxmlformats.org/drawingml/2006/main">
               <a:ext uri="{FF2B5EF4-FFF2-40B4-BE49-F238E27FC236}">
-                <a16:creationId xmlns:a16="http://schemas.microsoft.com/office/drawing/2014/main" id="{B602E770-A142-47C1-9BE3-492ECB57F091}"/>
+                <a16:creationId xmlns:a16="http://schemas.microsoft.com/office/drawing/2014/main" id="{9F1A2AE3-E762-4442-84B6-18BF8F790DDB}"/>
               </a:ext>
             </a:extLst>
           </p:cNvPr>
@@ -20808,7 +20808,7 @@
           <p:cNvPr id="4" name="">
             <a:extLst xmlns:a="http://schemas.openxmlformats.org/drawingml/2006/main">
               <a:ext uri="{FF2B5EF4-FFF2-40B4-BE49-F238E27FC236}">
-                <a16:creationId xmlns:a16="http://schemas.microsoft.com/office/drawing/2014/main" id="{11F60FDE-6783-4734-AE2D-332361433F43}"/>
+                <a16:creationId xmlns:a16="http://schemas.microsoft.com/office/drawing/2014/main" id="{6CA855E8-67C6-4FA2-A2BD-6118399C163B}"/>
               </a:ext>
             </a:extLst>
           </p:cNvPr>
@@ -20965,7 +20965,7 @@
           <p:cNvPr id="5" name="">
             <a:extLst xmlns:a="http://schemas.openxmlformats.org/drawingml/2006/main">
               <a:ext uri="{FF2B5EF4-FFF2-40B4-BE49-F238E27FC236}">
-                <a16:creationId xmlns:a16="http://schemas.microsoft.com/office/drawing/2014/main" id="{D8A8F2BD-1EA6-4A45-96CC-3156F5ADAC4F}"/>
+                <a16:creationId xmlns:a16="http://schemas.microsoft.com/office/drawing/2014/main" id="{5396AF34-EF68-4AFD-A855-0BCC62D804FC}"/>
               </a:ext>
             </a:extLst>
           </p:cNvPr>
@@ -21122,7 +21122,7 @@
           <p:cNvPr id="6" name="">
             <a:extLst xmlns:a="http://schemas.openxmlformats.org/drawingml/2006/main">
               <a:ext uri="{FF2B5EF4-FFF2-40B4-BE49-F238E27FC236}">
-                <a16:creationId xmlns:a16="http://schemas.microsoft.com/office/drawing/2014/main" id="{2823D0A6-0781-479A-8983-999C8C4B342D}"/>
+                <a16:creationId xmlns:a16="http://schemas.microsoft.com/office/drawing/2014/main" id="{AF918D3F-C0A7-4951-8785-7E7CF4A34CBC}"/>
               </a:ext>
             </a:extLst>
           </p:cNvPr>
@@ -21302,7 +21302,7 @@
           <p:cNvPr id="7" name="">
             <a:extLst xmlns:a="http://schemas.openxmlformats.org/drawingml/2006/main">
               <a:ext uri="{FF2B5EF4-FFF2-40B4-BE49-F238E27FC236}">
-                <a16:creationId xmlns:a16="http://schemas.microsoft.com/office/drawing/2014/main" id="{E808897F-B9DD-4DE5-86D2-760F5526D77A}"/>
+                <a16:creationId xmlns:a16="http://schemas.microsoft.com/office/drawing/2014/main" id="{C20D7CD6-964C-4770-93E1-5C8E6F6D2579}"/>
               </a:ext>
             </a:extLst>
           </p:cNvPr>
@@ -21482,7 +21482,7 @@
           <p:cNvPr id="8" name="">
             <a:extLst xmlns:a="http://schemas.openxmlformats.org/drawingml/2006/main">
               <a:ext uri="{FF2B5EF4-FFF2-40B4-BE49-F238E27FC236}">
-                <a16:creationId xmlns:a16="http://schemas.microsoft.com/office/drawing/2014/main" id="{9120C8C2-1A0C-4027-9286-2D4B61BA8C68}"/>
+                <a16:creationId xmlns:a16="http://schemas.microsoft.com/office/drawing/2014/main" id="{D902A92A-08E1-4929-93DF-2DE52F540248}"/>
               </a:ext>
             </a:extLst>
           </p:cNvPr>
@@ -21637,7 +21637,7 @@
     </p:spTree>
     <p:extLst>
       <p:ext uri="{BB962C8B-B14F-4D97-AF65-F5344CB8AC3E}">
-        <p14:creationId xmlns:p14="http://schemas.microsoft.com/office/powerpoint/2010/main" val="171163103"/>
+        <p14:creationId xmlns:p14="http://schemas.microsoft.com/office/powerpoint/2010/main" val="1985182002"/>
       </p:ext>
     </p:extLst>
   </p:cSld>
@@ -21668,7 +21668,7 @@
           <p:cNvPr id="20" name="">
             <a:extLst xmlns:a="http://schemas.openxmlformats.org/drawingml/2006/main">
               <a:ext uri="{FF2B5EF4-FFF2-40B4-BE49-F238E27FC236}">
-                <a16:creationId xmlns:a16="http://schemas.microsoft.com/office/drawing/2014/main" id="{32D927FC-EB01-492B-BBAC-BF5B216C3064}"/>
+                <a16:creationId xmlns:a16="http://schemas.microsoft.com/office/drawing/2014/main" id="{34DE77D2-8C44-42E6-8617-5A995C792714}"/>
               </a:ext>
             </a:extLst>
           </p:cNvPr>
@@ -21825,7 +21825,7 @@
           <p:cNvPr id="2" name="">
             <a:extLst xmlns:a="http://schemas.openxmlformats.org/drawingml/2006/main">
               <a:ext uri="{FF2B5EF4-FFF2-40B4-BE49-F238E27FC236}">
-                <a16:creationId xmlns:a16="http://schemas.microsoft.com/office/drawing/2014/main" id="{A8D91225-8969-4A53-A2EF-109AA17AAD78}"/>
+                <a16:creationId xmlns:a16="http://schemas.microsoft.com/office/drawing/2014/main" id="{FD9F569B-FFE2-4B9C-96D7-A3CA48402EE9}"/>
               </a:ext>
             </a:extLst>
           </p:cNvPr>
@@ -21856,7 +21856,7 @@
           <p:cNvPr id="3" name="">
             <a:extLst xmlns:a="http://schemas.openxmlformats.org/drawingml/2006/main">
               <a:ext uri="{FF2B5EF4-FFF2-40B4-BE49-F238E27FC236}">
-                <a16:creationId xmlns:a16="http://schemas.microsoft.com/office/drawing/2014/main" id="{10B35D62-9A27-450E-869A-83680F099554}"/>
+                <a16:creationId xmlns:a16="http://schemas.microsoft.com/office/drawing/2014/main" id="{0DECB61E-FD66-4EC9-825D-6E4C2A6ED83F}"/>
               </a:ext>
             </a:extLst>
           </p:cNvPr>
@@ -22013,7 +22013,7 @@
           <p:cNvPr id="4" name="">
             <a:extLst xmlns:a="http://schemas.openxmlformats.org/drawingml/2006/main">
               <a:ext uri="{FF2B5EF4-FFF2-40B4-BE49-F238E27FC236}">
-                <a16:creationId xmlns:a16="http://schemas.microsoft.com/office/drawing/2014/main" id="{CE8EFF02-95E0-4F3E-B3E4-BD4B76C1082E}"/>
+                <a16:creationId xmlns:a16="http://schemas.microsoft.com/office/drawing/2014/main" id="{4BA71080-B38B-411C-8C88-420B216C5C02}"/>
               </a:ext>
             </a:extLst>
           </p:cNvPr>
@@ -22170,7 +22170,7 @@
           <p:cNvPr id="5" name="">
             <a:extLst xmlns:a="http://schemas.openxmlformats.org/drawingml/2006/main">
               <a:ext uri="{FF2B5EF4-FFF2-40B4-BE49-F238E27FC236}">
-                <a16:creationId xmlns:a16="http://schemas.microsoft.com/office/drawing/2014/main" id="{A814FE2B-A014-4500-A883-B21EF569265E}"/>
+                <a16:creationId xmlns:a16="http://schemas.microsoft.com/office/drawing/2014/main" id="{7EAFCA29-30A7-4703-846C-776008E43462}"/>
               </a:ext>
             </a:extLst>
           </p:cNvPr>
@@ -22201,7 +22201,7 @@
           <p:cNvPr id="6" name="">
             <a:extLst xmlns:a="http://schemas.openxmlformats.org/drawingml/2006/main">
               <a:ext uri="{FF2B5EF4-FFF2-40B4-BE49-F238E27FC236}">
-                <a16:creationId xmlns:a16="http://schemas.microsoft.com/office/drawing/2014/main" id="{D0D9AC5A-D116-43F6-B62C-34134A2C390B}"/>
+                <a16:creationId xmlns:a16="http://schemas.microsoft.com/office/drawing/2014/main" id="{73D1C71C-452E-48AB-B012-6C720D3DCD65}"/>
               </a:ext>
             </a:extLst>
           </p:cNvPr>
@@ -22381,7 +22381,7 @@
           <p:cNvPr id="7" name="">
             <a:extLst xmlns:a="http://schemas.openxmlformats.org/drawingml/2006/main">
               <a:ext uri="{FF2B5EF4-FFF2-40B4-BE49-F238E27FC236}">
-                <a16:creationId xmlns:a16="http://schemas.microsoft.com/office/drawing/2014/main" id="{A103232B-1AE0-48C4-A18F-C681C3B62660}"/>
+                <a16:creationId xmlns:a16="http://schemas.microsoft.com/office/drawing/2014/main" id="{5A239146-107A-493D-8021-258C5FF49987}"/>
               </a:ext>
             </a:extLst>
           </p:cNvPr>
@@ -22412,7 +22412,7 @@
           <p:cNvPr id="8" name="">
             <a:extLst xmlns:a="http://schemas.openxmlformats.org/drawingml/2006/main">
               <a:ext uri="{FF2B5EF4-FFF2-40B4-BE49-F238E27FC236}">
-                <a16:creationId xmlns:a16="http://schemas.microsoft.com/office/drawing/2014/main" id="{D47530D4-35D2-4A35-A1AF-C966F23FBE3D}"/>
+                <a16:creationId xmlns:a16="http://schemas.microsoft.com/office/drawing/2014/main" id="{629BA66B-4C0D-4235-B675-F505DFA6F546}"/>
               </a:ext>
             </a:extLst>
           </p:cNvPr>
@@ -22592,7 +22592,7 @@
           <p:cNvPr id="9" name="">
             <a:extLst xmlns:a="http://schemas.openxmlformats.org/drawingml/2006/main">
               <a:ext uri="{FF2B5EF4-FFF2-40B4-BE49-F238E27FC236}">
-                <a16:creationId xmlns:a16="http://schemas.microsoft.com/office/drawing/2014/main" id="{3306C93D-FC54-427D-8DEA-A1720031A864}"/>
+                <a16:creationId xmlns:a16="http://schemas.microsoft.com/office/drawing/2014/main" id="{BA03E288-F3B1-4B84-B093-620DBCC359DB}"/>
               </a:ext>
             </a:extLst>
           </p:cNvPr>
@@ -22623,7 +22623,7 @@
           <p:cNvPr id="10" name="">
             <a:extLst xmlns:a="http://schemas.openxmlformats.org/drawingml/2006/main">
               <a:ext uri="{FF2B5EF4-FFF2-40B4-BE49-F238E27FC236}">
-                <a16:creationId xmlns:a16="http://schemas.microsoft.com/office/drawing/2014/main" id="{687A05FB-E848-4E5A-AE24-0EC86BF417D5}"/>
+                <a16:creationId xmlns:a16="http://schemas.microsoft.com/office/drawing/2014/main" id="{1A593654-89E2-40C2-970F-573091FFA712}"/>
               </a:ext>
             </a:extLst>
           </p:cNvPr>
@@ -22803,7 +22803,7 @@
           <p:cNvPr id="11" name="">
             <a:extLst xmlns:a="http://schemas.openxmlformats.org/drawingml/2006/main">
               <a:ext uri="{FF2B5EF4-FFF2-40B4-BE49-F238E27FC236}">
-                <a16:creationId xmlns:a16="http://schemas.microsoft.com/office/drawing/2014/main" id="{B099B481-696D-4051-A519-66F56D35A6EC}"/>
+                <a16:creationId xmlns:a16="http://schemas.microsoft.com/office/drawing/2014/main" id="{3355C4DC-1016-4F53-9B72-398A88389EE8}"/>
               </a:ext>
             </a:extLst>
           </p:cNvPr>
@@ -22834,7 +22834,7 @@
           <p:cNvPr id="12" name="">
             <a:extLst xmlns:a="http://schemas.openxmlformats.org/drawingml/2006/main">
               <a:ext uri="{FF2B5EF4-FFF2-40B4-BE49-F238E27FC236}">
-                <a16:creationId xmlns:a16="http://schemas.microsoft.com/office/drawing/2014/main" id="{7CFC466B-4C63-48E1-9633-1CD9E7B52A45}"/>
+                <a16:creationId xmlns:a16="http://schemas.microsoft.com/office/drawing/2014/main" id="{39EE8DD2-56D8-44C8-A2AA-4925113EA8C1}"/>
               </a:ext>
             </a:extLst>
           </p:cNvPr>
@@ -22865,7 +22865,7 @@
           <p:cNvPr id="13" name="">
             <a:extLst xmlns:a="http://schemas.openxmlformats.org/drawingml/2006/main">
               <a:ext uri="{FF2B5EF4-FFF2-40B4-BE49-F238E27FC236}">
-                <a16:creationId xmlns:a16="http://schemas.microsoft.com/office/drawing/2014/main" id="{5108CC22-FFDC-4A19-97B5-E76DAE98D6F2}"/>
+                <a16:creationId xmlns:a16="http://schemas.microsoft.com/office/drawing/2014/main" id="{08825ECC-1E33-4FE5-BF11-CB1E30CF8DEC}"/>
               </a:ext>
             </a:extLst>
           </p:cNvPr>
@@ -22896,7 +22896,7 @@
           <p:cNvPr id="14" name="">
             <a:extLst xmlns:a="http://schemas.openxmlformats.org/drawingml/2006/main">
               <a:ext uri="{FF2B5EF4-FFF2-40B4-BE49-F238E27FC236}">
-                <a16:creationId xmlns:a16="http://schemas.microsoft.com/office/drawing/2014/main" id="{94CDBCA6-EF9F-4764-8E3B-A2139722A2BE}"/>
+                <a16:creationId xmlns:a16="http://schemas.microsoft.com/office/drawing/2014/main" id="{CF45CD0F-49E3-4FFC-8CA5-7C5A54982CB5}"/>
               </a:ext>
             </a:extLst>
           </p:cNvPr>
@@ -23076,7 +23076,7 @@
           <p:cNvPr id="15" name="">
             <a:extLst xmlns:a="http://schemas.openxmlformats.org/drawingml/2006/main">
               <a:ext uri="{FF2B5EF4-FFF2-40B4-BE49-F238E27FC236}">
-                <a16:creationId xmlns:a16="http://schemas.microsoft.com/office/drawing/2014/main" id="{ACE70AF5-690F-4DEC-9F79-CC6C7157778D}"/>
+                <a16:creationId xmlns:a16="http://schemas.microsoft.com/office/drawing/2014/main" id="{0AF5396C-12BE-4C8B-A974-220C3A60EF3B}"/>
               </a:ext>
             </a:extLst>
           </p:cNvPr>
@@ -23107,7 +23107,7 @@
           <p:cNvPr id="16" name="">
             <a:extLst xmlns:a="http://schemas.openxmlformats.org/drawingml/2006/main">
               <a:ext uri="{FF2B5EF4-FFF2-40B4-BE49-F238E27FC236}">
-                <a16:creationId xmlns:a16="http://schemas.microsoft.com/office/drawing/2014/main" id="{A980C516-5F67-4D6B-8630-A50FA1D691E2}"/>
+                <a16:creationId xmlns:a16="http://schemas.microsoft.com/office/drawing/2014/main" id="{5D75F5F0-4CB3-4422-992D-78CC865E01CD}"/>
               </a:ext>
             </a:extLst>
           </p:cNvPr>
@@ -23287,7 +23287,7 @@
           <p:cNvPr id="17" name="">
             <a:extLst xmlns:a="http://schemas.openxmlformats.org/drawingml/2006/main">
               <a:ext uri="{FF2B5EF4-FFF2-40B4-BE49-F238E27FC236}">
-                <a16:creationId xmlns:a16="http://schemas.microsoft.com/office/drawing/2014/main" id="{07A52EC9-2FA3-4C1E-8A1B-9AD3F83F9687}"/>
+                <a16:creationId xmlns:a16="http://schemas.microsoft.com/office/drawing/2014/main" id="{675D778B-422C-4160-85B2-E02F03FD3610}"/>
               </a:ext>
             </a:extLst>
           </p:cNvPr>
@@ -23318,7 +23318,7 @@
           <p:cNvPr id="18" name="">
             <a:extLst xmlns:a="http://schemas.openxmlformats.org/drawingml/2006/main">
               <a:ext uri="{FF2B5EF4-FFF2-40B4-BE49-F238E27FC236}">
-                <a16:creationId xmlns:a16="http://schemas.microsoft.com/office/drawing/2014/main" id="{6FEE47DB-2D5E-423D-9953-BDF19FAADF80}"/>
+                <a16:creationId xmlns:a16="http://schemas.microsoft.com/office/drawing/2014/main" id="{0B5C82C4-C25A-4151-B512-4B31CB67AE4B}"/>
               </a:ext>
             </a:extLst>
           </p:cNvPr>
@@ -23349,7 +23349,7 @@
           <p:cNvPr id="19" name="">
             <a:extLst xmlns:a="http://schemas.openxmlformats.org/drawingml/2006/main">
               <a:ext uri="{FF2B5EF4-FFF2-40B4-BE49-F238E27FC236}">
-                <a16:creationId xmlns:a16="http://schemas.microsoft.com/office/drawing/2014/main" id="{BFF0118D-7E81-441E-9DE9-D2351100B056}"/>
+                <a16:creationId xmlns:a16="http://schemas.microsoft.com/office/drawing/2014/main" id="{4568E153-60C8-4BA7-89CB-0212E9E9763E}"/>
               </a:ext>
             </a:extLst>
           </p:cNvPr>
@@ -23504,7 +23504,7 @@
     </p:spTree>
     <p:extLst>
       <p:ext uri="{BB962C8B-B14F-4D97-AF65-F5344CB8AC3E}">
-        <p14:creationId xmlns:p14="http://schemas.microsoft.com/office/powerpoint/2010/main" val="2568616"/>
+        <p14:creationId xmlns:p14="http://schemas.microsoft.com/office/powerpoint/2010/main" val="899168156"/>
       </p:ext>
     </p:extLst>
   </p:cSld>
@@ -23535,7 +23535,7 @@
           <p:cNvPr id="12" name="">
             <a:extLst xmlns:a="http://schemas.openxmlformats.org/drawingml/2006/main">
               <a:ext uri="{FF2B5EF4-FFF2-40B4-BE49-F238E27FC236}">
-                <a16:creationId xmlns:a16="http://schemas.microsoft.com/office/drawing/2014/main" id="{C88C6C87-4811-4955-B0BA-578757C08CE0}"/>
+                <a16:creationId xmlns:a16="http://schemas.microsoft.com/office/drawing/2014/main" id="{D9F9E8F8-F765-435C-8E6D-CC5F2DFB2E44}"/>
               </a:ext>
             </a:extLst>
           </p:cNvPr>
@@ -23692,7 +23692,7 @@
           <p:cNvPr id="2" name="">
             <a:extLst xmlns:a="http://schemas.openxmlformats.org/drawingml/2006/main">
               <a:ext uri="{FF2B5EF4-FFF2-40B4-BE49-F238E27FC236}">
-                <a16:creationId xmlns:a16="http://schemas.microsoft.com/office/drawing/2014/main" id="{1A4519A9-04F7-4CED-AE10-9ADFC97BF943}"/>
+                <a16:creationId xmlns:a16="http://schemas.microsoft.com/office/drawing/2014/main" id="{140FB4F0-B891-4DA8-A80D-FBDB64054BD1}"/>
               </a:ext>
             </a:extLst>
           </p:cNvPr>
@@ -23723,7 +23723,7 @@
           <p:cNvPr id="3" name="">
             <a:extLst xmlns:a="http://schemas.openxmlformats.org/drawingml/2006/main">
               <a:ext uri="{FF2B5EF4-FFF2-40B4-BE49-F238E27FC236}">
-                <a16:creationId xmlns:a16="http://schemas.microsoft.com/office/drawing/2014/main" id="{243B4B46-30AC-4872-B8D2-1F27E3A00CB2}"/>
+                <a16:creationId xmlns:a16="http://schemas.microsoft.com/office/drawing/2014/main" id="{741DF5D9-AA4B-400B-A087-71FC96F8F13A}"/>
               </a:ext>
             </a:extLst>
           </p:cNvPr>
@@ -23880,7 +23880,7 @@
           <p:cNvPr id="4" name="">
             <a:extLst xmlns:a="http://schemas.openxmlformats.org/drawingml/2006/main">
               <a:ext uri="{FF2B5EF4-FFF2-40B4-BE49-F238E27FC236}">
-                <a16:creationId xmlns:a16="http://schemas.microsoft.com/office/drawing/2014/main" id="{F90670E9-49C4-4825-83DD-86FCB17503D2}"/>
+                <a16:creationId xmlns:a16="http://schemas.microsoft.com/office/drawing/2014/main" id="{281E4DC5-3F16-4AE9-9CFA-764C6329BEF6}"/>
               </a:ext>
             </a:extLst>
           </p:cNvPr>
@@ -24037,7 +24037,7 @@
           <p:cNvPr id="5" name="">
             <a:extLst xmlns:a="http://schemas.openxmlformats.org/drawingml/2006/main">
               <a:ext uri="{FF2B5EF4-FFF2-40B4-BE49-F238E27FC236}">
-                <a16:creationId xmlns:a16="http://schemas.microsoft.com/office/drawing/2014/main" id="{FFDDCEB7-A7D3-4E33-A6B3-BC527EF8604B}"/>
+                <a16:creationId xmlns:a16="http://schemas.microsoft.com/office/drawing/2014/main" id="{86E525B0-90BB-4D9F-BE59-483C453160CA}"/>
               </a:ext>
             </a:extLst>
           </p:cNvPr>
@@ -24194,7 +24194,7 @@
           <p:cNvPr id="6" name="">
             <a:extLst xmlns:a="http://schemas.openxmlformats.org/drawingml/2006/main">
               <a:ext uri="{FF2B5EF4-FFF2-40B4-BE49-F238E27FC236}">
-                <a16:creationId xmlns:a16="http://schemas.microsoft.com/office/drawing/2014/main" id="{7F8C70F7-CD6B-4972-A1D4-44CE9DC81C1A}"/>
+                <a16:creationId xmlns:a16="http://schemas.microsoft.com/office/drawing/2014/main" id="{AEB7EFD0-20A1-47A5-88CB-1EAB3C6149FF}"/>
               </a:ext>
             </a:extLst>
           </p:cNvPr>
@@ -24351,7 +24351,7 @@
           <p:cNvPr id="7" name="">
             <a:extLst xmlns:a="http://schemas.openxmlformats.org/drawingml/2006/main">
               <a:ext uri="{FF2B5EF4-FFF2-40B4-BE49-F238E27FC236}">
-                <a16:creationId xmlns:a16="http://schemas.microsoft.com/office/drawing/2014/main" id="{D02F04E0-A3FF-47AA-8330-B70DAC40B8F5}"/>
+                <a16:creationId xmlns:a16="http://schemas.microsoft.com/office/drawing/2014/main" id="{7A581115-17AB-4526-9AD4-EBC310FD2592}"/>
               </a:ext>
             </a:extLst>
           </p:cNvPr>
@@ -24508,7 +24508,7 @@
           <p:cNvPr id="8" name="">
             <a:extLst xmlns:a="http://schemas.openxmlformats.org/drawingml/2006/main">
               <a:ext uri="{FF2B5EF4-FFF2-40B4-BE49-F238E27FC236}">
-                <a16:creationId xmlns:a16="http://schemas.microsoft.com/office/drawing/2014/main" id="{702F7B86-760A-4766-8F0E-57E7B583FE27}"/>
+                <a16:creationId xmlns:a16="http://schemas.microsoft.com/office/drawing/2014/main" id="{019BDDDD-F8C3-4E10-8FEF-2DCFE5EA7CDB}"/>
               </a:ext>
             </a:extLst>
           </p:cNvPr>
@@ -24665,7 +24665,7 @@
           <p:cNvPr id="9" name="">
             <a:extLst xmlns:a="http://schemas.openxmlformats.org/drawingml/2006/main">
               <a:ext uri="{FF2B5EF4-FFF2-40B4-BE49-F238E27FC236}">
-                <a16:creationId xmlns:a16="http://schemas.microsoft.com/office/drawing/2014/main" id="{4954124D-21C5-45F9-87CF-815C3EDEF03E}"/>
+                <a16:creationId xmlns:a16="http://schemas.microsoft.com/office/drawing/2014/main" id="{97CA2593-5B13-4256-9DAE-C03C47D834A9}"/>
               </a:ext>
             </a:extLst>
           </p:cNvPr>
@@ -24822,7 +24822,7 @@
           <p:cNvPr id="10" name="">
             <a:extLst xmlns:a="http://schemas.openxmlformats.org/drawingml/2006/main">
               <a:ext uri="{FF2B5EF4-FFF2-40B4-BE49-F238E27FC236}">
-                <a16:creationId xmlns:a16="http://schemas.microsoft.com/office/drawing/2014/main" id="{8F004C56-568B-4642-B76D-8105BE065E56}"/>
+                <a16:creationId xmlns:a16="http://schemas.microsoft.com/office/drawing/2014/main" id="{378B0D6F-9B3E-4463-8F97-9909AF99418E}"/>
               </a:ext>
             </a:extLst>
           </p:cNvPr>
@@ -24979,7 +24979,7 @@
           <p:cNvPr id="11" name="">
             <a:extLst xmlns:a="http://schemas.openxmlformats.org/drawingml/2006/main">
               <a:ext uri="{FF2B5EF4-FFF2-40B4-BE49-F238E27FC236}">
-                <a16:creationId xmlns:a16="http://schemas.microsoft.com/office/drawing/2014/main" id="{FACBB0E6-B57F-4B84-B28A-E31E6D768387}"/>
+                <a16:creationId xmlns:a16="http://schemas.microsoft.com/office/drawing/2014/main" id="{B2FABFFE-7F05-4F3F-A893-733A01673F43}"/>
               </a:ext>
             </a:extLst>
           </p:cNvPr>
@@ -25134,7 +25134,7 @@
     </p:spTree>
     <p:extLst>
       <p:ext uri="{BB962C8B-B14F-4D97-AF65-F5344CB8AC3E}">
-        <p14:creationId xmlns:p14="http://schemas.microsoft.com/office/powerpoint/2010/main" val="281289013"/>
+        <p14:creationId xmlns:p14="http://schemas.microsoft.com/office/powerpoint/2010/main" val="897912556"/>
       </p:ext>
     </p:extLst>
   </p:cSld>
@@ -25165,7 +25165,7 @@
           <p:cNvPr id="10" name="">
             <a:extLst xmlns:a="http://schemas.openxmlformats.org/drawingml/2006/main">
               <a:ext uri="{FF2B5EF4-FFF2-40B4-BE49-F238E27FC236}">
-                <a16:creationId xmlns:a16="http://schemas.microsoft.com/office/drawing/2014/main" id="{296A56CC-F9FB-4974-A906-BFAB5D1BC881}"/>
+                <a16:creationId xmlns:a16="http://schemas.microsoft.com/office/drawing/2014/main" id="{98E327BF-5F0A-4F1F-94EA-D05087F8B78A}"/>
               </a:ext>
             </a:extLst>
           </p:cNvPr>
@@ -25322,7 +25322,7 @@
           <p:cNvPr id="2" name="">
             <a:extLst xmlns:a="http://schemas.openxmlformats.org/drawingml/2006/main">
               <a:ext uri="{FF2B5EF4-FFF2-40B4-BE49-F238E27FC236}">
-                <a16:creationId xmlns:a16="http://schemas.microsoft.com/office/drawing/2014/main" id="{864EB8E7-D72C-46DB-A720-4092168BE819}"/>
+                <a16:creationId xmlns:a16="http://schemas.microsoft.com/office/drawing/2014/main" id="{0DDCFE8C-2A74-4B0C-BAE1-3208C1334295}"/>
               </a:ext>
             </a:extLst>
           </p:cNvPr>
@@ -25353,7 +25353,7 @@
           <p:cNvPr id="3" name="">
             <a:extLst xmlns:a="http://schemas.openxmlformats.org/drawingml/2006/main">
               <a:ext uri="{FF2B5EF4-FFF2-40B4-BE49-F238E27FC236}">
-                <a16:creationId xmlns:a16="http://schemas.microsoft.com/office/drawing/2014/main" id="{5976A36A-BACC-40D0-A9AD-701DD7B0199B}"/>
+                <a16:creationId xmlns:a16="http://schemas.microsoft.com/office/drawing/2014/main" id="{98D80A4F-5C18-4D11-8BD1-DE1229A08B38}"/>
               </a:ext>
             </a:extLst>
           </p:cNvPr>
@@ -25510,7 +25510,7 @@
           <p:cNvPr id="4" name="">
             <a:extLst xmlns:a="http://schemas.openxmlformats.org/drawingml/2006/main">
               <a:ext uri="{FF2B5EF4-FFF2-40B4-BE49-F238E27FC236}">
-                <a16:creationId xmlns:a16="http://schemas.microsoft.com/office/drawing/2014/main" id="{6D0FC5EA-B4AF-47BD-B309-BBB890427F06}"/>
+                <a16:creationId xmlns:a16="http://schemas.microsoft.com/office/drawing/2014/main" id="{BA3C5C9E-7EF4-4597-A777-B8F6EFEA088C}"/>
               </a:ext>
             </a:extLst>
           </p:cNvPr>
@@ -25667,7 +25667,7 @@
           <p:cNvPr id="5" name="">
             <a:extLst xmlns:a="http://schemas.openxmlformats.org/drawingml/2006/main">
               <a:ext uri="{FF2B5EF4-FFF2-40B4-BE49-F238E27FC236}">
-                <a16:creationId xmlns:a16="http://schemas.microsoft.com/office/drawing/2014/main" id="{610C24A1-5D90-4F19-9FD8-9EDD370CBCC7}"/>
+                <a16:creationId xmlns:a16="http://schemas.microsoft.com/office/drawing/2014/main" id="{163A1F43-E5DC-41BD-90B2-580EE9F1E54C}"/>
               </a:ext>
             </a:extLst>
           </p:cNvPr>
@@ -25824,7 +25824,7 @@
           <p:cNvPr id="6" name="">
             <a:extLst xmlns:a="http://schemas.openxmlformats.org/drawingml/2006/main">
               <a:ext uri="{FF2B5EF4-FFF2-40B4-BE49-F238E27FC236}">
-                <a16:creationId xmlns:a16="http://schemas.microsoft.com/office/drawing/2014/main" id="{D3E44529-1A08-414C-A43F-AACF2CC77E0D}"/>
+                <a16:creationId xmlns:a16="http://schemas.microsoft.com/office/drawing/2014/main" id="{A3685FB6-A00D-4BB7-AD1E-F19C690E7038}"/>
               </a:ext>
             </a:extLst>
           </p:cNvPr>
@@ -25981,7 +25981,7 @@
           <p:cNvPr id="7" name="">
             <a:extLst xmlns:a="http://schemas.openxmlformats.org/drawingml/2006/main">
               <a:ext uri="{FF2B5EF4-FFF2-40B4-BE49-F238E27FC236}">
-                <a16:creationId xmlns:a16="http://schemas.microsoft.com/office/drawing/2014/main" id="{1AFA6AFE-BC1D-46C1-A649-A9CE396F420D}"/>
+                <a16:creationId xmlns:a16="http://schemas.microsoft.com/office/drawing/2014/main" id="{3D158DB6-AEE2-49A5-BD90-33436AF2208F}"/>
               </a:ext>
             </a:extLst>
           </p:cNvPr>
@@ -26235,7 +26235,7 @@
           <p:cNvPr id="8" name="">
             <a:extLst xmlns:a="http://schemas.openxmlformats.org/drawingml/2006/main">
               <a:ext uri="{FF2B5EF4-FFF2-40B4-BE49-F238E27FC236}">
-                <a16:creationId xmlns:a16="http://schemas.microsoft.com/office/drawing/2014/main" id="{5260F198-8E45-4CB1-AEDF-6AB2A38FFE25}"/>
+                <a16:creationId xmlns:a16="http://schemas.microsoft.com/office/drawing/2014/main" id="{42677F9C-E22B-4397-A25F-DD7F4A606507}"/>
               </a:ext>
             </a:extLst>
           </p:cNvPr>
@@ -26484,7 +26484,7 @@
           <p:cNvPr id="9" name="">
             <a:extLst xmlns:a="http://schemas.openxmlformats.org/drawingml/2006/main">
               <a:ext uri="{FF2B5EF4-FFF2-40B4-BE49-F238E27FC236}">
-                <a16:creationId xmlns:a16="http://schemas.microsoft.com/office/drawing/2014/main" id="{0A55072D-7CC9-40B8-9B22-814994FAD5EE}"/>
+                <a16:creationId xmlns:a16="http://schemas.microsoft.com/office/drawing/2014/main" id="{40EC2945-7F6C-4656-9527-93961C66C9AE}"/>
               </a:ext>
             </a:extLst>
           </p:cNvPr>
@@ -26639,7 +26639,7 @@
     </p:spTree>
     <p:extLst>
       <p:ext uri="{BB962C8B-B14F-4D97-AF65-F5344CB8AC3E}">
-        <p14:creationId xmlns:p14="http://schemas.microsoft.com/office/powerpoint/2010/main" val="332072710"/>
+        <p14:creationId xmlns:p14="http://schemas.microsoft.com/office/powerpoint/2010/main" val="172958740"/>
       </p:ext>
     </p:extLst>
   </p:cSld>
@@ -26670,7 +26670,7 @@
           <p:cNvPr id="14" name="">
             <a:extLst xmlns:a="http://schemas.openxmlformats.org/drawingml/2006/main">
               <a:ext uri="{FF2B5EF4-FFF2-40B4-BE49-F238E27FC236}">
-                <a16:creationId xmlns:a16="http://schemas.microsoft.com/office/drawing/2014/main" id="{5D8D2C21-215B-4EE3-A92A-691957AE9C3B}"/>
+                <a16:creationId xmlns:a16="http://schemas.microsoft.com/office/drawing/2014/main" id="{1F532742-1466-48A4-904C-66CB859DF43F}"/>
               </a:ext>
             </a:extLst>
           </p:cNvPr>
@@ -26827,7 +26827,7 @@
           <p:cNvPr id="2" name="">
             <a:extLst xmlns:a="http://schemas.openxmlformats.org/drawingml/2006/main">
               <a:ext uri="{FF2B5EF4-FFF2-40B4-BE49-F238E27FC236}">
-                <a16:creationId xmlns:a16="http://schemas.microsoft.com/office/drawing/2014/main" id="{C41E94D3-C3DC-4108-91A9-D3544168CC8C}"/>
+                <a16:creationId xmlns:a16="http://schemas.microsoft.com/office/drawing/2014/main" id="{C629D084-2DD6-4ADB-8F11-4E0A65605AC0}"/>
               </a:ext>
             </a:extLst>
           </p:cNvPr>
@@ -26858,7 +26858,7 @@
           <p:cNvPr id="3" name="">
             <a:extLst xmlns:a="http://schemas.openxmlformats.org/drawingml/2006/main">
               <a:ext uri="{FF2B5EF4-FFF2-40B4-BE49-F238E27FC236}">
-                <a16:creationId xmlns:a16="http://schemas.microsoft.com/office/drawing/2014/main" id="{3B85FCC6-87E5-4D2E-AB4F-A9B2455D1B27}"/>
+                <a16:creationId xmlns:a16="http://schemas.microsoft.com/office/drawing/2014/main" id="{84D4DDA7-313E-4E78-AD07-F472FF3E0BD0}"/>
               </a:ext>
             </a:extLst>
           </p:cNvPr>
@@ -27015,7 +27015,7 @@
           <p:cNvPr id="4" name="">
             <a:extLst xmlns:a="http://schemas.openxmlformats.org/drawingml/2006/main">
               <a:ext uri="{FF2B5EF4-FFF2-40B4-BE49-F238E27FC236}">
-                <a16:creationId xmlns:a16="http://schemas.microsoft.com/office/drawing/2014/main" id="{1048B204-AA87-42FC-BC2F-DF7178171417}"/>
+                <a16:creationId xmlns:a16="http://schemas.microsoft.com/office/drawing/2014/main" id="{F7BDCEBA-8484-4F65-8554-EA6CBCBB4607}"/>
               </a:ext>
             </a:extLst>
           </p:cNvPr>
@@ -27172,7 +27172,7 @@
           <p:cNvPr id="5" name="">
             <a:extLst xmlns:a="http://schemas.openxmlformats.org/drawingml/2006/main">
               <a:ext uri="{FF2B5EF4-FFF2-40B4-BE49-F238E27FC236}">
-                <a16:creationId xmlns:a16="http://schemas.microsoft.com/office/drawing/2014/main" id="{8858D0DC-EC57-4AA7-9D94-2C7DF4C2551C}"/>
+                <a16:creationId xmlns:a16="http://schemas.microsoft.com/office/drawing/2014/main" id="{58698572-CF57-4A30-A402-A1B7AA716F40}"/>
               </a:ext>
             </a:extLst>
           </p:cNvPr>
@@ -27329,7 +27329,7 @@
           <p:cNvPr id="6" name="">
             <a:extLst xmlns:a="http://schemas.openxmlformats.org/drawingml/2006/main">
               <a:ext uri="{FF2B5EF4-FFF2-40B4-BE49-F238E27FC236}">
-                <a16:creationId xmlns:a16="http://schemas.microsoft.com/office/drawing/2014/main" id="{DC63676D-1760-40DA-ACFA-B29E8B84769A}"/>
+                <a16:creationId xmlns:a16="http://schemas.microsoft.com/office/drawing/2014/main" id="{CFC6DE1A-51E1-4B84-8943-354505CBB1B2}"/>
               </a:ext>
             </a:extLst>
           </p:cNvPr>
@@ -27486,7 +27486,7 @@
           <p:cNvPr id="7" name="">
             <a:extLst xmlns:a="http://schemas.openxmlformats.org/drawingml/2006/main">
               <a:ext uri="{FF2B5EF4-FFF2-40B4-BE49-F238E27FC236}">
-                <a16:creationId xmlns:a16="http://schemas.microsoft.com/office/drawing/2014/main" id="{0A7CBFAF-FA43-4EEB-9AC7-EBEADB5E79BB}"/>
+                <a16:creationId xmlns:a16="http://schemas.microsoft.com/office/drawing/2014/main" id="{AB80DB4F-56D1-400D-B701-7D8062ADA99D}"/>
               </a:ext>
             </a:extLst>
           </p:cNvPr>
@@ -27643,7 +27643,7 @@
           <p:cNvPr id="8" name="">
             <a:extLst xmlns:a="http://schemas.openxmlformats.org/drawingml/2006/main">
               <a:ext uri="{FF2B5EF4-FFF2-40B4-BE49-F238E27FC236}">
-                <a16:creationId xmlns:a16="http://schemas.microsoft.com/office/drawing/2014/main" id="{1487B4E2-0D69-4172-9E6C-5BBEC55D6E06}"/>
+                <a16:creationId xmlns:a16="http://schemas.microsoft.com/office/drawing/2014/main" id="{E059EF22-E9DE-4915-A676-44DDC78097B6}"/>
               </a:ext>
             </a:extLst>
           </p:cNvPr>
@@ -27800,7 +27800,7 @@
           <p:cNvPr id="9" name="">
             <a:extLst xmlns:a="http://schemas.openxmlformats.org/drawingml/2006/main">
               <a:ext uri="{FF2B5EF4-FFF2-40B4-BE49-F238E27FC236}">
-                <a16:creationId xmlns:a16="http://schemas.microsoft.com/office/drawing/2014/main" id="{0F71C196-A81E-41EC-A61E-06B66D20C590}"/>
+                <a16:creationId xmlns:a16="http://schemas.microsoft.com/office/drawing/2014/main" id="{DBD93459-0946-44C1-BAF2-C6711C8A3E20}"/>
               </a:ext>
             </a:extLst>
           </p:cNvPr>
@@ -27957,7 +27957,7 @@
           <p:cNvPr id="10" name="">
             <a:extLst xmlns:a="http://schemas.openxmlformats.org/drawingml/2006/main">
               <a:ext uri="{FF2B5EF4-FFF2-40B4-BE49-F238E27FC236}">
-                <a16:creationId xmlns:a16="http://schemas.microsoft.com/office/drawing/2014/main" id="{A7113CEF-08F1-47E6-B4DE-5347266EAB0F}"/>
+                <a16:creationId xmlns:a16="http://schemas.microsoft.com/office/drawing/2014/main" id="{A6C119D0-8611-4336-BE17-388BC0564D6F}"/>
               </a:ext>
             </a:extLst>
           </p:cNvPr>
@@ -28114,7 +28114,7 @@
           <p:cNvPr id="11" name="">
             <a:extLst xmlns:a="http://schemas.openxmlformats.org/drawingml/2006/main">
               <a:ext uri="{FF2B5EF4-FFF2-40B4-BE49-F238E27FC236}">
-                <a16:creationId xmlns:a16="http://schemas.microsoft.com/office/drawing/2014/main" id="{DDE723C2-527A-4C67-9E4E-7EE04E6B0172}"/>
+                <a16:creationId xmlns:a16="http://schemas.microsoft.com/office/drawing/2014/main" id="{C3A1BAC4-0F46-45CE-8F0A-1CDF2C36DC59}"/>
               </a:ext>
             </a:extLst>
           </p:cNvPr>
@@ -28271,7 +28271,7 @@
           <p:cNvPr id="12" name="">
             <a:extLst xmlns:a="http://schemas.openxmlformats.org/drawingml/2006/main">
               <a:ext uri="{FF2B5EF4-FFF2-40B4-BE49-F238E27FC236}">
-                <a16:creationId xmlns:a16="http://schemas.microsoft.com/office/drawing/2014/main" id="{DD58BCDE-6402-4838-9A80-CEA5E332428D}"/>
+                <a16:creationId xmlns:a16="http://schemas.microsoft.com/office/drawing/2014/main" id="{9158C58C-0C5D-427E-B16F-61C1EB7DE459}"/>
               </a:ext>
             </a:extLst>
           </p:cNvPr>
@@ -28428,7 +28428,7 @@
           <p:cNvPr id="13" name="">
             <a:extLst xmlns:a="http://schemas.openxmlformats.org/drawingml/2006/main">
               <a:ext uri="{FF2B5EF4-FFF2-40B4-BE49-F238E27FC236}">
-                <a16:creationId xmlns:a16="http://schemas.microsoft.com/office/drawing/2014/main" id="{3F300DE2-2D09-482D-91B9-2ADB73CA454E}"/>
+                <a16:creationId xmlns:a16="http://schemas.microsoft.com/office/drawing/2014/main" id="{C0D6DCF9-DD07-449A-94A4-180941978422}"/>
               </a:ext>
             </a:extLst>
           </p:cNvPr>
@@ -28583,7 +28583,7 @@
     </p:spTree>
     <p:extLst>
       <p:ext uri="{BB962C8B-B14F-4D97-AF65-F5344CB8AC3E}">
-        <p14:creationId xmlns:p14="http://schemas.microsoft.com/office/powerpoint/2010/main" val="1780128977"/>
+        <p14:creationId xmlns:p14="http://schemas.microsoft.com/office/powerpoint/2010/main" val="1635322556"/>
       </p:ext>
     </p:extLst>
   </p:cSld>

</xml_diff>

<commit_message>
Align proposal materials with public website observation plan
</commit_message>
<xml_diff>
--- a/deliverables/OnDemand-World-Observatory-Proposal.pptx
+++ b/deliverables/OnDemand-World-Observatory-Proposal.pptx
@@ -2,26 +2,26 @@
 <file path=ppt/presentation.xml><?xml version="1.0" encoding="utf-8"?>
 <p:presentation xmlns:p="http://schemas.openxmlformats.org/presentationml/2006/main">
   <p:sldMasterIdLst>
-    <p:sldMasterId xmlns:r="http://schemas.openxmlformats.org/officeDocument/2006/relationships" id="2147483648" r:id="Rcd9a411546d94d90"/>
+    <p:sldMasterId xmlns:r="http://schemas.openxmlformats.org/officeDocument/2006/relationships" id="2147483648" r:id="R86eae31e4ff447c1"/>
   </p:sldMasterIdLst>
   <p:notesMasterIdLst>
-    <p:notesMasterId xmlns:r="http://schemas.openxmlformats.org/officeDocument/2006/relationships" r:id="R414db99e2d6942ca"/>
+    <p:notesMasterId xmlns:r="http://schemas.openxmlformats.org/officeDocument/2006/relationships" r:id="R7c395df7d7674748"/>
   </p:notesMasterIdLst>
   <p:sldIdLst>
-    <p:sldId xmlns:r="http://schemas.openxmlformats.org/officeDocument/2006/relationships" id="256" r:id="R9a86ca8d40c640a6"/>
-    <p:sldId xmlns:r="http://schemas.openxmlformats.org/officeDocument/2006/relationships" id="257" r:id="Ra6e076d61eec4d16"/>
-    <p:sldId xmlns:r="http://schemas.openxmlformats.org/officeDocument/2006/relationships" id="258" r:id="R800f39eaa55d4638"/>
-    <p:sldId xmlns:r="http://schemas.openxmlformats.org/officeDocument/2006/relationships" id="259" r:id="Rd4afae73dda74888"/>
-    <p:sldId xmlns:r="http://schemas.openxmlformats.org/officeDocument/2006/relationships" id="260" r:id="R96056755c2704aa1"/>
-    <p:sldId xmlns:r="http://schemas.openxmlformats.org/officeDocument/2006/relationships" id="261" r:id="Rd9d79e814f3d4861"/>
-    <p:sldId xmlns:r="http://schemas.openxmlformats.org/officeDocument/2006/relationships" id="262" r:id="R915c7e20a5514e93"/>
-    <p:sldId xmlns:r="http://schemas.openxmlformats.org/officeDocument/2006/relationships" id="263" r:id="R59a9f2dcc0704d0b"/>
-    <p:sldId xmlns:r="http://schemas.openxmlformats.org/officeDocument/2006/relationships" id="264" r:id="R946eeeca8c084517"/>
-    <p:sldId xmlns:r="http://schemas.openxmlformats.org/officeDocument/2006/relationships" id="265" r:id="Rd74b02ac6818434c"/>
-    <p:sldId xmlns:r="http://schemas.openxmlformats.org/officeDocument/2006/relationships" id="266" r:id="Rf3aa32bf7ac44f5b"/>
-    <p:sldId xmlns:r="http://schemas.openxmlformats.org/officeDocument/2006/relationships" id="267" r:id="R4cf56d2cb9864854"/>
-    <p:sldId xmlns:r="http://schemas.openxmlformats.org/officeDocument/2006/relationships" id="268" r:id="Rc0dd566f6cd84295"/>
-    <p:sldId xmlns:r="http://schemas.openxmlformats.org/officeDocument/2006/relationships" id="269" r:id="R49ad7dae8069443e"/>
+    <p:sldId xmlns:r="http://schemas.openxmlformats.org/officeDocument/2006/relationships" id="256" r:id="R8252c2892fd746ce"/>
+    <p:sldId xmlns:r="http://schemas.openxmlformats.org/officeDocument/2006/relationships" id="257" r:id="R057050eda0b24054"/>
+    <p:sldId xmlns:r="http://schemas.openxmlformats.org/officeDocument/2006/relationships" id="258" r:id="R7b1a89d3ca124b34"/>
+    <p:sldId xmlns:r="http://schemas.openxmlformats.org/officeDocument/2006/relationships" id="259" r:id="R0ff843e7733041d1"/>
+    <p:sldId xmlns:r="http://schemas.openxmlformats.org/officeDocument/2006/relationships" id="260" r:id="Rdca856cf9bd64248"/>
+    <p:sldId xmlns:r="http://schemas.openxmlformats.org/officeDocument/2006/relationships" id="261" r:id="Rb90beff016794f1f"/>
+    <p:sldId xmlns:r="http://schemas.openxmlformats.org/officeDocument/2006/relationships" id="262" r:id="R1d716b724a7e47bc"/>
+    <p:sldId xmlns:r="http://schemas.openxmlformats.org/officeDocument/2006/relationships" id="263" r:id="Rc117acd339aa42ae"/>
+    <p:sldId xmlns:r="http://schemas.openxmlformats.org/officeDocument/2006/relationships" id="264" r:id="Rc2ec78cd16e34379"/>
+    <p:sldId xmlns:r="http://schemas.openxmlformats.org/officeDocument/2006/relationships" id="265" r:id="R174dbcaaef44470f"/>
+    <p:sldId xmlns:r="http://schemas.openxmlformats.org/officeDocument/2006/relationships" id="266" r:id="Ra1d5ad474704444b"/>
+    <p:sldId xmlns:r="http://schemas.openxmlformats.org/officeDocument/2006/relationships" id="267" r:id="R7bc1861f8b724aff"/>
+    <p:sldId xmlns:r="http://schemas.openxmlformats.org/officeDocument/2006/relationships" id="268" r:id="R05c9f9d95cf54abc"/>
+    <p:sldId xmlns:r="http://schemas.openxmlformats.org/officeDocument/2006/relationships" id="269" r:id="R9bfcaa12ecf24488"/>
   </p:sldIdLst>
   <p:sldSz cx="12192000" cy="6858000"/>
   <p:notesSz cx="6858000" cy="9144000"/>
@@ -455,7 +455,7 @@
           <a:lstStyle xmlns:a="http://schemas.openxmlformats.org/drawingml/2006/main"/>
           <a:p xmlns:a="http://schemas.openxmlformats.org/drawingml/2006/main">
             <a:r>
-              <a:t>New proposal and interface drafts only. No generated-on-open prototype or hardware result. Team: FlyPig AI. Author credit M.K. Hsu. Product definition from author instruction, 28 Oct 2026. Official track: https://contest.bhuntr.com/tw/39jg9vimiynrhlksze/home/</a:t>
+              <a:t>Stage I project plan for a website observation experience. Team: FlyPig AI. Author credit M.K. Hsu. Product definition from author instruction, 28 Oct 2026. Official track: https://contest.bhuntr.com/tw/39jg9vimiynrhlksze/home/</a:t>
             </a:r>
           </a:p>
         </p:txBody>
@@ -595,7 +595,7 @@
           <a:lstStyle xmlns:a="http://schemas.openxmlformats.org/drawingml/2006/main"/>
           <a:p xmlns:a="http://schemas.openxmlformats.org/drawingml/2006/main">
             <a:r>
-              <a:t>These are proposed test sizes and gates, not completed studies. p50 and p95 latency, memory, energy boundaries, failures and retries to be collected after implementation. No numeric benchmark exists.</a:t>
+              <a:t>Proposed test sizes and acceptance gates for Stage II evaluation. p50 and p95 latency, memory, energy boundaries, failures and retries to be collected after implementation. Metrics would be collected during development.</a:t>
             </a:r>
           </a:p>
         </p:txBody>
@@ -805,7 +805,7 @@
           <a:lstStyle xmlns:a="http://schemas.openxmlformats.org/drawingml/2006/main"/>
           <a:p xmlns:a="http://schemas.openxmlformats.org/drawingml/2006/main">
             <a:r>
-              <a:t>Repository is private and contains proposal materials, not a complete implemented product. Official home https://contest.bhuntr.com/tw/39jg9vimiynrhlksze/home/ and amendment accessed 28 Oct 2026. Full source register: sources/official-source-register.md. Scoring: innovation 30, commercial feasibility 35, practical value 25, storytelling 10. Deadline 28 Oct 17:00 Asia/Taipei. Live form PDF limit 15 MB, video optional discrepancy recorded.</a:t>
+              <a:t>Public repository chosen by the author for proposal review. Stage I materials describe the planned system and development steps. Official home https://contest.bhuntr.com/tw/39jg9vimiynrhlksze/home/ and amendment accessed 28 Oct 2026. Full source register: sources/official-source-register.md. Scoring: innovation 30, commercial feasibility 35, practical value 25, storytelling 10. Deadline 28 Oct 17:00 Asia/Taipei. Live form PDF limit 15 MB, video optional discrepancy recorded.</a:t>
             </a:r>
           </a:p>
         </p:txBody>
@@ -945,7 +945,7 @@
           <a:lstStyle xmlns:a="http://schemas.openxmlformats.org/drawingml/2006/main"/>
           <a:p xmlns:a="http://schemas.openxmlformats.org/drawingml/2006/main">
             <a:r>
-              <a:t>Every opening intends a new request and new clip. This is an episodic video experience. No 3D, 2.5D, WebGL or persistent simulation engine. No implemented flow exists.</a:t>
+              <a:t>Each opening would request a new observation clip using the selected domain and references.</a:t>
             </a:r>
           </a:p>
         </p:txBody>
@@ -1085,7 +1085,7 @@
           <a:lstStyle xmlns:a="http://schemas.openxmlformats.org/drawingml/2006/main"/>
           <a:p xmlns:a="http://schemas.openxmlformats.org/drawingml/2006/main">
             <a:r>
-              <a:t>Example drafted for this proposal, not AI inference output. Reference asset approval is pending. No generation job was executed. See examples/scenario.json and examples/result.json.</a:t>
+              <a:t>Written scenario example for the proposed prompt-planning workflow. See examples/scenario.json and examples/result.json.</a:t>
             </a:r>
           </a:p>
         </p:txBody>
@@ -1155,7 +1155,7 @@
           <a:lstStyle xmlns:a="http://schemas.openxmlformats.org/drawingml/2006/main"/>
           <a:p xmlns:a="http://schemas.openxmlformats.org/drawingml/2006/main">
             <a:r>
-              <a:t>Architecture draft only. Evaluate context interpretation and scenario/prompt construction on UGen300 / Hailo-10H. Host orchestration remains necessary. Do not infer all-local execution or device video capability. Confirm split eligibility with organizer. https://contest.bhuntr.com/tw/39jg9vimiynrhlksze/home/</a:t>
+              <a:t>Evaluate context interpretation and prompt planning on UGen300 / Hailo-10H, coordinated by a host and integrated with a video service. Confirm the final split against track requirements. https://contest.bhuntr.com/tw/39jg9vimiynrhlksze/home/</a:t>
             </a:r>
           </a:p>
         </p:txBody>
@@ -1225,7 +1225,7 @@
           <a:lstStyle xmlns:a="http://schemas.openxmlformats.org/drawingml/2006/main"/>
           <a:p xmlns:a="http://schemas.openxmlformats.org/drawingml/2006/main">
             <a:r>
-              <a:t>Vendor describes Hailo-10H and LLM/VLM model categories. This does not establish workload compatibility. USB page: https://www.asus.com/tw/motherboards-components/ai-accelerator/ugen/ugen300-usb-8g/ accessed 28 Oct 2026. Form warns fixed hardware choice. Stage II requires actual UGen300 operation: https://contest.bhuntr.com/tw/39jg9vimiynrhlksze/home/</a:t>
+              <a:t>Vendor describes Hailo-10H and LLM/VLM model categories. Development will check workload compatibility against supported models. USB page: https://www.asus.com/tw/motherboards-components/ai-accelerator/ugen/ugen300-usb-8g/ accessed 28 Oct 2026. Form warns fixed hardware choice. Stage II requires actual UGen300 operation: https://contest.bhuntr.com/tw/39jg9vimiynrhlksze/home/</a:t>
             </a:r>
           </a:p>
         </p:txBody>
@@ -1295,7 +1295,7 @@
           <a:lstStyle xmlns:a="http://schemas.openxmlformats.org/drawingml/2006/main"/>
           <a:p xmlns:a="http://schemas.openxmlformats.org/drawingml/2006/main">
             <a:r>
-              <a:t>K prior concept: https://k-hunting-log.icareu.tw/journey/ accessed 28 Oct 2026. Agentic-Life-World-Zero / Agentic-Life-World-Studio is another product. Originality attachment includes similar public works by the same author. Written organizer clarification is pending.</a:t>
+              <a:t>K prior concept: https://k-hunting-log.icareu.tw/journey/ accessed 28 Oct 2026. Existing K artwork and footage provide concept references. Planned development covers the observation pipeline and website component. Originality and asset requirements are documented in the rights register.</a:t>
             </a:r>
           </a:p>
         </p:txBody>
@@ -1365,7 +1365,7 @@
           <a:lstStyle xmlns:a="http://schemas.openxmlformats.org/drawingml/2006/main"/>
           <a:p xmlns:a="http://schemas.openxmlformats.org/drawingml/2006/main">
             <a:r>
-              <a:t>The GitHub repository is a proposal and interface-draft repository, not complete prototype source. Contract checks verify internal consistency only. Local concept media uses prior K footage and is excluded from Git.</a:t>
+              <a:t>Planned website component and operator controls. Architecture, interfaces and written examples are available in the public repository.</a:t>
             </a:r>
           </a:p>
         </p:txBody>
@@ -1412,7 +1412,7 @@
           <p:cNvPr id="3" name="Title">
             <a:extLst xmlns:a="http://schemas.openxmlformats.org/drawingml/2006/main">
               <a:ext uri="{FF2B5EF4-FFF2-40B4-BE49-F238E27FC236}">
-                <a16:creationId xmlns:a16="http://schemas.microsoft.com/office/drawing/2014/main" id="{597A1FD8-33D8-4725-B4C4-04F7A966C74A}"/>
+                <a16:creationId xmlns:a16="http://schemas.microsoft.com/office/drawing/2014/main" id="{8933ED26-6369-4122-A935-C2D3B91C555D}"/>
               </a:ext>
             </a:extLst>
           </p:cNvPr>
@@ -1641,7 +1641,7 @@
           <p:cNvPr id="2" name="Subtitle">
             <a:extLst xmlns:a="http://schemas.openxmlformats.org/drawingml/2006/main">
               <a:ext uri="{FF2B5EF4-FFF2-40B4-BE49-F238E27FC236}">
-                <a16:creationId xmlns:a16="http://schemas.microsoft.com/office/drawing/2014/main" id="{8A58E861-8921-4F4D-8B59-5B75E22FAAAA}"/>
+                <a16:creationId xmlns:a16="http://schemas.microsoft.com/office/drawing/2014/main" id="{626AB29F-D63D-42DC-BF0B-A567027A16FD}"/>
               </a:ext>
             </a:extLst>
           </p:cNvPr>
@@ -1887,7 +1887,7 @@
           <p:cNvPr id="2" name="Section title">
             <a:extLst xmlns:a="http://schemas.openxmlformats.org/drawingml/2006/main">
               <a:ext uri="{FF2B5EF4-FFF2-40B4-BE49-F238E27FC236}">
-                <a16:creationId xmlns:a16="http://schemas.microsoft.com/office/drawing/2014/main" id="{9BFF3040-1396-4297-8487-03AD99F49A67}"/>
+                <a16:creationId xmlns:a16="http://schemas.microsoft.com/office/drawing/2014/main" id="{D07F2D0E-2546-4243-8C47-3A530788B65F}"/>
               </a:ext>
             </a:extLst>
           </p:cNvPr>
@@ -2133,7 +2133,7 @@
           <p:cNvPr id="3" name="Title">
             <a:extLst xmlns:a="http://schemas.openxmlformats.org/drawingml/2006/main">
               <a:ext uri="{FF2B5EF4-FFF2-40B4-BE49-F238E27FC236}">
-                <a16:creationId xmlns:a16="http://schemas.microsoft.com/office/drawing/2014/main" id="{C5F15EF0-D549-4181-82F9-D6C59BAE414F}"/>
+                <a16:creationId xmlns:a16="http://schemas.microsoft.com/office/drawing/2014/main" id="{47C8D2F0-541F-470D-9935-500CDB996902}"/>
               </a:ext>
             </a:extLst>
           </p:cNvPr>
@@ -2362,7 +2362,7 @@
           <p:cNvPr id="2" name="Body">
             <a:extLst xmlns:a="http://schemas.openxmlformats.org/drawingml/2006/main">
               <a:ext uri="{FF2B5EF4-FFF2-40B4-BE49-F238E27FC236}">
-                <a16:creationId xmlns:a16="http://schemas.microsoft.com/office/drawing/2014/main" id="{69E7A3C8-68A2-4858-ADEB-CFF3AD4B110F}"/>
+                <a16:creationId xmlns:a16="http://schemas.microsoft.com/office/drawing/2014/main" id="{39FACC39-FFDE-41FE-8C2E-0E8BAC0E82AA}"/>
               </a:ext>
             </a:extLst>
           </p:cNvPr>
@@ -2608,7 +2608,7 @@
           <p:cNvPr id="4" name="Title">
             <a:extLst xmlns:a="http://schemas.openxmlformats.org/drawingml/2006/main">
               <a:ext uri="{FF2B5EF4-FFF2-40B4-BE49-F238E27FC236}">
-                <a16:creationId xmlns:a16="http://schemas.microsoft.com/office/drawing/2014/main" id="{D4101E2A-4BB1-44C4-816D-131089DA0CE6}"/>
+                <a16:creationId xmlns:a16="http://schemas.microsoft.com/office/drawing/2014/main" id="{3FE95E08-E4E0-440E-B8F7-65C69E95D456}"/>
               </a:ext>
             </a:extLst>
           </p:cNvPr>
@@ -2837,7 +2837,7 @@
           <p:cNvPr id="2" name="Left column">
             <a:extLst xmlns:a="http://schemas.openxmlformats.org/drawingml/2006/main">
               <a:ext uri="{FF2B5EF4-FFF2-40B4-BE49-F238E27FC236}">
-                <a16:creationId xmlns:a16="http://schemas.microsoft.com/office/drawing/2014/main" id="{A5F6F9BD-7118-402A-96F2-2225B3EDBE24}"/>
+                <a16:creationId xmlns:a16="http://schemas.microsoft.com/office/drawing/2014/main" id="{BFC787DD-D6D7-42C6-9483-E84316A322DC}"/>
               </a:ext>
             </a:extLst>
           </p:cNvPr>
@@ -3066,7 +3066,7 @@
           <p:cNvPr id="3" name="Right column">
             <a:extLst xmlns:a="http://schemas.openxmlformats.org/drawingml/2006/main">
               <a:ext uri="{FF2B5EF4-FFF2-40B4-BE49-F238E27FC236}">
-                <a16:creationId xmlns:a16="http://schemas.microsoft.com/office/drawing/2014/main" id="{24153F99-38A4-44A4-9E40-94C00F9C7456}"/>
+                <a16:creationId xmlns:a16="http://schemas.microsoft.com/office/drawing/2014/main" id="{E39A7A26-28FF-4F3E-86F9-09401D499ED1}"/>
               </a:ext>
             </a:extLst>
           </p:cNvPr>
@@ -3312,7 +3312,7 @@
           <p:cNvPr id="3" name="Title">
             <a:extLst xmlns:a="http://schemas.openxmlformats.org/drawingml/2006/main">
               <a:ext uri="{FF2B5EF4-FFF2-40B4-BE49-F238E27FC236}">
-                <a16:creationId xmlns:a16="http://schemas.microsoft.com/office/drawing/2014/main" id="{B01B39BC-1E04-4882-92FA-00D7EE0AAE18}"/>
+                <a16:creationId xmlns:a16="http://schemas.microsoft.com/office/drawing/2014/main" id="{CB830CB1-71B1-4469-B2EC-2803FE6AC7BF}"/>
               </a:ext>
             </a:extLst>
           </p:cNvPr>
@@ -3541,7 +3541,7 @@
           <p:cNvPr id="2" name="Left column">
             <a:extLst xmlns:a="http://schemas.openxmlformats.org/drawingml/2006/main">
               <a:ext uri="{FF2B5EF4-FFF2-40B4-BE49-F238E27FC236}">
-                <a16:creationId xmlns:a16="http://schemas.microsoft.com/office/drawing/2014/main" id="{4C1F3E4E-B8A1-4FD7-AF9F-909EBF8A4D35}"/>
+                <a16:creationId xmlns:a16="http://schemas.microsoft.com/office/drawing/2014/main" id="{049D98EC-C838-4A2B-86CF-9A0E215DF861}"/>
               </a:ext>
             </a:extLst>
           </p:cNvPr>
@@ -3808,12 +3808,12 @@
   </p:cSld>
   <p:clrMap bg1="lt1" tx1="dk1" bg2="lt2" tx2="dk2" accent1="accent1" accent2="accent2" accent3="accent3" accent4="accent4" accent5="accent5" accent6="accent6" hlink="hlink" folHlink="folHlink"/>
   <p:sldLayoutIdLst>
-    <p:sldLayoutId xmlns:r="http://schemas.openxmlformats.org/officeDocument/2006/relationships" id="2147483649" r:id="Rd8c3866676d44713"/>
-    <p:sldLayoutId xmlns:r="http://schemas.openxmlformats.org/officeDocument/2006/relationships" id="2147483650" r:id="Raa7f3baa8fe64393"/>
-    <p:sldLayoutId xmlns:r="http://schemas.openxmlformats.org/officeDocument/2006/relationships" id="2147483651" r:id="R31766046f5254d6b"/>
-    <p:sldLayoutId xmlns:r="http://schemas.openxmlformats.org/officeDocument/2006/relationships" id="2147483652" r:id="R449782dc46524f7b"/>
-    <p:sldLayoutId xmlns:r="http://schemas.openxmlformats.org/officeDocument/2006/relationships" id="2147483653" r:id="Rfba53311e49a4f06"/>
-    <p:sldLayoutId xmlns:r="http://schemas.openxmlformats.org/officeDocument/2006/relationships" id="2147483654" r:id="R01e3c14cf04c4bef"/>
+    <p:sldLayoutId xmlns:r="http://schemas.openxmlformats.org/officeDocument/2006/relationships" id="2147483649" r:id="Rc532076953ab420c"/>
+    <p:sldLayoutId xmlns:r="http://schemas.openxmlformats.org/officeDocument/2006/relationships" id="2147483650" r:id="R069a019f27c645fc"/>
+    <p:sldLayoutId xmlns:r="http://schemas.openxmlformats.org/officeDocument/2006/relationships" id="2147483651" r:id="R63176b3809d2494b"/>
+    <p:sldLayoutId xmlns:r="http://schemas.openxmlformats.org/officeDocument/2006/relationships" id="2147483652" r:id="Rf2308b5a158d46bd"/>
+    <p:sldLayoutId xmlns:r="http://schemas.openxmlformats.org/officeDocument/2006/relationships" id="2147483653" r:id="Rbe67c222eb854a79"/>
+    <p:sldLayoutId xmlns:r="http://schemas.openxmlformats.org/officeDocument/2006/relationships" id="2147483654" r:id="R4cf33c1ecc6144b5"/>
   </p:sldLayoutIdLst>
   <p:txStyles>
     <p:titleStyle>
@@ -4364,7 +4364,7 @@
           <p:cNvPr id="13" name="">
             <a:extLst xmlns:a="http://schemas.openxmlformats.org/drawingml/2006/main">
               <a:ext uri="{FF2B5EF4-FFF2-40B4-BE49-F238E27FC236}">
-                <a16:creationId xmlns:a16="http://schemas.microsoft.com/office/drawing/2014/main" id="{E0BF122B-40BB-40CA-86B3-47EAE712415F}"/>
+                <a16:creationId xmlns:a16="http://schemas.microsoft.com/office/drawing/2014/main" id="{D6927FCE-63EE-46F1-9672-94E1C5284BD6}"/>
               </a:ext>
             </a:extLst>
           </p:cNvPr>
@@ -4544,7 +4544,7 @@
           <p:cNvPr id="2" name="">
             <a:extLst xmlns:a="http://schemas.openxmlformats.org/drawingml/2006/main">
               <a:ext uri="{FF2B5EF4-FFF2-40B4-BE49-F238E27FC236}">
-                <a16:creationId xmlns:a16="http://schemas.microsoft.com/office/drawing/2014/main" id="{83EFB94C-4DF6-454A-A031-F92E29543AFC}"/>
+                <a16:creationId xmlns:a16="http://schemas.microsoft.com/office/drawing/2014/main" id="{4D64C3E5-1D2B-4318-9E84-73393E8750A5}"/>
               </a:ext>
             </a:extLst>
           </p:cNvPr>
@@ -4575,7 +4575,7 @@
           <p:cNvPr id="3" name="">
             <a:extLst xmlns:a="http://schemas.openxmlformats.org/drawingml/2006/main">
               <a:ext uri="{FF2B5EF4-FFF2-40B4-BE49-F238E27FC236}">
-                <a16:creationId xmlns:a16="http://schemas.microsoft.com/office/drawing/2014/main" id="{33CAD395-1ED3-4028-AC35-EC4C22F22CA3}"/>
+                <a16:creationId xmlns:a16="http://schemas.microsoft.com/office/drawing/2014/main" id="{DA5BAFEC-F9AB-4552-8CFE-71C2D0670EDD}"/>
               </a:ext>
             </a:extLst>
           </p:cNvPr>
@@ -4722,7 +4722,7 @@
                 <a:ea typeface="Helvetica Neue"/>
                 <a:cs typeface="Helvetica Neue"/>
               </a:rPr>
-              <a:t>STAGE I CONCEPT / NO PRODUCT IMPLEMENTATION</a:t>
+              <a:t>STAGE I / PROJECT PLAN</a:t>
             </a:r>
           </a:p>
         </p:txBody>
@@ -4732,7 +4732,7 @@
           <p:cNvPr id="4" name="">
             <a:extLst xmlns:a="http://schemas.openxmlformats.org/drawingml/2006/main">
               <a:ext uri="{FF2B5EF4-FFF2-40B4-BE49-F238E27FC236}">
-                <a16:creationId xmlns:a16="http://schemas.microsoft.com/office/drawing/2014/main" id="{1411AB15-1F78-4269-8C32-54BEAFCD72E3}"/>
+                <a16:creationId xmlns:a16="http://schemas.microsoft.com/office/drawing/2014/main" id="{1DCDFFEF-D1F1-4906-B387-A8CAB6D03770}"/>
               </a:ext>
             </a:extLst>
           </p:cNvPr>
@@ -4889,7 +4889,7 @@
           <p:cNvPr id="5" name="">
             <a:extLst xmlns:a="http://schemas.openxmlformats.org/drawingml/2006/main">
               <a:ext uri="{FF2B5EF4-FFF2-40B4-BE49-F238E27FC236}">
-                <a16:creationId xmlns:a16="http://schemas.microsoft.com/office/drawing/2014/main" id="{E5B3D4C0-8457-4DAD-8F6C-0A9795FBD10D}"/>
+                <a16:creationId xmlns:a16="http://schemas.microsoft.com/office/drawing/2014/main" id="{F2943109-F5F9-4C9A-B29A-B3465AE1FA2B}"/>
               </a:ext>
             </a:extLst>
           </p:cNvPr>
@@ -5036,7 +5036,7 @@
                 <a:ea typeface="Helvetica Neue"/>
                 <a:cs typeface="Helvetica Neue"/>
               </a:rPr>
-              <a:t>Context-conditioned short video</a:t>
+              <a:t>Realistic, real-time imagery</a:t>
             </a:r>
           </a:p>
           <a:p xmlns:a="http://schemas.openxmlformats.org/drawingml/2006/main">
@@ -5059,7 +5059,7 @@
                 <a:ea typeface="Helvetica Neue"/>
                 <a:cs typeface="Helvetica Neue"/>
               </a:rPr>
-              <a:t>for every observation-page opening</a:t>
+              <a:t>for websites with existing world settings</a:t>
             </a:r>
           </a:p>
         </p:txBody>
@@ -5069,7 +5069,7 @@
           <p:cNvPr id="6" name="">
             <a:extLst xmlns:a="http://schemas.openxmlformats.org/drawingml/2006/main">
               <a:ext uri="{FF2B5EF4-FFF2-40B4-BE49-F238E27FC236}">
-                <a16:creationId xmlns:a16="http://schemas.microsoft.com/office/drawing/2014/main" id="{41863175-FC9D-4541-A477-2E07CE465ADE}"/>
+                <a16:creationId xmlns:a16="http://schemas.microsoft.com/office/drawing/2014/main" id="{9D0598FE-28E9-42A9-B3E4-2C4FE4941A87}"/>
               </a:ext>
             </a:extLst>
           </p:cNvPr>
@@ -5249,7 +5249,7 @@
           <p:cNvPr id="7" name="">
             <a:extLst xmlns:a="http://schemas.openxmlformats.org/drawingml/2006/main">
               <a:ext uri="{FF2B5EF4-FFF2-40B4-BE49-F238E27FC236}">
-                <a16:creationId xmlns:a16="http://schemas.microsoft.com/office/drawing/2014/main" id="{DBED829E-7A82-425D-B8AA-706DAE7F3EB9}"/>
+                <a16:creationId xmlns:a16="http://schemas.microsoft.com/office/drawing/2014/main" id="{6871656C-61D4-4DFB-A7E4-5B398B5EE6BA}"/>
               </a:ext>
             </a:extLst>
           </p:cNvPr>
@@ -5406,7 +5406,7 @@
           <p:cNvPr id="8" name="">
             <a:extLst xmlns:a="http://schemas.openxmlformats.org/drawingml/2006/main">
               <a:ext uri="{FF2B5EF4-FFF2-40B4-BE49-F238E27FC236}">
-                <a16:creationId xmlns:a16="http://schemas.microsoft.com/office/drawing/2014/main" id="{FE55F64E-F6F4-4E0A-8B87-9EF925EB9102}"/>
+                <a16:creationId xmlns:a16="http://schemas.microsoft.com/office/drawing/2014/main" id="{97527426-058E-4EC7-B914-D407575DB942}"/>
               </a:ext>
             </a:extLst>
           </p:cNvPr>
@@ -5437,7 +5437,7 @@
           <p:cNvPr id="9" name="">
             <a:extLst xmlns:a="http://schemas.openxmlformats.org/drawingml/2006/main">
               <a:ext uri="{FF2B5EF4-FFF2-40B4-BE49-F238E27FC236}">
-                <a16:creationId xmlns:a16="http://schemas.microsoft.com/office/drawing/2014/main" id="{B32E1827-6004-4C8D-9DEE-801C50BCE9F4}"/>
+                <a16:creationId xmlns:a16="http://schemas.microsoft.com/office/drawing/2014/main" id="{C7C2FB74-2F3C-4E47-9F90-4CE36A314591}"/>
               </a:ext>
             </a:extLst>
           </p:cNvPr>
@@ -5468,7 +5468,7 @@
           <p:cNvPr id="10" name="">
             <a:extLst xmlns:a="http://schemas.openxmlformats.org/drawingml/2006/main">
               <a:ext uri="{FF2B5EF4-FFF2-40B4-BE49-F238E27FC236}">
-                <a16:creationId xmlns:a16="http://schemas.microsoft.com/office/drawing/2014/main" id="{1FB64EB4-B718-4219-9AE4-B541379270B9}"/>
+                <a16:creationId xmlns:a16="http://schemas.microsoft.com/office/drawing/2014/main" id="{5CB742AC-01BF-460E-A084-91262448B521}"/>
               </a:ext>
             </a:extLst>
           </p:cNvPr>
@@ -5499,7 +5499,7 @@
           <p:cNvPr id="11" name="">
             <a:extLst xmlns:a="http://schemas.openxmlformats.org/drawingml/2006/main">
               <a:ext uri="{FF2B5EF4-FFF2-40B4-BE49-F238E27FC236}">
-                <a16:creationId xmlns:a16="http://schemas.microsoft.com/office/drawing/2014/main" id="{D90F98F9-E189-44E8-AFD6-5A3F958D2116}"/>
+                <a16:creationId xmlns:a16="http://schemas.microsoft.com/office/drawing/2014/main" id="{2051B647-A8FE-42C6-9F52-E8D633B646EF}"/>
               </a:ext>
             </a:extLst>
           </p:cNvPr>
@@ -5530,7 +5530,7 @@
           <p:cNvPr id="12" name="">
             <a:extLst xmlns:a="http://schemas.openxmlformats.org/drawingml/2006/main">
               <a:ext uri="{FF2B5EF4-FFF2-40B4-BE49-F238E27FC236}">
-                <a16:creationId xmlns:a16="http://schemas.microsoft.com/office/drawing/2014/main" id="{E2BE8CE3-3D6B-4505-9CAB-9FEDBA9A2EB4}"/>
+                <a16:creationId xmlns:a16="http://schemas.microsoft.com/office/drawing/2014/main" id="{EDF9E24C-3BDB-4E81-8E45-22B30CD6F8B8}"/>
               </a:ext>
             </a:extLst>
           </p:cNvPr>
@@ -5708,7 +5708,7 @@
     </p:spTree>
     <p:extLst>
       <p:ext uri="{BB962C8B-B14F-4D97-AF65-F5344CB8AC3E}">
-        <p14:creationId xmlns:p14="http://schemas.microsoft.com/office/powerpoint/2010/main" val="1401389185"/>
+        <p14:creationId xmlns:p14="http://schemas.microsoft.com/office/powerpoint/2010/main" val="1726172678"/>
       </p:ext>
     </p:extLst>
   </p:cSld>
@@ -5739,7 +5739,7 @@
           <p:cNvPr id="13" name="">
             <a:extLst xmlns:a="http://schemas.openxmlformats.org/drawingml/2006/main">
               <a:ext uri="{FF2B5EF4-FFF2-40B4-BE49-F238E27FC236}">
-                <a16:creationId xmlns:a16="http://schemas.microsoft.com/office/drawing/2014/main" id="{917BDDA8-216B-4A5F-8442-5117E5F952B9}"/>
+                <a16:creationId xmlns:a16="http://schemas.microsoft.com/office/drawing/2014/main" id="{9D3F8AFB-6967-4EA5-B8A2-461C0D2ADDB9}"/>
               </a:ext>
             </a:extLst>
           </p:cNvPr>
@@ -5896,7 +5896,7 @@
           <p:cNvPr id="2" name="">
             <a:extLst xmlns:a="http://schemas.openxmlformats.org/drawingml/2006/main">
               <a:ext uri="{FF2B5EF4-FFF2-40B4-BE49-F238E27FC236}">
-                <a16:creationId xmlns:a16="http://schemas.microsoft.com/office/drawing/2014/main" id="{A2BB70D5-9E84-4B09-AC5F-9E41F2C3AC1E}"/>
+                <a16:creationId xmlns:a16="http://schemas.microsoft.com/office/drawing/2014/main" id="{16251A46-D398-4630-8EB9-92E2FD085514}"/>
               </a:ext>
             </a:extLst>
           </p:cNvPr>
@@ -5927,7 +5927,7 @@
           <p:cNvPr id="3" name="">
             <a:extLst xmlns:a="http://schemas.openxmlformats.org/drawingml/2006/main">
               <a:ext uri="{FF2B5EF4-FFF2-40B4-BE49-F238E27FC236}">
-                <a16:creationId xmlns:a16="http://schemas.microsoft.com/office/drawing/2014/main" id="{A12B8A1E-54FB-4540-B409-3A2AD29C96E9}"/>
+                <a16:creationId xmlns:a16="http://schemas.microsoft.com/office/drawing/2014/main" id="{7FFBA69D-DD31-4B44-8CCB-45DA52256121}"/>
               </a:ext>
             </a:extLst>
           </p:cNvPr>
@@ -6074,7 +6074,7 @@
                 <a:ea typeface="Helvetica Neue"/>
                 <a:cs typeface="Helvetica Neue"/>
               </a:rPr>
-              <a:t>STAGE I CONCEPT / NO PRODUCT IMPLEMENTATION</a:t>
+              <a:t>STAGE I / PROJECT PLAN</a:t>
             </a:r>
           </a:p>
         </p:txBody>
@@ -6084,7 +6084,7 @@
           <p:cNvPr id="4" name="">
             <a:extLst xmlns:a="http://schemas.openxmlformats.org/drawingml/2006/main">
               <a:ext uri="{FF2B5EF4-FFF2-40B4-BE49-F238E27FC236}">
-                <a16:creationId xmlns:a16="http://schemas.microsoft.com/office/drawing/2014/main" id="{480920B0-53D4-4BE4-96C8-9B4AFF68307C}"/>
+                <a16:creationId xmlns:a16="http://schemas.microsoft.com/office/drawing/2014/main" id="{89125AC5-7D50-47E0-91EA-DD68D99AC879}"/>
               </a:ext>
             </a:extLst>
           </p:cNvPr>
@@ -6241,7 +6241,7 @@
           <p:cNvPr id="5" name="">
             <a:extLst xmlns:a="http://schemas.openxmlformats.org/drawingml/2006/main">
               <a:ext uri="{FF2B5EF4-FFF2-40B4-BE49-F238E27FC236}">
-                <a16:creationId xmlns:a16="http://schemas.microsoft.com/office/drawing/2014/main" id="{58DF88DD-057F-48DE-A455-58079E838005}"/>
+                <a16:creationId xmlns:a16="http://schemas.microsoft.com/office/drawing/2014/main" id="{3D02820A-D9F5-4686-9B82-4CAE40B314BD}"/>
               </a:ext>
             </a:extLst>
           </p:cNvPr>
@@ -6398,7 +6398,7 @@
           <p:cNvPr id="6" name="">
             <a:extLst xmlns:a="http://schemas.openxmlformats.org/drawingml/2006/main">
               <a:ext uri="{FF2B5EF4-FFF2-40B4-BE49-F238E27FC236}">
-                <a16:creationId xmlns:a16="http://schemas.microsoft.com/office/drawing/2014/main" id="{6A2E6D98-DE23-4748-AEFC-B9448EECA5E5}"/>
+                <a16:creationId xmlns:a16="http://schemas.microsoft.com/office/drawing/2014/main" id="{FD2F2B24-74E8-42BA-8B6E-25CC6B565586}"/>
               </a:ext>
             </a:extLst>
           </p:cNvPr>
@@ -6601,7 +6601,7 @@
           <p:cNvPr id="7" name="">
             <a:extLst xmlns:a="http://schemas.openxmlformats.org/drawingml/2006/main">
               <a:ext uri="{FF2B5EF4-FFF2-40B4-BE49-F238E27FC236}">
-                <a16:creationId xmlns:a16="http://schemas.microsoft.com/office/drawing/2014/main" id="{B3931811-2DE1-4897-9284-C40D6EB2368E}"/>
+                <a16:creationId xmlns:a16="http://schemas.microsoft.com/office/drawing/2014/main" id="{8DCE31F4-1F23-4ABD-B713-27788270807C}"/>
               </a:ext>
             </a:extLst>
           </p:cNvPr>
@@ -6758,7 +6758,7 @@
           <p:cNvPr id="8" name="">
             <a:extLst xmlns:a="http://schemas.openxmlformats.org/drawingml/2006/main">
               <a:ext uri="{FF2B5EF4-FFF2-40B4-BE49-F238E27FC236}">
-                <a16:creationId xmlns:a16="http://schemas.microsoft.com/office/drawing/2014/main" id="{39B234F2-6FCB-42B2-9650-FDDF5318A095}"/>
+                <a16:creationId xmlns:a16="http://schemas.microsoft.com/office/drawing/2014/main" id="{F95C3336-42B2-45C8-AEE4-EFC72A1F8F64}"/>
               </a:ext>
             </a:extLst>
           </p:cNvPr>
@@ -6961,7 +6961,7 @@
           <p:cNvPr id="9" name="">
             <a:extLst xmlns:a="http://schemas.openxmlformats.org/drawingml/2006/main">
               <a:ext uri="{FF2B5EF4-FFF2-40B4-BE49-F238E27FC236}">
-                <a16:creationId xmlns:a16="http://schemas.microsoft.com/office/drawing/2014/main" id="{C343A9CB-46F5-4E6A-B80D-778381008462}"/>
+                <a16:creationId xmlns:a16="http://schemas.microsoft.com/office/drawing/2014/main" id="{BD4A769E-3EF6-4073-8BEA-A98749D5C584}"/>
               </a:ext>
             </a:extLst>
           </p:cNvPr>
@@ -7118,7 +7118,7 @@
           <p:cNvPr id="10" name="">
             <a:extLst xmlns:a="http://schemas.openxmlformats.org/drawingml/2006/main">
               <a:ext uri="{FF2B5EF4-FFF2-40B4-BE49-F238E27FC236}">
-                <a16:creationId xmlns:a16="http://schemas.microsoft.com/office/drawing/2014/main" id="{F11C41EF-E76F-45B3-917E-70A51388BE05}"/>
+                <a16:creationId xmlns:a16="http://schemas.microsoft.com/office/drawing/2014/main" id="{70020510-A5F4-4829-8C38-69A07115E8F0}"/>
               </a:ext>
             </a:extLst>
           </p:cNvPr>
@@ -7321,7 +7321,7 @@
           <p:cNvPr id="11" name="">
             <a:extLst xmlns:a="http://schemas.openxmlformats.org/drawingml/2006/main">
               <a:ext uri="{FF2B5EF4-FFF2-40B4-BE49-F238E27FC236}">
-                <a16:creationId xmlns:a16="http://schemas.microsoft.com/office/drawing/2014/main" id="{D524493B-2629-4136-9004-9872B2F60DAA}"/>
+                <a16:creationId xmlns:a16="http://schemas.microsoft.com/office/drawing/2014/main" id="{8D02F808-3448-4325-91EE-005F213A7725}"/>
               </a:ext>
             </a:extLst>
           </p:cNvPr>
@@ -7352,7 +7352,7 @@
           <p:cNvPr id="12" name="">
             <a:extLst xmlns:a="http://schemas.openxmlformats.org/drawingml/2006/main">
               <a:ext uri="{FF2B5EF4-FFF2-40B4-BE49-F238E27FC236}">
-                <a16:creationId xmlns:a16="http://schemas.microsoft.com/office/drawing/2014/main" id="{4F27FDE0-06BA-46E1-BDC5-F3AD7769CE8D}"/>
+                <a16:creationId xmlns:a16="http://schemas.microsoft.com/office/drawing/2014/main" id="{3B618203-2192-4E4A-BD80-90B9BB812FA2}"/>
               </a:ext>
             </a:extLst>
           </p:cNvPr>
@@ -7507,7 +7507,7 @@
     </p:spTree>
     <p:extLst>
       <p:ext uri="{BB962C8B-B14F-4D97-AF65-F5344CB8AC3E}">
-        <p14:creationId xmlns:p14="http://schemas.microsoft.com/office/powerpoint/2010/main" val="1701835291"/>
+        <p14:creationId xmlns:p14="http://schemas.microsoft.com/office/powerpoint/2010/main" val="1539924160"/>
       </p:ext>
     </p:extLst>
   </p:cSld>
@@ -7538,7 +7538,7 @@
           <p:cNvPr id="12" name="">
             <a:extLst xmlns:a="http://schemas.openxmlformats.org/drawingml/2006/main">
               <a:ext uri="{FF2B5EF4-FFF2-40B4-BE49-F238E27FC236}">
-                <a16:creationId xmlns:a16="http://schemas.microsoft.com/office/drawing/2014/main" id="{7E9366AC-8046-4F3D-A20D-FF0C939E370D}"/>
+                <a16:creationId xmlns:a16="http://schemas.microsoft.com/office/drawing/2014/main" id="{0BE9BC21-4A71-491D-86A1-6E141B692CDF}"/>
               </a:ext>
             </a:extLst>
           </p:cNvPr>
@@ -7695,7 +7695,7 @@
           <p:cNvPr id="2" name="">
             <a:extLst xmlns:a="http://schemas.openxmlformats.org/drawingml/2006/main">
               <a:ext uri="{FF2B5EF4-FFF2-40B4-BE49-F238E27FC236}">
-                <a16:creationId xmlns:a16="http://schemas.microsoft.com/office/drawing/2014/main" id="{35413D7F-EC88-45C2-BD7D-8B82B9F83D7C}"/>
+                <a16:creationId xmlns:a16="http://schemas.microsoft.com/office/drawing/2014/main" id="{68FEE309-EDED-46C5-876B-FFEC4B03D227}"/>
               </a:ext>
             </a:extLst>
           </p:cNvPr>
@@ -7726,7 +7726,7 @@
           <p:cNvPr id="3" name="">
             <a:extLst xmlns:a="http://schemas.openxmlformats.org/drawingml/2006/main">
               <a:ext uri="{FF2B5EF4-FFF2-40B4-BE49-F238E27FC236}">
-                <a16:creationId xmlns:a16="http://schemas.microsoft.com/office/drawing/2014/main" id="{0500E34E-034F-47CE-A0B4-582F3E365C66}"/>
+                <a16:creationId xmlns:a16="http://schemas.microsoft.com/office/drawing/2014/main" id="{62113905-AA0D-4B18-897E-650DBFED4074}"/>
               </a:ext>
             </a:extLst>
           </p:cNvPr>
@@ -7873,7 +7873,7 @@
                 <a:ea typeface="Helvetica Neue"/>
                 <a:cs typeface="Helvetica Neue"/>
               </a:rPr>
-              <a:t>STAGE I CONCEPT / NO PRODUCT IMPLEMENTATION</a:t>
+              <a:t>STAGE I / PROJECT PLAN</a:t>
             </a:r>
           </a:p>
         </p:txBody>
@@ -7883,7 +7883,7 @@
           <p:cNvPr id="4" name="">
             <a:extLst xmlns:a="http://schemas.openxmlformats.org/drawingml/2006/main">
               <a:ext uri="{FF2B5EF4-FFF2-40B4-BE49-F238E27FC236}">
-                <a16:creationId xmlns:a16="http://schemas.microsoft.com/office/drawing/2014/main" id="{AF86D5DD-1848-496E-8AA5-1579775571C1}"/>
+                <a16:creationId xmlns:a16="http://schemas.microsoft.com/office/drawing/2014/main" id="{F63EE3C2-CFC1-4C9F-8AD2-B2C48DAF8AB6}"/>
               </a:ext>
             </a:extLst>
           </p:cNvPr>
@@ -8040,7 +8040,7 @@
           <p:cNvPr id="5" name="">
             <a:extLst xmlns:a="http://schemas.openxmlformats.org/drawingml/2006/main">
               <a:ext uri="{FF2B5EF4-FFF2-40B4-BE49-F238E27FC236}">
-                <a16:creationId xmlns:a16="http://schemas.microsoft.com/office/drawing/2014/main" id="{4A6F6BAB-98C3-408E-B307-FBF0ECBC57C0}"/>
+                <a16:creationId xmlns:a16="http://schemas.microsoft.com/office/drawing/2014/main" id="{8A33B56A-FAE1-4216-9E31-E5A866251C30}"/>
               </a:ext>
             </a:extLst>
           </p:cNvPr>
@@ -8197,7 +8197,7 @@
           <p:cNvPr id="6" name="">
             <a:extLst xmlns:a="http://schemas.openxmlformats.org/drawingml/2006/main">
               <a:ext uri="{FF2B5EF4-FFF2-40B4-BE49-F238E27FC236}">
-                <a16:creationId xmlns:a16="http://schemas.microsoft.com/office/drawing/2014/main" id="{70C42880-7176-4067-8D2B-9068B1FAAAAA}"/>
+                <a16:creationId xmlns:a16="http://schemas.microsoft.com/office/drawing/2014/main" id="{776E789A-4D6C-4245-B8A5-AC95E571B031}"/>
               </a:ext>
             </a:extLst>
           </p:cNvPr>
@@ -8354,7 +8354,7 @@
           <p:cNvPr id="7" name="">
             <a:extLst xmlns:a="http://schemas.openxmlformats.org/drawingml/2006/main">
               <a:ext uri="{FF2B5EF4-FFF2-40B4-BE49-F238E27FC236}">
-                <a16:creationId xmlns:a16="http://schemas.microsoft.com/office/drawing/2014/main" id="{88953821-2EA2-4546-85A5-AEB997F3F436}"/>
+                <a16:creationId xmlns:a16="http://schemas.microsoft.com/office/drawing/2014/main" id="{3617D95F-6AA0-42A4-9222-33ED96A6D64E}"/>
               </a:ext>
             </a:extLst>
           </p:cNvPr>
@@ -8511,7 +8511,7 @@
           <p:cNvPr id="8" name="">
             <a:extLst xmlns:a="http://schemas.openxmlformats.org/drawingml/2006/main">
               <a:ext uri="{FF2B5EF4-FFF2-40B4-BE49-F238E27FC236}">
-                <a16:creationId xmlns:a16="http://schemas.microsoft.com/office/drawing/2014/main" id="{573A8525-417D-4103-ACC9-39CB9AD6D8FE}"/>
+                <a16:creationId xmlns:a16="http://schemas.microsoft.com/office/drawing/2014/main" id="{D2ED7DDF-60A4-4793-A076-063A6B02E86A}"/>
               </a:ext>
             </a:extLst>
           </p:cNvPr>
@@ -8668,7 +8668,7 @@
           <p:cNvPr id="9" name="">
             <a:extLst xmlns:a="http://schemas.openxmlformats.org/drawingml/2006/main">
               <a:ext uri="{FF2B5EF4-FFF2-40B4-BE49-F238E27FC236}">
-                <a16:creationId xmlns:a16="http://schemas.microsoft.com/office/drawing/2014/main" id="{357649D5-E360-406F-8C85-EE543E201990}"/>
+                <a16:creationId xmlns:a16="http://schemas.microsoft.com/office/drawing/2014/main" id="{4CAE9E05-9C80-48C3-B4FD-380052C107BF}"/>
               </a:ext>
             </a:extLst>
           </p:cNvPr>
@@ -8825,7 +8825,7 @@
           <p:cNvPr id="10" name="">
             <a:extLst xmlns:a="http://schemas.openxmlformats.org/drawingml/2006/main">
               <a:ext uri="{FF2B5EF4-FFF2-40B4-BE49-F238E27FC236}">
-                <a16:creationId xmlns:a16="http://schemas.microsoft.com/office/drawing/2014/main" id="{D770FBDC-C940-42F5-8D0E-2E25C1380079}"/>
+                <a16:creationId xmlns:a16="http://schemas.microsoft.com/office/drawing/2014/main" id="{C99DFA62-5F64-499A-B800-B6796ABB241D}"/>
               </a:ext>
             </a:extLst>
           </p:cNvPr>
@@ -8982,7 +8982,7 @@
           <p:cNvPr id="11" name="">
             <a:extLst xmlns:a="http://schemas.openxmlformats.org/drawingml/2006/main">
               <a:ext uri="{FF2B5EF4-FFF2-40B4-BE49-F238E27FC236}">
-                <a16:creationId xmlns:a16="http://schemas.microsoft.com/office/drawing/2014/main" id="{F6C61562-537E-4A26-8DA0-883865E08432}"/>
+                <a16:creationId xmlns:a16="http://schemas.microsoft.com/office/drawing/2014/main" id="{C83E4103-1825-48E7-B498-0DC9743AAEA3}"/>
               </a:ext>
             </a:extLst>
           </p:cNvPr>
@@ -9137,7 +9137,7 @@
     </p:spTree>
     <p:extLst>
       <p:ext uri="{BB962C8B-B14F-4D97-AF65-F5344CB8AC3E}">
-        <p14:creationId xmlns:p14="http://schemas.microsoft.com/office/powerpoint/2010/main" val="1212128919"/>
+        <p14:creationId xmlns:p14="http://schemas.microsoft.com/office/powerpoint/2010/main" val="1421481448"/>
       </p:ext>
     </p:extLst>
   </p:cSld>
@@ -9168,7 +9168,7 @@
           <p:cNvPr id="16" name="">
             <a:extLst xmlns:a="http://schemas.openxmlformats.org/drawingml/2006/main">
               <a:ext uri="{FF2B5EF4-FFF2-40B4-BE49-F238E27FC236}">
-                <a16:creationId xmlns:a16="http://schemas.microsoft.com/office/drawing/2014/main" id="{A345DECE-6C12-43B8-A1F9-0C71B9328C0C}"/>
+                <a16:creationId xmlns:a16="http://schemas.microsoft.com/office/drawing/2014/main" id="{CF48D4F1-E7C7-41A7-B35D-E83D828D555C}"/>
               </a:ext>
             </a:extLst>
           </p:cNvPr>
@@ -9325,7 +9325,7 @@
           <p:cNvPr id="2" name="">
             <a:extLst xmlns:a="http://schemas.openxmlformats.org/drawingml/2006/main">
               <a:ext uri="{FF2B5EF4-FFF2-40B4-BE49-F238E27FC236}">
-                <a16:creationId xmlns:a16="http://schemas.microsoft.com/office/drawing/2014/main" id="{71D753B9-5261-4A3F-9425-44DD4B04C0E2}"/>
+                <a16:creationId xmlns:a16="http://schemas.microsoft.com/office/drawing/2014/main" id="{2B684ABA-7204-40BA-A4D5-55F0B75B74B4}"/>
               </a:ext>
             </a:extLst>
           </p:cNvPr>
@@ -9356,7 +9356,7 @@
           <p:cNvPr id="3" name="">
             <a:extLst xmlns:a="http://schemas.openxmlformats.org/drawingml/2006/main">
               <a:ext uri="{FF2B5EF4-FFF2-40B4-BE49-F238E27FC236}">
-                <a16:creationId xmlns:a16="http://schemas.microsoft.com/office/drawing/2014/main" id="{AA19963B-86F5-4C9B-8843-3BD1C0D5BE3C}"/>
+                <a16:creationId xmlns:a16="http://schemas.microsoft.com/office/drawing/2014/main" id="{E3C923B4-34D7-4196-BC15-C98B50AC423F}"/>
               </a:ext>
             </a:extLst>
           </p:cNvPr>
@@ -9503,7 +9503,7 @@
                 <a:ea typeface="Helvetica Neue"/>
                 <a:cs typeface="Helvetica Neue"/>
               </a:rPr>
-              <a:t>STAGE I CONCEPT / NO PRODUCT IMPLEMENTATION</a:t>
+              <a:t>STAGE I / PROJECT PLAN</a:t>
             </a:r>
           </a:p>
         </p:txBody>
@@ -9513,7 +9513,7 @@
           <p:cNvPr id="4" name="">
             <a:extLst xmlns:a="http://schemas.openxmlformats.org/drawingml/2006/main">
               <a:ext uri="{FF2B5EF4-FFF2-40B4-BE49-F238E27FC236}">
-                <a16:creationId xmlns:a16="http://schemas.microsoft.com/office/drawing/2014/main" id="{247A90DE-45E5-44DE-A64D-BB5B52441305}"/>
+                <a16:creationId xmlns:a16="http://schemas.microsoft.com/office/drawing/2014/main" id="{2907A1F7-F3F4-45C0-AFEA-EF081DB07D29}"/>
               </a:ext>
             </a:extLst>
           </p:cNvPr>
@@ -9670,7 +9670,7 @@
           <p:cNvPr id="5" name="">
             <a:extLst xmlns:a="http://schemas.openxmlformats.org/drawingml/2006/main">
               <a:ext uri="{FF2B5EF4-FFF2-40B4-BE49-F238E27FC236}">
-                <a16:creationId xmlns:a16="http://schemas.microsoft.com/office/drawing/2014/main" id="{21535CC9-E783-4264-BE8B-0A113F073F96}"/>
+                <a16:creationId xmlns:a16="http://schemas.microsoft.com/office/drawing/2014/main" id="{34315003-F934-4C3E-8459-574A9B94F2AF}"/>
               </a:ext>
             </a:extLst>
           </p:cNvPr>
@@ -9827,7 +9827,7 @@
           <p:cNvPr id="6" name="">
             <a:extLst xmlns:a="http://schemas.openxmlformats.org/drawingml/2006/main">
               <a:ext uri="{FF2B5EF4-FFF2-40B4-BE49-F238E27FC236}">
-                <a16:creationId xmlns:a16="http://schemas.microsoft.com/office/drawing/2014/main" id="{AE59A9EF-7A37-4B3A-8DD4-D8E45AD649F6}"/>
+                <a16:creationId xmlns:a16="http://schemas.microsoft.com/office/drawing/2014/main" id="{6E887EC7-D1B1-4A51-8A7E-5F2B8E2555D8}"/>
               </a:ext>
             </a:extLst>
           </p:cNvPr>
@@ -10007,7 +10007,7 @@
           <p:cNvPr id="7" name="">
             <a:extLst xmlns:a="http://schemas.openxmlformats.org/drawingml/2006/main">
               <a:ext uri="{FF2B5EF4-FFF2-40B4-BE49-F238E27FC236}">
-                <a16:creationId xmlns:a16="http://schemas.microsoft.com/office/drawing/2014/main" id="{74A61201-CCFF-48DA-BC00-245EA0829148}"/>
+                <a16:creationId xmlns:a16="http://schemas.microsoft.com/office/drawing/2014/main" id="{4530D0DA-F031-4D48-B5BE-9BDFCCEFF5DD}"/>
               </a:ext>
             </a:extLst>
           </p:cNvPr>
@@ -10038,7 +10038,7 @@
           <p:cNvPr id="8" name="">
             <a:extLst xmlns:a="http://schemas.openxmlformats.org/drawingml/2006/main">
               <a:ext uri="{FF2B5EF4-FFF2-40B4-BE49-F238E27FC236}">
-                <a16:creationId xmlns:a16="http://schemas.microsoft.com/office/drawing/2014/main" id="{BA18973C-A96B-40D5-9618-00EC4D55D9A3}"/>
+                <a16:creationId xmlns:a16="http://schemas.microsoft.com/office/drawing/2014/main" id="{FACE35AE-945F-4690-85FA-6BC81FC213CA}"/>
               </a:ext>
             </a:extLst>
           </p:cNvPr>
@@ -10195,7 +10195,7 @@
           <p:cNvPr id="9" name="">
             <a:extLst xmlns:a="http://schemas.openxmlformats.org/drawingml/2006/main">
               <a:ext uri="{FF2B5EF4-FFF2-40B4-BE49-F238E27FC236}">
-                <a16:creationId xmlns:a16="http://schemas.microsoft.com/office/drawing/2014/main" id="{A67146B5-D0E0-4A13-86E4-9173B966EF83}"/>
+                <a16:creationId xmlns:a16="http://schemas.microsoft.com/office/drawing/2014/main" id="{9007FA87-3551-4709-8D00-2B3C8CAABA9D}"/>
               </a:ext>
             </a:extLst>
           </p:cNvPr>
@@ -10375,7 +10375,7 @@
           <p:cNvPr id="10" name="">
             <a:extLst xmlns:a="http://schemas.openxmlformats.org/drawingml/2006/main">
               <a:ext uri="{FF2B5EF4-FFF2-40B4-BE49-F238E27FC236}">
-                <a16:creationId xmlns:a16="http://schemas.microsoft.com/office/drawing/2014/main" id="{8F33D30A-1761-4DCD-9CBB-86D6EC9781B5}"/>
+                <a16:creationId xmlns:a16="http://schemas.microsoft.com/office/drawing/2014/main" id="{735A837F-DD5A-43CC-B343-9C3203D6404B}"/>
               </a:ext>
             </a:extLst>
           </p:cNvPr>
@@ -10406,7 +10406,7 @@
           <p:cNvPr id="11" name="">
             <a:extLst xmlns:a="http://schemas.openxmlformats.org/drawingml/2006/main">
               <a:ext uri="{FF2B5EF4-FFF2-40B4-BE49-F238E27FC236}">
-                <a16:creationId xmlns:a16="http://schemas.microsoft.com/office/drawing/2014/main" id="{78A0E4D1-B6EA-412F-A8E1-CA340BC00E9F}"/>
+                <a16:creationId xmlns:a16="http://schemas.microsoft.com/office/drawing/2014/main" id="{749CFABB-5003-40F3-B11B-3AA0F6544670}"/>
               </a:ext>
             </a:extLst>
           </p:cNvPr>
@@ -10563,7 +10563,7 @@
           <p:cNvPr id="12" name="">
             <a:extLst xmlns:a="http://schemas.openxmlformats.org/drawingml/2006/main">
               <a:ext uri="{FF2B5EF4-FFF2-40B4-BE49-F238E27FC236}">
-                <a16:creationId xmlns:a16="http://schemas.microsoft.com/office/drawing/2014/main" id="{41F3D74C-79FD-42F1-B1D1-498519518BC0}"/>
+                <a16:creationId xmlns:a16="http://schemas.microsoft.com/office/drawing/2014/main" id="{6D628894-CFD6-498B-946D-76AE54496369}"/>
               </a:ext>
             </a:extLst>
           </p:cNvPr>
@@ -10743,7 +10743,7 @@
           <p:cNvPr id="13" name="">
             <a:extLst xmlns:a="http://schemas.openxmlformats.org/drawingml/2006/main">
               <a:ext uri="{FF2B5EF4-FFF2-40B4-BE49-F238E27FC236}">
-                <a16:creationId xmlns:a16="http://schemas.microsoft.com/office/drawing/2014/main" id="{E29EEFA1-9624-49D9-8CE5-655BBE36BE41}"/>
+                <a16:creationId xmlns:a16="http://schemas.microsoft.com/office/drawing/2014/main" id="{4AF95F15-2E13-4C66-8F34-F98D5CF32F7A}"/>
               </a:ext>
             </a:extLst>
           </p:cNvPr>
@@ -10774,7 +10774,7 @@
           <p:cNvPr id="14" name="">
             <a:extLst xmlns:a="http://schemas.openxmlformats.org/drawingml/2006/main">
               <a:ext uri="{FF2B5EF4-FFF2-40B4-BE49-F238E27FC236}">
-                <a16:creationId xmlns:a16="http://schemas.microsoft.com/office/drawing/2014/main" id="{51F0B5DD-DC96-4001-9FF8-108F364DE214}"/>
+                <a16:creationId xmlns:a16="http://schemas.microsoft.com/office/drawing/2014/main" id="{7A5BF491-6093-4AEB-8AE2-478FBCAD7F54}"/>
               </a:ext>
             </a:extLst>
           </p:cNvPr>
@@ -10931,7 +10931,7 @@
           <p:cNvPr id="15" name="">
             <a:extLst xmlns:a="http://schemas.openxmlformats.org/drawingml/2006/main">
               <a:ext uri="{FF2B5EF4-FFF2-40B4-BE49-F238E27FC236}">
-                <a16:creationId xmlns:a16="http://schemas.microsoft.com/office/drawing/2014/main" id="{4B54DB74-730E-4319-98EE-49ED1D0B7402}"/>
+                <a16:creationId xmlns:a16="http://schemas.microsoft.com/office/drawing/2014/main" id="{9D4668F6-BECD-4190-B58E-B40F678B1085}"/>
               </a:ext>
             </a:extLst>
           </p:cNvPr>
@@ -11109,7 +11109,7 @@
     </p:spTree>
     <p:extLst>
       <p:ext uri="{BB962C8B-B14F-4D97-AF65-F5344CB8AC3E}">
-        <p14:creationId xmlns:p14="http://schemas.microsoft.com/office/powerpoint/2010/main" val="251734852"/>
+        <p14:creationId xmlns:p14="http://schemas.microsoft.com/office/powerpoint/2010/main" val="1349920189"/>
       </p:ext>
     </p:extLst>
   </p:cSld>
@@ -11140,7 +11140,7 @@
           <p:cNvPr id="14" name="">
             <a:extLst xmlns:a="http://schemas.openxmlformats.org/drawingml/2006/main">
               <a:ext uri="{FF2B5EF4-FFF2-40B4-BE49-F238E27FC236}">
-                <a16:creationId xmlns:a16="http://schemas.microsoft.com/office/drawing/2014/main" id="{B6DE9CAD-C311-4FE1-A7CB-BA656F16A66D}"/>
+                <a16:creationId xmlns:a16="http://schemas.microsoft.com/office/drawing/2014/main" id="{1422BC00-D765-4D30-9785-BBE20AA7B7DB}"/>
               </a:ext>
             </a:extLst>
           </p:cNvPr>
@@ -11297,7 +11297,7 @@
           <p:cNvPr id="2" name="">
             <a:extLst xmlns:a="http://schemas.openxmlformats.org/drawingml/2006/main">
               <a:ext uri="{FF2B5EF4-FFF2-40B4-BE49-F238E27FC236}">
-                <a16:creationId xmlns:a16="http://schemas.microsoft.com/office/drawing/2014/main" id="{A66C4B8D-B89A-4D7D-8FDD-4B4D9B882C16}"/>
+                <a16:creationId xmlns:a16="http://schemas.microsoft.com/office/drawing/2014/main" id="{6ED2D878-AFBF-4822-965E-AE4ED4B4BEC8}"/>
               </a:ext>
             </a:extLst>
           </p:cNvPr>
@@ -11328,7 +11328,7 @@
           <p:cNvPr id="3" name="">
             <a:extLst xmlns:a="http://schemas.openxmlformats.org/drawingml/2006/main">
               <a:ext uri="{FF2B5EF4-FFF2-40B4-BE49-F238E27FC236}">
-                <a16:creationId xmlns:a16="http://schemas.microsoft.com/office/drawing/2014/main" id="{15815D5E-76FA-4F61-96D6-D86E34CD0D30}"/>
+                <a16:creationId xmlns:a16="http://schemas.microsoft.com/office/drawing/2014/main" id="{A867A98F-2A62-4F9E-8559-ADF4B1459987}"/>
               </a:ext>
             </a:extLst>
           </p:cNvPr>
@@ -11475,7 +11475,7 @@
                 <a:ea typeface="Helvetica Neue"/>
                 <a:cs typeface="Helvetica Neue"/>
               </a:rPr>
-              <a:t>STAGE I CONCEPT / NO PRODUCT IMPLEMENTATION</a:t>
+              <a:t>STAGE I / PROJECT PLAN</a:t>
             </a:r>
           </a:p>
         </p:txBody>
@@ -11485,7 +11485,7 @@
           <p:cNvPr id="4" name="">
             <a:extLst xmlns:a="http://schemas.openxmlformats.org/drawingml/2006/main">
               <a:ext uri="{FF2B5EF4-FFF2-40B4-BE49-F238E27FC236}">
-                <a16:creationId xmlns:a16="http://schemas.microsoft.com/office/drawing/2014/main" id="{7817E256-6B27-4824-9233-1B4D80EE1AD4}"/>
+                <a16:creationId xmlns:a16="http://schemas.microsoft.com/office/drawing/2014/main" id="{3A5C5875-55E9-48E4-BA2E-EF0EBDDAAD3C}"/>
               </a:ext>
             </a:extLst>
           </p:cNvPr>
@@ -11642,7 +11642,7 @@
           <p:cNvPr id="5" name="">
             <a:extLst xmlns:a="http://schemas.openxmlformats.org/drawingml/2006/main">
               <a:ext uri="{FF2B5EF4-FFF2-40B4-BE49-F238E27FC236}">
-                <a16:creationId xmlns:a16="http://schemas.microsoft.com/office/drawing/2014/main" id="{1C1E0A36-625C-480F-8C1C-1CA8571E2BF0}"/>
+                <a16:creationId xmlns:a16="http://schemas.microsoft.com/office/drawing/2014/main" id="{257FAA17-BBE0-446B-B53D-023BEA369BC3}"/>
               </a:ext>
             </a:extLst>
           </p:cNvPr>
@@ -11799,7 +11799,7 @@
           <p:cNvPr id="6" name="">
             <a:extLst xmlns:a="http://schemas.openxmlformats.org/drawingml/2006/main">
               <a:ext uri="{FF2B5EF4-FFF2-40B4-BE49-F238E27FC236}">
-                <a16:creationId xmlns:a16="http://schemas.microsoft.com/office/drawing/2014/main" id="{9796042C-58DE-4B42-A9EB-39B7530AB96E}"/>
+                <a16:creationId xmlns:a16="http://schemas.microsoft.com/office/drawing/2014/main" id="{26F50370-0B8A-43DB-9319-32B1860CD8D3}"/>
               </a:ext>
             </a:extLst>
           </p:cNvPr>
@@ -11956,7 +11956,7 @@
           <p:cNvPr id="7" name="">
             <a:extLst xmlns:a="http://schemas.openxmlformats.org/drawingml/2006/main">
               <a:ext uri="{FF2B5EF4-FFF2-40B4-BE49-F238E27FC236}">
-                <a16:creationId xmlns:a16="http://schemas.microsoft.com/office/drawing/2014/main" id="{402FFB5C-36C1-4891-B6DC-E8D791FEDB34}"/>
+                <a16:creationId xmlns:a16="http://schemas.microsoft.com/office/drawing/2014/main" id="{F148DD17-067F-4D3C-98AC-4826BEF6F360}"/>
               </a:ext>
             </a:extLst>
           </p:cNvPr>
@@ -12113,7 +12113,7 @@
           <p:cNvPr id="8" name="">
             <a:extLst xmlns:a="http://schemas.openxmlformats.org/drawingml/2006/main">
               <a:ext uri="{FF2B5EF4-FFF2-40B4-BE49-F238E27FC236}">
-                <a16:creationId xmlns:a16="http://schemas.microsoft.com/office/drawing/2014/main" id="{D2F1126B-FF04-4616-951F-4219486F9AEF}"/>
+                <a16:creationId xmlns:a16="http://schemas.microsoft.com/office/drawing/2014/main" id="{77FB9768-634C-48B0-AAA9-E468F889BFFE}"/>
               </a:ext>
             </a:extLst>
           </p:cNvPr>
@@ -12270,7 +12270,7 @@
           <p:cNvPr id="9" name="">
             <a:extLst xmlns:a="http://schemas.openxmlformats.org/drawingml/2006/main">
               <a:ext uri="{FF2B5EF4-FFF2-40B4-BE49-F238E27FC236}">
-                <a16:creationId xmlns:a16="http://schemas.microsoft.com/office/drawing/2014/main" id="{688CE444-CA16-4AFA-A1F1-37917B975B5C}"/>
+                <a16:creationId xmlns:a16="http://schemas.microsoft.com/office/drawing/2014/main" id="{AF595494-0C6F-49A0-ACF9-B26479F5A517}"/>
               </a:ext>
             </a:extLst>
           </p:cNvPr>
@@ -12427,7 +12427,7 @@
           <p:cNvPr id="10" name="">
             <a:extLst xmlns:a="http://schemas.openxmlformats.org/drawingml/2006/main">
               <a:ext uri="{FF2B5EF4-FFF2-40B4-BE49-F238E27FC236}">
-                <a16:creationId xmlns:a16="http://schemas.microsoft.com/office/drawing/2014/main" id="{71B4D528-2C9F-4B9A-8230-66FC5AD0F29C}"/>
+                <a16:creationId xmlns:a16="http://schemas.microsoft.com/office/drawing/2014/main" id="{1C2A1793-EB47-43E5-AC36-0C94D76CA068}"/>
               </a:ext>
             </a:extLst>
           </p:cNvPr>
@@ -12584,7 +12584,7 @@
           <p:cNvPr id="11" name="">
             <a:extLst xmlns:a="http://schemas.openxmlformats.org/drawingml/2006/main">
               <a:ext uri="{FF2B5EF4-FFF2-40B4-BE49-F238E27FC236}">
-                <a16:creationId xmlns:a16="http://schemas.microsoft.com/office/drawing/2014/main" id="{AFDF63A7-0F47-47A2-8A6B-B10DC0B22661}"/>
+                <a16:creationId xmlns:a16="http://schemas.microsoft.com/office/drawing/2014/main" id="{F0DA6AF5-078A-4E64-AF42-71D28E62D28A}"/>
               </a:ext>
             </a:extLst>
           </p:cNvPr>
@@ -12741,7 +12741,7 @@
           <p:cNvPr id="12" name="">
             <a:extLst xmlns:a="http://schemas.openxmlformats.org/drawingml/2006/main">
               <a:ext uri="{FF2B5EF4-FFF2-40B4-BE49-F238E27FC236}">
-                <a16:creationId xmlns:a16="http://schemas.microsoft.com/office/drawing/2014/main" id="{59EEA3CA-4905-46F6-8977-1E1804A96993}"/>
+                <a16:creationId xmlns:a16="http://schemas.microsoft.com/office/drawing/2014/main" id="{91B602A3-527B-4F62-A5DA-9CE1C5A830C5}"/>
               </a:ext>
             </a:extLst>
           </p:cNvPr>
@@ -12898,7 +12898,7 @@
           <p:cNvPr id="13" name="">
             <a:extLst xmlns:a="http://schemas.openxmlformats.org/drawingml/2006/main">
               <a:ext uri="{FF2B5EF4-FFF2-40B4-BE49-F238E27FC236}">
-                <a16:creationId xmlns:a16="http://schemas.microsoft.com/office/drawing/2014/main" id="{4AB60343-B310-45AD-B1E6-8146B925365E}"/>
+                <a16:creationId xmlns:a16="http://schemas.microsoft.com/office/drawing/2014/main" id="{DA976AA4-B5C0-4B8E-90B1-8D6A60C4A50A}"/>
               </a:ext>
             </a:extLst>
           </p:cNvPr>
@@ -13053,7 +13053,7 @@
     </p:spTree>
     <p:extLst>
       <p:ext uri="{BB962C8B-B14F-4D97-AF65-F5344CB8AC3E}">
-        <p14:creationId xmlns:p14="http://schemas.microsoft.com/office/powerpoint/2010/main" val="1958835815"/>
+        <p14:creationId xmlns:p14="http://schemas.microsoft.com/office/powerpoint/2010/main" val="1582431668"/>
       </p:ext>
     </p:extLst>
   </p:cSld>
@@ -13084,7 +13084,7 @@
           <p:cNvPr id="11" name="">
             <a:extLst xmlns:a="http://schemas.openxmlformats.org/drawingml/2006/main">
               <a:ext uri="{FF2B5EF4-FFF2-40B4-BE49-F238E27FC236}">
-                <a16:creationId xmlns:a16="http://schemas.microsoft.com/office/drawing/2014/main" id="{02EE62D6-F2DA-46D4-BC55-451D44A83836}"/>
+                <a16:creationId xmlns:a16="http://schemas.microsoft.com/office/drawing/2014/main" id="{7CC76A45-0FE9-4BB8-8562-BDD3217B04D9}"/>
               </a:ext>
             </a:extLst>
           </p:cNvPr>
@@ -13231,7 +13231,7 @@
                 <a:ea typeface="Helvetica Neue"/>
                 <a:cs typeface="Helvetica Neue"/>
               </a:rPr>
-              <a:t>Stage I review package and next steps</a:t>
+              <a:t>Development plan and project resources</a:t>
             </a:r>
           </a:p>
         </p:txBody>
@@ -13241,7 +13241,7 @@
           <p:cNvPr id="2" name="">
             <a:extLst xmlns:a="http://schemas.openxmlformats.org/drawingml/2006/main">
               <a:ext uri="{FF2B5EF4-FFF2-40B4-BE49-F238E27FC236}">
-                <a16:creationId xmlns:a16="http://schemas.microsoft.com/office/drawing/2014/main" id="{6498013B-0049-494D-AB7C-D1287B332904}"/>
+                <a16:creationId xmlns:a16="http://schemas.microsoft.com/office/drawing/2014/main" id="{217F75E1-64DE-4236-B2CC-F1B9A85631E7}"/>
               </a:ext>
             </a:extLst>
           </p:cNvPr>
@@ -13272,7 +13272,7 @@
           <p:cNvPr id="3" name="">
             <a:extLst xmlns:a="http://schemas.openxmlformats.org/drawingml/2006/main">
               <a:ext uri="{FF2B5EF4-FFF2-40B4-BE49-F238E27FC236}">
-                <a16:creationId xmlns:a16="http://schemas.microsoft.com/office/drawing/2014/main" id="{67E66CD8-13DB-478C-A6C1-4459743B5632}"/>
+                <a16:creationId xmlns:a16="http://schemas.microsoft.com/office/drawing/2014/main" id="{BB0E9B79-3E14-40AB-9491-23A4461BD013}"/>
               </a:ext>
             </a:extLst>
           </p:cNvPr>
@@ -13419,7 +13419,7 @@
                 <a:ea typeface="Helvetica Neue"/>
                 <a:cs typeface="Helvetica Neue"/>
               </a:rPr>
-              <a:t>STAGE I CONCEPT / NO PRODUCT IMPLEMENTATION</a:t>
+              <a:t>STAGE I / PROJECT PLAN</a:t>
             </a:r>
           </a:p>
         </p:txBody>
@@ -13429,7 +13429,7 @@
           <p:cNvPr id="4" name="">
             <a:extLst xmlns:a="http://schemas.openxmlformats.org/drawingml/2006/main">
               <a:ext uri="{FF2B5EF4-FFF2-40B4-BE49-F238E27FC236}">
-                <a16:creationId xmlns:a16="http://schemas.microsoft.com/office/drawing/2014/main" id="{4783FC6D-EF4C-45E4-BDA1-7C6F057D3552}"/>
+                <a16:creationId xmlns:a16="http://schemas.microsoft.com/office/drawing/2014/main" id="{4E50409F-81D7-4454-B98E-F58B80CC70C2}"/>
               </a:ext>
             </a:extLst>
           </p:cNvPr>
@@ -13586,7 +13586,7 @@
           <p:cNvPr id="5" name="">
             <a:extLst xmlns:a="http://schemas.openxmlformats.org/drawingml/2006/main">
               <a:ext uri="{FF2B5EF4-FFF2-40B4-BE49-F238E27FC236}">
-                <a16:creationId xmlns:a16="http://schemas.microsoft.com/office/drawing/2014/main" id="{80D26B16-BCBB-414F-8CB6-E2D42A58456F}"/>
+                <a16:creationId xmlns:a16="http://schemas.microsoft.com/office/drawing/2014/main" id="{45E450E9-BF88-4994-8223-E6F9A07FC5B8}"/>
               </a:ext>
             </a:extLst>
           </p:cNvPr>
@@ -13733,7 +13733,7 @@
                 <a:ea typeface="Helvetica Neue"/>
                 <a:cs typeface="Helvetica Neue"/>
               </a:rPr>
-              <a:t>Review-ready</a:t>
+              <a:t>Project materials</a:t>
             </a:r>
           </a:p>
         </p:txBody>
@@ -13743,7 +13743,7 @@
           <p:cNvPr id="6" name="">
             <a:extLst xmlns:a="http://schemas.openxmlformats.org/drawingml/2006/main">
               <a:ext uri="{FF2B5EF4-FFF2-40B4-BE49-F238E27FC236}">
-                <a16:creationId xmlns:a16="http://schemas.microsoft.com/office/drawing/2014/main" id="{62188DA9-879A-4C84-ACBB-D3F90B2309DD}"/>
+                <a16:creationId xmlns:a16="http://schemas.microsoft.com/office/drawing/2014/main" id="{017B40DA-1CF4-4759-9C88-4E2B1A2B1ACA}"/>
               </a:ext>
             </a:extLst>
           </p:cNvPr>
@@ -13890,7 +13890,7 @@
                 <a:ea typeface="Helvetica Neue"/>
                 <a:cs typeface="Helvetica Neue"/>
               </a:rPr>
-              <a:t>14-page English proposal</a:t>
+              <a:t>World-rule and interface plans</a:t>
             </a:r>
           </a:p>
           <a:p xmlns:a="http://schemas.openxmlformats.org/drawingml/2006/main">
@@ -13913,7 +13913,7 @@
                 <a:ea typeface="Helvetica Neue"/>
                 <a:cs typeface="Helvetica Neue"/>
               </a:rPr>
-              <a:t>Draft interfaces and examples</a:t>
+              <a:t>Scenario and data examples</a:t>
             </a:r>
           </a:p>
           <a:p xmlns:a="http://schemas.openxmlformats.org/drawingml/2006/main">
@@ -13936,7 +13936,7 @@
                 <a:ea typeface="Helvetica Neue"/>
                 <a:cs typeface="Helvetica Neue"/>
               </a:rPr>
-              <a:t>English concept video script</a:t>
+              <a:t>English proposal and storyboard</a:t>
             </a:r>
           </a:p>
           <a:p xmlns:a="http://schemas.openxmlformats.org/drawingml/2006/main">
@@ -13959,7 +13959,7 @@
                 <a:ea typeface="Helvetica Neue"/>
                 <a:cs typeface="Helvetica Neue"/>
               </a:rPr>
-              <a:t>Source and rights register</a:t>
+              <a:t>Source and reference register</a:t>
             </a:r>
           </a:p>
         </p:txBody>
@@ -13969,7 +13969,7 @@
           <p:cNvPr id="7" name="">
             <a:extLst xmlns:a="http://schemas.openxmlformats.org/drawingml/2006/main">
               <a:ext uri="{FF2B5EF4-FFF2-40B4-BE49-F238E27FC236}">
-                <a16:creationId xmlns:a16="http://schemas.microsoft.com/office/drawing/2014/main" id="{135ED1A2-6D1E-4866-89AC-E8E0A903801F}"/>
+                <a16:creationId xmlns:a16="http://schemas.microsoft.com/office/drawing/2014/main" id="{862947EE-C49F-46EA-B1E6-89E9C5156146}"/>
               </a:ext>
             </a:extLst>
           </p:cNvPr>
@@ -14116,7 +14116,7 @@
                 <a:ea typeface="Helvetica Neue"/>
                 <a:cs typeface="Helvetica Neue"/>
               </a:rPr>
-              <a:t>Owner completion</a:t>
+              <a:t>Next development steps</a:t>
             </a:r>
           </a:p>
         </p:txBody>
@@ -14126,7 +14126,7 @@
           <p:cNvPr id="8" name="">
             <a:extLst xmlns:a="http://schemas.openxmlformats.org/drawingml/2006/main">
               <a:ext uri="{FF2B5EF4-FFF2-40B4-BE49-F238E27FC236}">
-                <a16:creationId xmlns:a16="http://schemas.microsoft.com/office/drawing/2014/main" id="{B27E60A1-D5E0-44BF-AD9F-587D14BDA836}"/>
+                <a16:creationId xmlns:a16="http://schemas.microsoft.com/office/drawing/2014/main" id="{06FF9DE1-8935-4E08-93AC-DAA95BCCE0F5}"/>
               </a:ext>
             </a:extLst>
           </p:cNvPr>
@@ -14273,7 +14273,7 @@
                 <a:ea typeface="Helvetica Neue"/>
                 <a:cs typeface="Helvetica Neue"/>
               </a:rPr>
-              <a:t>Eligibility and asset clearance</a:t>
+              <a:t>One domain and reference set</a:t>
             </a:r>
           </a:p>
           <a:p xmlns:a="http://schemas.openxmlformats.org/drawingml/2006/main">
@@ -14296,7 +14296,7 @@
                 <a:ea typeface="Helvetica Neue"/>
                 <a:cs typeface="Helvetica Neue"/>
               </a:rPr>
-              <a:t>Legal/contact fields and hardware</a:t>
+              <a:t>UGen300 context planning</a:t>
             </a:r>
           </a:p>
           <a:p xmlns:a="http://schemas.openxmlformats.org/drawingml/2006/main">
@@ -14319,7 +14319,7 @@
                 <a:ea typeface="Helvetica Neue"/>
                 <a:cs typeface="Helvetica Neue"/>
               </a:rPr>
-              <a:t>Signed consent PDF</a:t>
+              <a:t>Video-service integration</a:t>
             </a:r>
           </a:p>
           <a:p xmlns:a="http://schemas.openxmlformats.org/drawingml/2006/main">
@@ -14342,7 +14342,7 @@
                 <a:ea typeface="Helvetica Neue"/>
                 <a:cs typeface="Helvetica Neue"/>
               </a:rPr>
-              <a:t>Judge access and video link</a:t>
+              <a:t>Embeddable website component</a:t>
             </a:r>
           </a:p>
         </p:txBody>
@@ -14352,7 +14352,7 @@
           <p:cNvPr id="9" name="">
             <a:extLst xmlns:a="http://schemas.openxmlformats.org/drawingml/2006/main">
               <a:ext uri="{FF2B5EF4-FFF2-40B4-BE49-F238E27FC236}">
-                <a16:creationId xmlns:a16="http://schemas.microsoft.com/office/drawing/2014/main" id="{1E87024E-7621-45F8-8292-27DE33A27254}"/>
+                <a16:creationId xmlns:a16="http://schemas.microsoft.com/office/drawing/2014/main" id="{E07DEA89-F810-42DE-BB94-8F3C607FA5BA}"/>
               </a:ext>
             </a:extLst>
           </p:cNvPr>
@@ -14509,7 +14509,7 @@
           <p:cNvPr id="10" name="">
             <a:extLst xmlns:a="http://schemas.openxmlformats.org/drawingml/2006/main">
               <a:ext uri="{FF2B5EF4-FFF2-40B4-BE49-F238E27FC236}">
-                <a16:creationId xmlns:a16="http://schemas.microsoft.com/office/drawing/2014/main" id="{CE5D9AE2-300E-4DF9-8927-1DFD5E43CD3D}"/>
+                <a16:creationId xmlns:a16="http://schemas.microsoft.com/office/drawing/2014/main" id="{D792E28A-8EB7-45FF-AB90-BB1AB05E14AF}"/>
               </a:ext>
             </a:extLst>
           </p:cNvPr>
@@ -14656,7 +14656,7 @@
                 <a:ea typeface="Helvetica Neue"/>
                 <a:cs typeface="Helvetica Neue"/>
               </a:rPr>
-              <a:t>Private repository. No product source implementation yet.</a:t>
+              <a:t>FlyPig AI / M.K. Hsu / Public project repository</a:t>
             </a:r>
           </a:p>
         </p:txBody>
@@ -14664,7 +14664,7 @@
     </p:spTree>
     <p:extLst>
       <p:ext uri="{BB962C8B-B14F-4D97-AF65-F5344CB8AC3E}">
-        <p14:creationId xmlns:p14="http://schemas.microsoft.com/office/powerpoint/2010/main" val="398584023"/>
+        <p14:creationId xmlns:p14="http://schemas.microsoft.com/office/powerpoint/2010/main" val="1861368768"/>
       </p:ext>
     </p:extLst>
   </p:cSld>
@@ -14695,7 +14695,7 @@
           <p:cNvPr id="12" name="">
             <a:extLst xmlns:a="http://schemas.openxmlformats.org/drawingml/2006/main">
               <a:ext uri="{FF2B5EF4-FFF2-40B4-BE49-F238E27FC236}">
-                <a16:creationId xmlns:a16="http://schemas.microsoft.com/office/drawing/2014/main" id="{D3973CEB-3D97-4768-A978-3029E0890F9F}"/>
+                <a16:creationId xmlns:a16="http://schemas.microsoft.com/office/drawing/2014/main" id="{050BF1EA-51E2-4F0A-9A23-BC77E2B59546}"/>
               </a:ext>
             </a:extLst>
           </p:cNvPr>
@@ -14852,7 +14852,7 @@
           <p:cNvPr id="2" name="">
             <a:extLst xmlns:a="http://schemas.openxmlformats.org/drawingml/2006/main">
               <a:ext uri="{FF2B5EF4-FFF2-40B4-BE49-F238E27FC236}">
-                <a16:creationId xmlns:a16="http://schemas.microsoft.com/office/drawing/2014/main" id="{072EE115-CA3E-479C-A538-6B2F924AAA81}"/>
+                <a16:creationId xmlns:a16="http://schemas.microsoft.com/office/drawing/2014/main" id="{5ED93C9F-4F0B-4046-BA64-C8B400E22EEC}"/>
               </a:ext>
             </a:extLst>
           </p:cNvPr>
@@ -14883,7 +14883,7 @@
           <p:cNvPr id="3" name="">
             <a:extLst xmlns:a="http://schemas.openxmlformats.org/drawingml/2006/main">
               <a:ext uri="{FF2B5EF4-FFF2-40B4-BE49-F238E27FC236}">
-                <a16:creationId xmlns:a16="http://schemas.microsoft.com/office/drawing/2014/main" id="{9BDC0BBA-6D03-4BD6-94B4-DDCEE6C9AEC0}"/>
+                <a16:creationId xmlns:a16="http://schemas.microsoft.com/office/drawing/2014/main" id="{A6DD5217-33B1-4686-A036-6842C19868E3}"/>
               </a:ext>
             </a:extLst>
           </p:cNvPr>
@@ -15030,7 +15030,7 @@
                 <a:ea typeface="Helvetica Neue"/>
                 <a:cs typeface="Helvetica Neue"/>
               </a:rPr>
-              <a:t>STAGE I CONCEPT / NO PRODUCT IMPLEMENTATION</a:t>
+              <a:t>STAGE I / PROJECT PLAN</a:t>
             </a:r>
           </a:p>
         </p:txBody>
@@ -15040,7 +15040,7 @@
           <p:cNvPr id="4" name="">
             <a:extLst xmlns:a="http://schemas.openxmlformats.org/drawingml/2006/main">
               <a:ext uri="{FF2B5EF4-FFF2-40B4-BE49-F238E27FC236}">
-                <a16:creationId xmlns:a16="http://schemas.microsoft.com/office/drawing/2014/main" id="{5B1B62CD-E3B6-44C4-A64C-7912930D4EF7}"/>
+                <a16:creationId xmlns:a16="http://schemas.microsoft.com/office/drawing/2014/main" id="{A35EAAE2-EFB1-4ACC-A62E-31D7450009A3}"/>
               </a:ext>
             </a:extLst>
           </p:cNvPr>
@@ -15197,7 +15197,7 @@
           <p:cNvPr id="5" name="">
             <a:extLst xmlns:a="http://schemas.openxmlformats.org/drawingml/2006/main">
               <a:ext uri="{FF2B5EF4-FFF2-40B4-BE49-F238E27FC236}">
-                <a16:creationId xmlns:a16="http://schemas.microsoft.com/office/drawing/2014/main" id="{5ACE8570-F74D-4D57-9F0F-894AB9527821}"/>
+                <a16:creationId xmlns:a16="http://schemas.microsoft.com/office/drawing/2014/main" id="{9442254A-99E8-4630-9DA4-E3AC59062DD9}"/>
               </a:ext>
             </a:extLst>
           </p:cNvPr>
@@ -15354,7 +15354,7 @@
           <p:cNvPr id="6" name="">
             <a:extLst xmlns:a="http://schemas.openxmlformats.org/drawingml/2006/main">
               <a:ext uri="{FF2B5EF4-FFF2-40B4-BE49-F238E27FC236}">
-                <a16:creationId xmlns:a16="http://schemas.microsoft.com/office/drawing/2014/main" id="{3C3B1489-B337-41AB-BC50-39D1D387AC4B}"/>
+                <a16:creationId xmlns:a16="http://schemas.microsoft.com/office/drawing/2014/main" id="{5F726137-2BE3-46D6-A9CC-9F3E79799911}"/>
               </a:ext>
             </a:extLst>
           </p:cNvPr>
@@ -15511,7 +15511,7 @@
           <p:cNvPr id="7" name="">
             <a:extLst xmlns:a="http://schemas.openxmlformats.org/drawingml/2006/main">
               <a:ext uri="{FF2B5EF4-FFF2-40B4-BE49-F238E27FC236}">
-                <a16:creationId xmlns:a16="http://schemas.microsoft.com/office/drawing/2014/main" id="{2FD31CC8-89F8-443B-86D0-F62F0DD0132B}"/>
+                <a16:creationId xmlns:a16="http://schemas.microsoft.com/office/drawing/2014/main" id="{25351927-7B11-4F95-BD1A-24648C976125}"/>
               </a:ext>
             </a:extLst>
           </p:cNvPr>
@@ -15668,7 +15668,7 @@
           <p:cNvPr id="8" name="">
             <a:extLst xmlns:a="http://schemas.openxmlformats.org/drawingml/2006/main">
               <a:ext uri="{FF2B5EF4-FFF2-40B4-BE49-F238E27FC236}">
-                <a16:creationId xmlns:a16="http://schemas.microsoft.com/office/drawing/2014/main" id="{A91E2863-D6F5-487C-AEF5-D66AC3D7B1B9}"/>
+                <a16:creationId xmlns:a16="http://schemas.microsoft.com/office/drawing/2014/main" id="{257C5EA5-89BF-41B1-8A1E-4BA8F333F034}"/>
               </a:ext>
             </a:extLst>
           </p:cNvPr>
@@ -15825,7 +15825,7 @@
           <p:cNvPr id="9" name="">
             <a:extLst xmlns:a="http://schemas.openxmlformats.org/drawingml/2006/main">
               <a:ext uri="{FF2B5EF4-FFF2-40B4-BE49-F238E27FC236}">
-                <a16:creationId xmlns:a16="http://schemas.microsoft.com/office/drawing/2014/main" id="{5A018F94-CF37-4077-BED2-05699C307891}"/>
+                <a16:creationId xmlns:a16="http://schemas.microsoft.com/office/drawing/2014/main" id="{F011B8F0-356F-40AC-952F-2468B8345AA3}"/>
               </a:ext>
             </a:extLst>
           </p:cNvPr>
@@ -15982,7 +15982,7 @@
           <p:cNvPr id="10" name="">
             <a:extLst xmlns:a="http://schemas.openxmlformats.org/drawingml/2006/main">
               <a:ext uri="{FF2B5EF4-FFF2-40B4-BE49-F238E27FC236}">
-                <a16:creationId xmlns:a16="http://schemas.microsoft.com/office/drawing/2014/main" id="{B6C994D3-F18E-4570-AF0D-4472FEA4DB06}"/>
+                <a16:creationId xmlns:a16="http://schemas.microsoft.com/office/drawing/2014/main" id="{969327C5-17E8-4DE5-9901-484B224FAF63}"/>
               </a:ext>
             </a:extLst>
           </p:cNvPr>
@@ -16139,7 +16139,7 @@
           <p:cNvPr id="11" name="">
             <a:extLst xmlns:a="http://schemas.openxmlformats.org/drawingml/2006/main">
               <a:ext uri="{FF2B5EF4-FFF2-40B4-BE49-F238E27FC236}">
-                <a16:creationId xmlns:a16="http://schemas.microsoft.com/office/drawing/2014/main" id="{28C0C077-46D2-460D-8EE2-3C6BC93F22F5}"/>
+                <a16:creationId xmlns:a16="http://schemas.microsoft.com/office/drawing/2014/main" id="{20EBC153-2320-4A39-BA9C-2AC1E7778CD9}"/>
               </a:ext>
             </a:extLst>
           </p:cNvPr>
@@ -16294,7 +16294,7 @@
     </p:spTree>
     <p:extLst>
       <p:ext uri="{BB962C8B-B14F-4D97-AF65-F5344CB8AC3E}">
-        <p14:creationId xmlns:p14="http://schemas.microsoft.com/office/powerpoint/2010/main" val="873476579"/>
+        <p14:creationId xmlns:p14="http://schemas.microsoft.com/office/powerpoint/2010/main" val="594197366"/>
       </p:ext>
     </p:extLst>
   </p:cSld>
@@ -16325,7 +16325,7 @@
           <p:cNvPr id="18" name="">
             <a:extLst xmlns:a="http://schemas.openxmlformats.org/drawingml/2006/main">
               <a:ext uri="{FF2B5EF4-FFF2-40B4-BE49-F238E27FC236}">
-                <a16:creationId xmlns:a16="http://schemas.microsoft.com/office/drawing/2014/main" id="{D1308E5E-8C02-4EC0-A529-AA874E0534F0}"/>
+                <a16:creationId xmlns:a16="http://schemas.microsoft.com/office/drawing/2014/main" id="{166D575A-D82E-4A65-A6C2-9823EFE19E4D}"/>
               </a:ext>
             </a:extLst>
           </p:cNvPr>
@@ -16482,7 +16482,7 @@
           <p:cNvPr id="2" name="">
             <a:extLst xmlns:a="http://schemas.openxmlformats.org/drawingml/2006/main">
               <a:ext uri="{FF2B5EF4-FFF2-40B4-BE49-F238E27FC236}">
-                <a16:creationId xmlns:a16="http://schemas.microsoft.com/office/drawing/2014/main" id="{3441B1C6-41BB-4768-B63F-E219634A036A}"/>
+                <a16:creationId xmlns:a16="http://schemas.microsoft.com/office/drawing/2014/main" id="{71DFBF73-6A38-4FCC-9CBB-AF87E0874279}"/>
               </a:ext>
             </a:extLst>
           </p:cNvPr>
@@ -16513,7 +16513,7 @@
           <p:cNvPr id="3" name="">
             <a:extLst xmlns:a="http://schemas.openxmlformats.org/drawingml/2006/main">
               <a:ext uri="{FF2B5EF4-FFF2-40B4-BE49-F238E27FC236}">
-                <a16:creationId xmlns:a16="http://schemas.microsoft.com/office/drawing/2014/main" id="{48292FF1-4355-4035-BF25-BA23FFA3E95C}"/>
+                <a16:creationId xmlns:a16="http://schemas.microsoft.com/office/drawing/2014/main" id="{1C547D0F-ACFA-4B12-8CA0-7A664A1E0465}"/>
               </a:ext>
             </a:extLst>
           </p:cNvPr>
@@ -16660,7 +16660,7 @@
                 <a:ea typeface="Helvetica Neue"/>
                 <a:cs typeface="Helvetica Neue"/>
               </a:rPr>
-              <a:t>STAGE I CONCEPT / NO PRODUCT IMPLEMENTATION</a:t>
+              <a:t>STAGE I / PROJECT PLAN</a:t>
             </a:r>
           </a:p>
         </p:txBody>
@@ -16670,7 +16670,7 @@
           <p:cNvPr id="4" name="">
             <a:extLst xmlns:a="http://schemas.openxmlformats.org/drawingml/2006/main">
               <a:ext uri="{FF2B5EF4-FFF2-40B4-BE49-F238E27FC236}">
-                <a16:creationId xmlns:a16="http://schemas.microsoft.com/office/drawing/2014/main" id="{514934C9-979E-49F5-A587-F602E1009C23}"/>
+                <a16:creationId xmlns:a16="http://schemas.microsoft.com/office/drawing/2014/main" id="{733149C0-DBFA-4452-8638-429B9D3C24D2}"/>
               </a:ext>
             </a:extLst>
           </p:cNvPr>
@@ -16827,7 +16827,7 @@
           <p:cNvPr id="5" name="">
             <a:extLst xmlns:a="http://schemas.openxmlformats.org/drawingml/2006/main">
               <a:ext uri="{FF2B5EF4-FFF2-40B4-BE49-F238E27FC236}">
-                <a16:creationId xmlns:a16="http://schemas.microsoft.com/office/drawing/2014/main" id="{51841333-1786-42CC-803C-EBB876A4C7BD}"/>
+                <a16:creationId xmlns:a16="http://schemas.microsoft.com/office/drawing/2014/main" id="{30ACB477-8965-4B4C-A3F2-CBA389FD8391}"/>
               </a:ext>
             </a:extLst>
           </p:cNvPr>
@@ -16984,7 +16984,7 @@
           <p:cNvPr id="6" name="">
             <a:extLst xmlns:a="http://schemas.openxmlformats.org/drawingml/2006/main">
               <a:ext uri="{FF2B5EF4-FFF2-40B4-BE49-F238E27FC236}">
-                <a16:creationId xmlns:a16="http://schemas.microsoft.com/office/drawing/2014/main" id="{21F3426A-D1D8-4809-9959-C7808B136441}"/>
+                <a16:creationId xmlns:a16="http://schemas.microsoft.com/office/drawing/2014/main" id="{96366F67-BADD-4BB4-9322-5759A548CB78}"/>
               </a:ext>
             </a:extLst>
           </p:cNvPr>
@@ -17141,7 +17141,7 @@
           <p:cNvPr id="7" name="">
             <a:extLst xmlns:a="http://schemas.openxmlformats.org/drawingml/2006/main">
               <a:ext uri="{FF2B5EF4-FFF2-40B4-BE49-F238E27FC236}">
-                <a16:creationId xmlns:a16="http://schemas.microsoft.com/office/drawing/2014/main" id="{106803F8-B405-4C1D-98F4-487243F67F61}"/>
+                <a16:creationId xmlns:a16="http://schemas.microsoft.com/office/drawing/2014/main" id="{219BFB00-E39F-4705-BAD1-2041DDE383EA}"/>
               </a:ext>
             </a:extLst>
           </p:cNvPr>
@@ -17172,7 +17172,7 @@
           <p:cNvPr id="8" name="">
             <a:extLst xmlns:a="http://schemas.openxmlformats.org/drawingml/2006/main">
               <a:ext uri="{FF2B5EF4-FFF2-40B4-BE49-F238E27FC236}">
-                <a16:creationId xmlns:a16="http://schemas.microsoft.com/office/drawing/2014/main" id="{743F3C56-0549-4E25-92BE-614C0258032A}"/>
+                <a16:creationId xmlns:a16="http://schemas.microsoft.com/office/drawing/2014/main" id="{EFBF7119-C4A2-438B-A01A-847FCE1B9AF2}"/>
               </a:ext>
             </a:extLst>
           </p:cNvPr>
@@ -17329,7 +17329,7 @@
           <p:cNvPr id="9" name="">
             <a:extLst xmlns:a="http://schemas.openxmlformats.org/drawingml/2006/main">
               <a:ext uri="{FF2B5EF4-FFF2-40B4-BE49-F238E27FC236}">
-                <a16:creationId xmlns:a16="http://schemas.microsoft.com/office/drawing/2014/main" id="{B83CA020-A3FA-4D1F-8218-B3495BC55A71}"/>
+                <a16:creationId xmlns:a16="http://schemas.microsoft.com/office/drawing/2014/main" id="{4D4F475E-CADB-430F-9B30-51F00BA24C64}"/>
               </a:ext>
             </a:extLst>
           </p:cNvPr>
@@ -17486,7 +17486,7 @@
           <p:cNvPr id="10" name="">
             <a:extLst xmlns:a="http://schemas.openxmlformats.org/drawingml/2006/main">
               <a:ext uri="{FF2B5EF4-FFF2-40B4-BE49-F238E27FC236}">
-                <a16:creationId xmlns:a16="http://schemas.microsoft.com/office/drawing/2014/main" id="{C03E386B-59D3-4B65-BD60-42CE5D901390}"/>
+                <a16:creationId xmlns:a16="http://schemas.microsoft.com/office/drawing/2014/main" id="{CFA0561C-CE46-47F9-9EC4-F6ED2D7C8657}"/>
               </a:ext>
             </a:extLst>
           </p:cNvPr>
@@ -17517,7 +17517,7 @@
           <p:cNvPr id="11" name="">
             <a:extLst xmlns:a="http://schemas.openxmlformats.org/drawingml/2006/main">
               <a:ext uri="{FF2B5EF4-FFF2-40B4-BE49-F238E27FC236}">
-                <a16:creationId xmlns:a16="http://schemas.microsoft.com/office/drawing/2014/main" id="{1A8080DF-2405-44D4-B8D2-6689FF332921}"/>
+                <a16:creationId xmlns:a16="http://schemas.microsoft.com/office/drawing/2014/main" id="{AE56B319-1AE6-4C68-9E8F-6A30CD698AF5}"/>
               </a:ext>
             </a:extLst>
           </p:cNvPr>
@@ -17674,7 +17674,7 @@
           <p:cNvPr id="12" name="">
             <a:extLst xmlns:a="http://schemas.openxmlformats.org/drawingml/2006/main">
               <a:ext uri="{FF2B5EF4-FFF2-40B4-BE49-F238E27FC236}">
-                <a16:creationId xmlns:a16="http://schemas.microsoft.com/office/drawing/2014/main" id="{93D53DE3-1FBA-4635-97C5-BFBA70840F4C}"/>
+                <a16:creationId xmlns:a16="http://schemas.microsoft.com/office/drawing/2014/main" id="{06881734-3D2A-4893-9E59-0C5F192A5E77}"/>
               </a:ext>
             </a:extLst>
           </p:cNvPr>
@@ -17831,7 +17831,7 @@
           <p:cNvPr id="13" name="">
             <a:extLst xmlns:a="http://schemas.openxmlformats.org/drawingml/2006/main">
               <a:ext uri="{FF2B5EF4-FFF2-40B4-BE49-F238E27FC236}">
-                <a16:creationId xmlns:a16="http://schemas.microsoft.com/office/drawing/2014/main" id="{35A0BBEB-D7D2-4338-96EB-D85F5AD6E781}"/>
+                <a16:creationId xmlns:a16="http://schemas.microsoft.com/office/drawing/2014/main" id="{7E6EFAAD-FF46-49FD-9471-CBFE54D32ED6}"/>
               </a:ext>
             </a:extLst>
           </p:cNvPr>
@@ -17862,7 +17862,7 @@
           <p:cNvPr id="14" name="">
             <a:extLst xmlns:a="http://schemas.openxmlformats.org/drawingml/2006/main">
               <a:ext uri="{FF2B5EF4-FFF2-40B4-BE49-F238E27FC236}">
-                <a16:creationId xmlns:a16="http://schemas.microsoft.com/office/drawing/2014/main" id="{2E223BCB-29E5-4952-A8CF-661B79732F27}"/>
+                <a16:creationId xmlns:a16="http://schemas.microsoft.com/office/drawing/2014/main" id="{CE374A9C-A62E-4C97-B379-3CEFD1A7352B}"/>
               </a:ext>
             </a:extLst>
           </p:cNvPr>
@@ -18019,7 +18019,7 @@
           <p:cNvPr id="15" name="">
             <a:extLst xmlns:a="http://schemas.openxmlformats.org/drawingml/2006/main">
               <a:ext uri="{FF2B5EF4-FFF2-40B4-BE49-F238E27FC236}">
-                <a16:creationId xmlns:a16="http://schemas.microsoft.com/office/drawing/2014/main" id="{5C4188C8-2A30-43CF-8A03-7E7BFDAFB2A2}"/>
+                <a16:creationId xmlns:a16="http://schemas.microsoft.com/office/drawing/2014/main" id="{3E4A217F-AC53-424F-A5FA-31BCAE0AD212}"/>
               </a:ext>
             </a:extLst>
           </p:cNvPr>
@@ -18176,7 +18176,7 @@
           <p:cNvPr id="16" name="">
             <a:extLst xmlns:a="http://schemas.openxmlformats.org/drawingml/2006/main">
               <a:ext uri="{FF2B5EF4-FFF2-40B4-BE49-F238E27FC236}">
-                <a16:creationId xmlns:a16="http://schemas.microsoft.com/office/drawing/2014/main" id="{30DD48B9-252E-4CFC-A5F8-D92DDBD124D2}"/>
+                <a16:creationId xmlns:a16="http://schemas.microsoft.com/office/drawing/2014/main" id="{82C71F49-5BD5-495B-A614-0DDA08F46BE6}"/>
               </a:ext>
             </a:extLst>
           </p:cNvPr>
@@ -18323,7 +18323,7 @@
                 <a:ea typeface="Helvetica Neue"/>
                 <a:cs typeface="Helvetica Neue"/>
               </a:rPr>
-              <a:t>Domain + eligible species + time + climate + approved reference images</a:t>
+              <a:t>World settings + eligible subjects + time + climate + reference images</a:t>
             </a:r>
           </a:p>
         </p:txBody>
@@ -18333,7 +18333,7 @@
           <p:cNvPr id="17" name="">
             <a:extLst xmlns:a="http://schemas.openxmlformats.org/drawingml/2006/main">
               <a:ext uri="{FF2B5EF4-FFF2-40B4-BE49-F238E27FC236}">
-                <a16:creationId xmlns:a16="http://schemas.microsoft.com/office/drawing/2014/main" id="{02E2BE86-7BAC-4168-8965-0A132CBB8686}"/>
+                <a16:creationId xmlns:a16="http://schemas.microsoft.com/office/drawing/2014/main" id="{DACDE0C6-4793-41D6-98CB-CFFF30F9EC57}"/>
               </a:ext>
             </a:extLst>
           </p:cNvPr>
@@ -18480,7 +18480,7 @@
                 <a:ea typeface="Helvetica Neue"/>
                 <a:cs typeface="Helvetica Neue"/>
               </a:rPr>
-              <a:t>Fast generation is the intended experience. Backend and latency remain unvalidated.</a:t>
+              <a:t>A new contextual moment, planned from the creator’s world and existing artwork.</a:t>
             </a:r>
           </a:p>
         </p:txBody>
@@ -18488,7 +18488,7 @@
     </p:spTree>
     <p:extLst>
       <p:ext uri="{BB962C8B-B14F-4D97-AF65-F5344CB8AC3E}">
-        <p14:creationId xmlns:p14="http://schemas.microsoft.com/office/powerpoint/2010/main" val="1647717130"/>
+        <p14:creationId xmlns:p14="http://schemas.microsoft.com/office/powerpoint/2010/main" val="1679885890"/>
       </p:ext>
     </p:extLst>
   </p:cSld>
@@ -18519,7 +18519,7 @@
           <p:cNvPr id="14" name="">
             <a:extLst xmlns:a="http://schemas.openxmlformats.org/drawingml/2006/main">
               <a:ext uri="{FF2B5EF4-FFF2-40B4-BE49-F238E27FC236}">
-                <a16:creationId xmlns:a16="http://schemas.microsoft.com/office/drawing/2014/main" id="{8FFC2DBC-BF33-4BDE-BF84-E83A72C06DD0}"/>
+                <a16:creationId xmlns:a16="http://schemas.microsoft.com/office/drawing/2014/main" id="{2F7910C9-DCE5-4E3D-B8A1-0F032A81758E}"/>
               </a:ext>
             </a:extLst>
           </p:cNvPr>
@@ -18676,7 +18676,7 @@
           <p:cNvPr id="2" name="">
             <a:extLst xmlns:a="http://schemas.openxmlformats.org/drawingml/2006/main">
               <a:ext uri="{FF2B5EF4-FFF2-40B4-BE49-F238E27FC236}">
-                <a16:creationId xmlns:a16="http://schemas.microsoft.com/office/drawing/2014/main" id="{15F64DC2-34B3-4861-A1C2-117E22926A2E}"/>
+                <a16:creationId xmlns:a16="http://schemas.microsoft.com/office/drawing/2014/main" id="{F46AD0B5-0355-48F3-9878-20F496909F76}"/>
               </a:ext>
             </a:extLst>
           </p:cNvPr>
@@ -18707,7 +18707,7 @@
           <p:cNvPr id="3" name="">
             <a:extLst xmlns:a="http://schemas.openxmlformats.org/drawingml/2006/main">
               <a:ext uri="{FF2B5EF4-FFF2-40B4-BE49-F238E27FC236}">
-                <a16:creationId xmlns:a16="http://schemas.microsoft.com/office/drawing/2014/main" id="{5A51FEB3-1BCE-4FDB-B4F5-9E21E8F596D3}"/>
+                <a16:creationId xmlns:a16="http://schemas.microsoft.com/office/drawing/2014/main" id="{1AFFCB68-B81E-4BC3-BD30-CE0C2AE1BEE3}"/>
               </a:ext>
             </a:extLst>
           </p:cNvPr>
@@ -18854,7 +18854,7 @@
                 <a:ea typeface="Helvetica Neue"/>
                 <a:cs typeface="Helvetica Neue"/>
               </a:rPr>
-              <a:t>STAGE I CONCEPT / NO PRODUCT IMPLEMENTATION</a:t>
+              <a:t>STAGE I / PROJECT PLAN</a:t>
             </a:r>
           </a:p>
         </p:txBody>
@@ -18864,7 +18864,7 @@
           <p:cNvPr id="4" name="">
             <a:extLst xmlns:a="http://schemas.openxmlformats.org/drawingml/2006/main">
               <a:ext uri="{FF2B5EF4-FFF2-40B4-BE49-F238E27FC236}">
-                <a16:creationId xmlns:a16="http://schemas.microsoft.com/office/drawing/2014/main" id="{1882DCA7-5716-4895-B98D-EE932395D191}"/>
+                <a16:creationId xmlns:a16="http://schemas.microsoft.com/office/drawing/2014/main" id="{1D58764D-FC28-42FB-96E3-C0E039232C25}"/>
               </a:ext>
             </a:extLst>
           </p:cNvPr>
@@ -19021,7 +19021,7 @@
           <p:cNvPr id="5" name="">
             <a:extLst xmlns:a="http://schemas.openxmlformats.org/drawingml/2006/main">
               <a:ext uri="{FF2B5EF4-FFF2-40B4-BE49-F238E27FC236}">
-                <a16:creationId xmlns:a16="http://schemas.microsoft.com/office/drawing/2014/main" id="{D0BBAA13-1FC2-441D-9186-93A8314EBD1D}"/>
+                <a16:creationId xmlns:a16="http://schemas.microsoft.com/office/drawing/2014/main" id="{293B9D19-CCD1-4327-AD1D-647F7D84F178}"/>
               </a:ext>
             </a:extLst>
           </p:cNvPr>
@@ -19178,7 +19178,7 @@
           <p:cNvPr id="6" name="">
             <a:extLst xmlns:a="http://schemas.openxmlformats.org/drawingml/2006/main">
               <a:ext uri="{FF2B5EF4-FFF2-40B4-BE49-F238E27FC236}">
-                <a16:creationId xmlns:a16="http://schemas.microsoft.com/office/drawing/2014/main" id="{BEA16958-3D5C-4913-B27B-A496695B8012}"/>
+                <a16:creationId xmlns:a16="http://schemas.microsoft.com/office/drawing/2014/main" id="{3E9C07C3-67A4-4E52-A619-9ACCA6955A94}"/>
               </a:ext>
             </a:extLst>
           </p:cNvPr>
@@ -19335,7 +19335,7 @@
           <p:cNvPr id="7" name="">
             <a:extLst xmlns:a="http://schemas.openxmlformats.org/drawingml/2006/main">
               <a:ext uri="{FF2B5EF4-FFF2-40B4-BE49-F238E27FC236}">
-                <a16:creationId xmlns:a16="http://schemas.microsoft.com/office/drawing/2014/main" id="{62F64CDA-1FBF-4EA7-AB3F-1541873916FE}"/>
+                <a16:creationId xmlns:a16="http://schemas.microsoft.com/office/drawing/2014/main" id="{70793276-DCD8-4AB8-AC3B-DBF271E6716A}"/>
               </a:ext>
             </a:extLst>
           </p:cNvPr>
@@ -19482,7 +19482,7 @@
                 <a:ea typeface="Helvetica Neue"/>
                 <a:cs typeface="Helvetica Neue"/>
               </a:rPr>
-              <a:t>One domain, approved species, visual references and prohibited events.</a:t>
+              <a:t>One domain, eligible species or characters, visual references and event rules.</a:t>
             </a:r>
           </a:p>
         </p:txBody>
@@ -19492,7 +19492,7 @@
           <p:cNvPr id="8" name="">
             <a:extLst xmlns:a="http://schemas.openxmlformats.org/drawingml/2006/main">
               <a:ext uri="{FF2B5EF4-FFF2-40B4-BE49-F238E27FC236}">
-                <a16:creationId xmlns:a16="http://schemas.microsoft.com/office/drawing/2014/main" id="{8F312ED9-D870-4815-AB85-7F3E09E42119}"/>
+                <a16:creationId xmlns:a16="http://schemas.microsoft.com/office/drawing/2014/main" id="{39D71C1F-D45D-4651-89A5-4789F7BC2B5A}"/>
               </a:ext>
             </a:extLst>
           </p:cNvPr>
@@ -19649,7 +19649,7 @@
           <p:cNvPr id="9" name="">
             <a:extLst xmlns:a="http://schemas.openxmlformats.org/drawingml/2006/main">
               <a:ext uri="{FF2B5EF4-FFF2-40B4-BE49-F238E27FC236}">
-                <a16:creationId xmlns:a16="http://schemas.microsoft.com/office/drawing/2014/main" id="{0309FFAD-C873-40A6-ACB5-5316C7BE7EDC}"/>
+                <a16:creationId xmlns:a16="http://schemas.microsoft.com/office/drawing/2014/main" id="{C8C56678-9C42-4D96-BB92-839E75F45F27}"/>
               </a:ext>
             </a:extLst>
           </p:cNvPr>
@@ -19806,7 +19806,7 @@
           <p:cNvPr id="10" name="">
             <a:extLst xmlns:a="http://schemas.openxmlformats.org/drawingml/2006/main">
               <a:ext uri="{FF2B5EF4-FFF2-40B4-BE49-F238E27FC236}">
-                <a16:creationId xmlns:a16="http://schemas.microsoft.com/office/drawing/2014/main" id="{8AC89A71-BB19-4BF6-8557-0D51B4FC3BB6}"/>
+                <a16:creationId xmlns:a16="http://schemas.microsoft.com/office/drawing/2014/main" id="{72D88CFB-2CFD-4E1E-B2A6-89059B4EAB71}"/>
               </a:ext>
             </a:extLst>
           </p:cNvPr>
@@ -19963,7 +19963,7 @@
           <p:cNvPr id="11" name="">
             <a:extLst xmlns:a="http://schemas.openxmlformats.org/drawingml/2006/main">
               <a:ext uri="{FF2B5EF4-FFF2-40B4-BE49-F238E27FC236}">
-                <a16:creationId xmlns:a16="http://schemas.microsoft.com/office/drawing/2014/main" id="{E7FD43EB-0B1A-4659-B282-4A8DBC9CFCF3}"/>
+                <a16:creationId xmlns:a16="http://schemas.microsoft.com/office/drawing/2014/main" id="{F39AEEC0-1EAC-4613-B068-5F26EC2A252F}"/>
               </a:ext>
             </a:extLst>
           </p:cNvPr>
@@ -20120,7 +20120,7 @@
           <p:cNvPr id="12" name="">
             <a:extLst xmlns:a="http://schemas.openxmlformats.org/drawingml/2006/main">
               <a:ext uri="{FF2B5EF4-FFF2-40B4-BE49-F238E27FC236}">
-                <a16:creationId xmlns:a16="http://schemas.microsoft.com/office/drawing/2014/main" id="{B4AD39E1-12D7-4D46-9BD3-B7F90DDF9092}"/>
+                <a16:creationId xmlns:a16="http://schemas.microsoft.com/office/drawing/2014/main" id="{265EEB97-43AC-4F90-8D32-38542B7BB7B6}"/>
               </a:ext>
             </a:extLst>
           </p:cNvPr>
@@ -20277,7 +20277,7 @@
           <p:cNvPr id="13" name="">
             <a:extLst xmlns:a="http://schemas.openxmlformats.org/drawingml/2006/main">
               <a:ext uri="{FF2B5EF4-FFF2-40B4-BE49-F238E27FC236}">
-                <a16:creationId xmlns:a16="http://schemas.microsoft.com/office/drawing/2014/main" id="{00778B26-E1D3-4A93-A96F-5F4B57BD597B}"/>
+                <a16:creationId xmlns:a16="http://schemas.microsoft.com/office/drawing/2014/main" id="{12D084E8-9224-44A1-B077-3495EE0647AB}"/>
               </a:ext>
             </a:extLst>
           </p:cNvPr>
@@ -20432,7 +20432,7 @@
     </p:spTree>
     <p:extLst>
       <p:ext uri="{BB962C8B-B14F-4D97-AF65-F5344CB8AC3E}">
-        <p14:creationId xmlns:p14="http://schemas.microsoft.com/office/powerpoint/2010/main" val="230101687"/>
+        <p14:creationId xmlns:p14="http://schemas.microsoft.com/office/powerpoint/2010/main" val="1981143905"/>
       </p:ext>
     </p:extLst>
   </p:cSld>
@@ -20463,7 +20463,7 @@
           <p:cNvPr id="9" name="">
             <a:extLst xmlns:a="http://schemas.openxmlformats.org/drawingml/2006/main">
               <a:ext uri="{FF2B5EF4-FFF2-40B4-BE49-F238E27FC236}">
-                <a16:creationId xmlns:a16="http://schemas.microsoft.com/office/drawing/2014/main" id="{2E6A6760-3291-44B7-9631-9F8EA5B56D84}"/>
+                <a16:creationId xmlns:a16="http://schemas.microsoft.com/office/drawing/2014/main" id="{DB6F98CD-C2E7-4CD4-A9FE-A16203DE1F18}"/>
               </a:ext>
             </a:extLst>
           </p:cNvPr>
@@ -20620,7 +20620,7 @@
           <p:cNvPr id="2" name="">
             <a:extLst xmlns:a="http://schemas.openxmlformats.org/drawingml/2006/main">
               <a:ext uri="{FF2B5EF4-FFF2-40B4-BE49-F238E27FC236}">
-                <a16:creationId xmlns:a16="http://schemas.microsoft.com/office/drawing/2014/main" id="{FD488387-97BD-4CEC-9E8D-34CD1E295E1B}"/>
+                <a16:creationId xmlns:a16="http://schemas.microsoft.com/office/drawing/2014/main" id="{3B7E4EBF-B7E1-40A6-B058-CF4972C33E57}"/>
               </a:ext>
             </a:extLst>
           </p:cNvPr>
@@ -20651,7 +20651,7 @@
           <p:cNvPr id="3" name="">
             <a:extLst xmlns:a="http://schemas.openxmlformats.org/drawingml/2006/main">
               <a:ext uri="{FF2B5EF4-FFF2-40B4-BE49-F238E27FC236}">
-                <a16:creationId xmlns:a16="http://schemas.microsoft.com/office/drawing/2014/main" id="{9F1A2AE3-E762-4442-84B6-18BF8F790DDB}"/>
+                <a16:creationId xmlns:a16="http://schemas.microsoft.com/office/drawing/2014/main" id="{882BCFC5-26B5-4647-A1CA-E37D5058277D}"/>
               </a:ext>
             </a:extLst>
           </p:cNvPr>
@@ -20798,7 +20798,7 @@
                 <a:ea typeface="Helvetica Neue"/>
                 <a:cs typeface="Helvetica Neue"/>
               </a:rPr>
-              <a:t>STAGE I CONCEPT / NO PRODUCT IMPLEMENTATION</a:t>
+              <a:t>STAGE I / PROJECT PLAN</a:t>
             </a:r>
           </a:p>
         </p:txBody>
@@ -20808,7 +20808,7 @@
           <p:cNvPr id="4" name="">
             <a:extLst xmlns:a="http://schemas.openxmlformats.org/drawingml/2006/main">
               <a:ext uri="{FF2B5EF4-FFF2-40B4-BE49-F238E27FC236}">
-                <a16:creationId xmlns:a16="http://schemas.microsoft.com/office/drawing/2014/main" id="{6CA855E8-67C6-4FA2-A2BD-6118399C163B}"/>
+                <a16:creationId xmlns:a16="http://schemas.microsoft.com/office/drawing/2014/main" id="{9947BCB1-9B12-43E1-8FAC-2CC8D31A61E6}"/>
               </a:ext>
             </a:extLst>
           </p:cNvPr>
@@ -20965,7 +20965,7 @@
           <p:cNvPr id="5" name="">
             <a:extLst xmlns:a="http://schemas.openxmlformats.org/drawingml/2006/main">
               <a:ext uri="{FF2B5EF4-FFF2-40B4-BE49-F238E27FC236}">
-                <a16:creationId xmlns:a16="http://schemas.microsoft.com/office/drawing/2014/main" id="{5396AF34-EF68-4AFD-A855-0BCC62D804FC}"/>
+                <a16:creationId xmlns:a16="http://schemas.microsoft.com/office/drawing/2014/main" id="{82691340-B653-4807-A78D-1D96A6B2F003}"/>
               </a:ext>
             </a:extLst>
           </p:cNvPr>
@@ -21122,7 +21122,7 @@
           <p:cNvPr id="6" name="">
             <a:extLst xmlns:a="http://schemas.openxmlformats.org/drawingml/2006/main">
               <a:ext uri="{FF2B5EF4-FFF2-40B4-BE49-F238E27FC236}">
-                <a16:creationId xmlns:a16="http://schemas.microsoft.com/office/drawing/2014/main" id="{AF918D3F-C0A7-4951-8785-7E7CF4A34CBC}"/>
+                <a16:creationId xmlns:a16="http://schemas.microsoft.com/office/drawing/2014/main" id="{E8BD2EDE-B570-4574-A0E8-03B02854F265}"/>
               </a:ext>
             </a:extLst>
           </p:cNvPr>
@@ -21302,7 +21302,7 @@
           <p:cNvPr id="7" name="">
             <a:extLst xmlns:a="http://schemas.openxmlformats.org/drawingml/2006/main">
               <a:ext uri="{FF2B5EF4-FFF2-40B4-BE49-F238E27FC236}">
-                <a16:creationId xmlns:a16="http://schemas.microsoft.com/office/drawing/2014/main" id="{C20D7CD6-964C-4770-93E1-5C8E6F6D2579}"/>
+                <a16:creationId xmlns:a16="http://schemas.microsoft.com/office/drawing/2014/main" id="{682A215F-4C08-415F-BC62-8242E15E876E}"/>
               </a:ext>
             </a:extLst>
           </p:cNvPr>
@@ -21482,7 +21482,7 @@
           <p:cNvPr id="8" name="">
             <a:extLst xmlns:a="http://schemas.openxmlformats.org/drawingml/2006/main">
               <a:ext uri="{FF2B5EF4-FFF2-40B4-BE49-F238E27FC236}">
-                <a16:creationId xmlns:a16="http://schemas.microsoft.com/office/drawing/2014/main" id="{D902A92A-08E1-4929-93DF-2DE52F540248}"/>
+                <a16:creationId xmlns:a16="http://schemas.microsoft.com/office/drawing/2014/main" id="{6F6FB77F-7177-41DE-9452-1A305BB4E64C}"/>
               </a:ext>
             </a:extLst>
           </p:cNvPr>
@@ -21629,7 +21629,7 @@
                 <a:ea typeface="Helvetica Neue"/>
                 <a:cs typeface="Helvetica Neue"/>
               </a:rPr>
-              <a:t>Hand-authored sample. No model output, generated clip or measured result.</a:t>
+              <a:t>Illustrative scenario for the planned reference-conditioned workflow.</a:t>
             </a:r>
           </a:p>
         </p:txBody>
@@ -21637,7 +21637,7 @@
     </p:spTree>
     <p:extLst>
       <p:ext uri="{BB962C8B-B14F-4D97-AF65-F5344CB8AC3E}">
-        <p14:creationId xmlns:p14="http://schemas.microsoft.com/office/powerpoint/2010/main" val="1985182002"/>
+        <p14:creationId xmlns:p14="http://schemas.microsoft.com/office/powerpoint/2010/main" val="2108855006"/>
       </p:ext>
     </p:extLst>
   </p:cSld>
@@ -21668,7 +21668,7 @@
           <p:cNvPr id="20" name="">
             <a:extLst xmlns:a="http://schemas.openxmlformats.org/drawingml/2006/main">
               <a:ext uri="{FF2B5EF4-FFF2-40B4-BE49-F238E27FC236}">
-                <a16:creationId xmlns:a16="http://schemas.microsoft.com/office/drawing/2014/main" id="{34DE77D2-8C44-42E6-8617-5A995C792714}"/>
+                <a16:creationId xmlns:a16="http://schemas.microsoft.com/office/drawing/2014/main" id="{CD7C4829-4303-4D82-A355-9F128C73D446}"/>
               </a:ext>
             </a:extLst>
           </p:cNvPr>
@@ -21825,7 +21825,7 @@
           <p:cNvPr id="2" name="">
             <a:extLst xmlns:a="http://schemas.openxmlformats.org/drawingml/2006/main">
               <a:ext uri="{FF2B5EF4-FFF2-40B4-BE49-F238E27FC236}">
-                <a16:creationId xmlns:a16="http://schemas.microsoft.com/office/drawing/2014/main" id="{FD9F569B-FFE2-4B9C-96D7-A3CA48402EE9}"/>
+                <a16:creationId xmlns:a16="http://schemas.microsoft.com/office/drawing/2014/main" id="{A223DB82-1147-440D-B998-604FAFD5464F}"/>
               </a:ext>
             </a:extLst>
           </p:cNvPr>
@@ -21856,7 +21856,7 @@
           <p:cNvPr id="3" name="">
             <a:extLst xmlns:a="http://schemas.openxmlformats.org/drawingml/2006/main">
               <a:ext uri="{FF2B5EF4-FFF2-40B4-BE49-F238E27FC236}">
-                <a16:creationId xmlns:a16="http://schemas.microsoft.com/office/drawing/2014/main" id="{0DECB61E-FD66-4EC9-825D-6E4C2A6ED83F}"/>
+                <a16:creationId xmlns:a16="http://schemas.microsoft.com/office/drawing/2014/main" id="{B320FBA8-642C-49C0-9BD1-6CE502439791}"/>
               </a:ext>
             </a:extLst>
           </p:cNvPr>
@@ -22003,7 +22003,7 @@
                 <a:ea typeface="Helvetica Neue"/>
                 <a:cs typeface="Helvetica Neue"/>
               </a:rPr>
-              <a:t>STAGE I CONCEPT / NO PRODUCT IMPLEMENTATION</a:t>
+              <a:t>STAGE I / PROJECT PLAN</a:t>
             </a:r>
           </a:p>
         </p:txBody>
@@ -22013,7 +22013,7 @@
           <p:cNvPr id="4" name="">
             <a:extLst xmlns:a="http://schemas.openxmlformats.org/drawingml/2006/main">
               <a:ext uri="{FF2B5EF4-FFF2-40B4-BE49-F238E27FC236}">
-                <a16:creationId xmlns:a16="http://schemas.microsoft.com/office/drawing/2014/main" id="{4BA71080-B38B-411C-8C88-420B216C5C02}"/>
+                <a16:creationId xmlns:a16="http://schemas.microsoft.com/office/drawing/2014/main" id="{C661EA2C-494A-436E-824B-E516F7378925}"/>
               </a:ext>
             </a:extLst>
           </p:cNvPr>
@@ -22170,7 +22170,7 @@
           <p:cNvPr id="5" name="">
             <a:extLst xmlns:a="http://schemas.openxmlformats.org/drawingml/2006/main">
               <a:ext uri="{FF2B5EF4-FFF2-40B4-BE49-F238E27FC236}">
-                <a16:creationId xmlns:a16="http://schemas.microsoft.com/office/drawing/2014/main" id="{7EAFCA29-30A7-4703-846C-776008E43462}"/>
+                <a16:creationId xmlns:a16="http://schemas.microsoft.com/office/drawing/2014/main" id="{73B2C16D-5904-473E-BA41-7FC46A7102FE}"/>
               </a:ext>
             </a:extLst>
           </p:cNvPr>
@@ -22201,7 +22201,7 @@
           <p:cNvPr id="6" name="">
             <a:extLst xmlns:a="http://schemas.openxmlformats.org/drawingml/2006/main">
               <a:ext uri="{FF2B5EF4-FFF2-40B4-BE49-F238E27FC236}">
-                <a16:creationId xmlns:a16="http://schemas.microsoft.com/office/drawing/2014/main" id="{73D1C71C-452E-48AB-B012-6C720D3DCD65}"/>
+                <a16:creationId xmlns:a16="http://schemas.microsoft.com/office/drawing/2014/main" id="{14467D4B-7EF9-49B1-B405-8A88D8566703}"/>
               </a:ext>
             </a:extLst>
           </p:cNvPr>
@@ -22381,7 +22381,7 @@
           <p:cNvPr id="7" name="">
             <a:extLst xmlns:a="http://schemas.openxmlformats.org/drawingml/2006/main">
               <a:ext uri="{FF2B5EF4-FFF2-40B4-BE49-F238E27FC236}">
-                <a16:creationId xmlns:a16="http://schemas.microsoft.com/office/drawing/2014/main" id="{5A239146-107A-493D-8021-258C5FF49987}"/>
+                <a16:creationId xmlns:a16="http://schemas.microsoft.com/office/drawing/2014/main" id="{4003493C-58F8-4BE8-81F5-372D64C6F9FE}"/>
               </a:ext>
             </a:extLst>
           </p:cNvPr>
@@ -22412,7 +22412,7 @@
           <p:cNvPr id="8" name="">
             <a:extLst xmlns:a="http://schemas.openxmlformats.org/drawingml/2006/main">
               <a:ext uri="{FF2B5EF4-FFF2-40B4-BE49-F238E27FC236}">
-                <a16:creationId xmlns:a16="http://schemas.microsoft.com/office/drawing/2014/main" id="{629BA66B-4C0D-4235-B675-F505DFA6F546}"/>
+                <a16:creationId xmlns:a16="http://schemas.microsoft.com/office/drawing/2014/main" id="{FFCBBEF5-6D6D-4C6B-82D8-40441E299276}"/>
               </a:ext>
             </a:extLst>
           </p:cNvPr>
@@ -22592,7 +22592,7 @@
           <p:cNvPr id="9" name="">
             <a:extLst xmlns:a="http://schemas.openxmlformats.org/drawingml/2006/main">
               <a:ext uri="{FF2B5EF4-FFF2-40B4-BE49-F238E27FC236}">
-                <a16:creationId xmlns:a16="http://schemas.microsoft.com/office/drawing/2014/main" id="{BA03E288-F3B1-4B84-B093-620DBCC359DB}"/>
+                <a16:creationId xmlns:a16="http://schemas.microsoft.com/office/drawing/2014/main" id="{7EF1EC82-AC6C-483E-AE88-C24E736E8EC2}"/>
               </a:ext>
             </a:extLst>
           </p:cNvPr>
@@ -22623,7 +22623,7 @@
           <p:cNvPr id="10" name="">
             <a:extLst xmlns:a="http://schemas.openxmlformats.org/drawingml/2006/main">
               <a:ext uri="{FF2B5EF4-FFF2-40B4-BE49-F238E27FC236}">
-                <a16:creationId xmlns:a16="http://schemas.microsoft.com/office/drawing/2014/main" id="{1A593654-89E2-40C2-970F-573091FFA712}"/>
+                <a16:creationId xmlns:a16="http://schemas.microsoft.com/office/drawing/2014/main" id="{503E189B-BEF6-487F-A510-0BE7D103B18E}"/>
               </a:ext>
             </a:extLst>
           </p:cNvPr>
@@ -22793,7 +22793,7 @@
                 <a:ea typeface="Helvetica Neue"/>
                 <a:cs typeface="Helvetica Neue"/>
               </a:rPr>
-              <a:t>UGen300 hypothesis</a:t>
+              <a:t>UGen300 planning role</a:t>
             </a:r>
           </a:p>
         </p:txBody>
@@ -22803,7 +22803,7 @@
           <p:cNvPr id="11" name="">
             <a:extLst xmlns:a="http://schemas.openxmlformats.org/drawingml/2006/main">
               <a:ext uri="{FF2B5EF4-FFF2-40B4-BE49-F238E27FC236}">
-                <a16:creationId xmlns:a16="http://schemas.microsoft.com/office/drawing/2014/main" id="{3355C4DC-1016-4F53-9B72-398A88389EE8}"/>
+                <a16:creationId xmlns:a16="http://schemas.microsoft.com/office/drawing/2014/main" id="{D80B823F-3B98-43BF-B1E6-A69C276B2705}"/>
               </a:ext>
             </a:extLst>
           </p:cNvPr>
@@ -22834,7 +22834,7 @@
           <p:cNvPr id="12" name="">
             <a:extLst xmlns:a="http://schemas.openxmlformats.org/drawingml/2006/main">
               <a:ext uri="{FF2B5EF4-FFF2-40B4-BE49-F238E27FC236}">
-                <a16:creationId xmlns:a16="http://schemas.microsoft.com/office/drawing/2014/main" id="{39EE8DD2-56D8-44C8-A2AA-4925113EA8C1}"/>
+                <a16:creationId xmlns:a16="http://schemas.microsoft.com/office/drawing/2014/main" id="{2AC12421-9717-4278-B033-1D984B32BAB7}"/>
               </a:ext>
             </a:extLst>
           </p:cNvPr>
@@ -22865,7 +22865,7 @@
           <p:cNvPr id="13" name="">
             <a:extLst xmlns:a="http://schemas.openxmlformats.org/drawingml/2006/main">
               <a:ext uri="{FF2B5EF4-FFF2-40B4-BE49-F238E27FC236}">
-                <a16:creationId xmlns:a16="http://schemas.microsoft.com/office/drawing/2014/main" id="{08825ECC-1E33-4FE5-BF11-CB1E30CF8DEC}"/>
+                <a16:creationId xmlns:a16="http://schemas.microsoft.com/office/drawing/2014/main" id="{4B707EA3-7BA1-49B1-AD46-E250D732BFCD}"/>
               </a:ext>
             </a:extLst>
           </p:cNvPr>
@@ -22896,7 +22896,7 @@
           <p:cNvPr id="14" name="">
             <a:extLst xmlns:a="http://schemas.openxmlformats.org/drawingml/2006/main">
               <a:ext uri="{FF2B5EF4-FFF2-40B4-BE49-F238E27FC236}">
-                <a16:creationId xmlns:a16="http://schemas.microsoft.com/office/drawing/2014/main" id="{CF45CD0F-49E3-4FFC-8CA5-7C5A54982CB5}"/>
+                <a16:creationId xmlns:a16="http://schemas.microsoft.com/office/drawing/2014/main" id="{EC95FF02-2000-4121-ABBD-1C6E82075950}"/>
               </a:ext>
             </a:extLst>
           </p:cNvPr>
@@ -23076,7 +23076,7 @@
           <p:cNvPr id="15" name="">
             <a:extLst xmlns:a="http://schemas.openxmlformats.org/drawingml/2006/main">
               <a:ext uri="{FF2B5EF4-FFF2-40B4-BE49-F238E27FC236}">
-                <a16:creationId xmlns:a16="http://schemas.microsoft.com/office/drawing/2014/main" id="{0AF5396C-12BE-4C8B-A974-220C3A60EF3B}"/>
+                <a16:creationId xmlns:a16="http://schemas.microsoft.com/office/drawing/2014/main" id="{335505C2-CBBF-4669-BCF6-5301ED413F6C}"/>
               </a:ext>
             </a:extLst>
           </p:cNvPr>
@@ -23107,7 +23107,7 @@
           <p:cNvPr id="16" name="">
             <a:extLst xmlns:a="http://schemas.openxmlformats.org/drawingml/2006/main">
               <a:ext uri="{FF2B5EF4-FFF2-40B4-BE49-F238E27FC236}">
-                <a16:creationId xmlns:a16="http://schemas.microsoft.com/office/drawing/2014/main" id="{5D75F5F0-4CB3-4422-992D-78CC865E01CD}"/>
+                <a16:creationId xmlns:a16="http://schemas.microsoft.com/office/drawing/2014/main" id="{0321C52D-48FB-4D5C-91A9-9EFC8C4D47E0}"/>
               </a:ext>
             </a:extLst>
           </p:cNvPr>
@@ -23277,7 +23277,7 @@
                 <a:ea typeface="Helvetica Neue"/>
                 <a:cs typeface="Helvetica Neue"/>
               </a:rPr>
-              <a:t>Unselected / unvalidated</a:t>
+              <a:t>Service integration plan</a:t>
             </a:r>
           </a:p>
         </p:txBody>
@@ -23287,7 +23287,7 @@
           <p:cNvPr id="17" name="">
             <a:extLst xmlns:a="http://schemas.openxmlformats.org/drawingml/2006/main">
               <a:ext uri="{FF2B5EF4-FFF2-40B4-BE49-F238E27FC236}">
-                <a16:creationId xmlns:a16="http://schemas.microsoft.com/office/drawing/2014/main" id="{675D778B-422C-4160-85B2-E02F03FD3610}"/>
+                <a16:creationId xmlns:a16="http://schemas.microsoft.com/office/drawing/2014/main" id="{2CEF18F7-4EE2-4DE7-A585-3379BFF70690}"/>
               </a:ext>
             </a:extLst>
           </p:cNvPr>
@@ -23318,7 +23318,7 @@
           <p:cNvPr id="18" name="">
             <a:extLst xmlns:a="http://schemas.openxmlformats.org/drawingml/2006/main">
               <a:ext uri="{FF2B5EF4-FFF2-40B4-BE49-F238E27FC236}">
-                <a16:creationId xmlns:a16="http://schemas.microsoft.com/office/drawing/2014/main" id="{0B5C82C4-C25A-4151-B512-4B31CB67AE4B}"/>
+                <a16:creationId xmlns:a16="http://schemas.microsoft.com/office/drawing/2014/main" id="{7721BF01-2930-47D7-AB1A-A4C54269103D}"/>
               </a:ext>
             </a:extLst>
           </p:cNvPr>
@@ -23349,7 +23349,7 @@
           <p:cNvPr id="19" name="">
             <a:extLst xmlns:a="http://schemas.openxmlformats.org/drawingml/2006/main">
               <a:ext uri="{FF2B5EF4-FFF2-40B4-BE49-F238E27FC236}">
-                <a16:creationId xmlns:a16="http://schemas.microsoft.com/office/drawing/2014/main" id="{4568E153-60C8-4BA7-89CB-0212E9E9763E}"/>
+                <a16:creationId xmlns:a16="http://schemas.microsoft.com/office/drawing/2014/main" id="{1999FDC7-7F8E-4653-8A86-6580AA7B1605}"/>
               </a:ext>
             </a:extLst>
           </p:cNvPr>
@@ -23496,7 +23496,7 @@
                 <a:ea typeface="Helvetica Neue"/>
                 <a:cs typeface="Helvetica Neue"/>
               </a:rPr>
-              <a:t>The device contribution and the video-generation backend require separate validation.</a:t>
+              <a:t>The planned architecture separates context planning, video generation and website playback.</a:t>
             </a:r>
           </a:p>
         </p:txBody>
@@ -23504,7 +23504,7 @@
     </p:spTree>
     <p:extLst>
       <p:ext uri="{BB962C8B-B14F-4D97-AF65-F5344CB8AC3E}">
-        <p14:creationId xmlns:p14="http://schemas.microsoft.com/office/powerpoint/2010/main" val="899168156"/>
+        <p14:creationId xmlns:p14="http://schemas.microsoft.com/office/powerpoint/2010/main" val="942621030"/>
       </p:ext>
     </p:extLst>
   </p:cSld>
@@ -23535,7 +23535,7 @@
           <p:cNvPr id="12" name="">
             <a:extLst xmlns:a="http://schemas.openxmlformats.org/drawingml/2006/main">
               <a:ext uri="{FF2B5EF4-FFF2-40B4-BE49-F238E27FC236}">
-                <a16:creationId xmlns:a16="http://schemas.microsoft.com/office/drawing/2014/main" id="{D9F9E8F8-F765-435C-8E6D-CC5F2DFB2E44}"/>
+                <a16:creationId xmlns:a16="http://schemas.microsoft.com/office/drawing/2014/main" id="{867C0D79-4CCA-495B-934B-226D383DFDC4}"/>
               </a:ext>
             </a:extLst>
           </p:cNvPr>
@@ -23692,7 +23692,7 @@
           <p:cNvPr id="2" name="">
             <a:extLst xmlns:a="http://schemas.openxmlformats.org/drawingml/2006/main">
               <a:ext uri="{FF2B5EF4-FFF2-40B4-BE49-F238E27FC236}">
-                <a16:creationId xmlns:a16="http://schemas.microsoft.com/office/drawing/2014/main" id="{140FB4F0-B891-4DA8-A80D-FBDB64054BD1}"/>
+                <a16:creationId xmlns:a16="http://schemas.microsoft.com/office/drawing/2014/main" id="{A073A5E3-0C9A-474D-BC1B-3C78143E98BD}"/>
               </a:ext>
             </a:extLst>
           </p:cNvPr>
@@ -23723,7 +23723,7 @@
           <p:cNvPr id="3" name="">
             <a:extLst xmlns:a="http://schemas.openxmlformats.org/drawingml/2006/main">
               <a:ext uri="{FF2B5EF4-FFF2-40B4-BE49-F238E27FC236}">
-                <a16:creationId xmlns:a16="http://schemas.microsoft.com/office/drawing/2014/main" id="{741DF5D9-AA4B-400B-A087-71FC96F8F13A}"/>
+                <a16:creationId xmlns:a16="http://schemas.microsoft.com/office/drawing/2014/main" id="{7894C0D6-D572-44BF-B09E-0E6E1F544508}"/>
               </a:ext>
             </a:extLst>
           </p:cNvPr>
@@ -23870,7 +23870,7 @@
                 <a:ea typeface="Helvetica Neue"/>
                 <a:cs typeface="Helvetica Neue"/>
               </a:rPr>
-              <a:t>STAGE I CONCEPT / NO PRODUCT IMPLEMENTATION</a:t>
+              <a:t>STAGE I / PROJECT PLAN</a:t>
             </a:r>
           </a:p>
         </p:txBody>
@@ -23880,7 +23880,7 @@
           <p:cNvPr id="4" name="">
             <a:extLst xmlns:a="http://schemas.openxmlformats.org/drawingml/2006/main">
               <a:ext uri="{FF2B5EF4-FFF2-40B4-BE49-F238E27FC236}">
-                <a16:creationId xmlns:a16="http://schemas.microsoft.com/office/drawing/2014/main" id="{281E4DC5-3F16-4AE9-9CFA-764C6329BEF6}"/>
+                <a16:creationId xmlns:a16="http://schemas.microsoft.com/office/drawing/2014/main" id="{0673537C-690C-4D51-AC2A-89484BB4DEBE}"/>
               </a:ext>
             </a:extLst>
           </p:cNvPr>
@@ -24037,7 +24037,7 @@
           <p:cNvPr id="5" name="">
             <a:extLst xmlns:a="http://schemas.openxmlformats.org/drawingml/2006/main">
               <a:ext uri="{FF2B5EF4-FFF2-40B4-BE49-F238E27FC236}">
-                <a16:creationId xmlns:a16="http://schemas.microsoft.com/office/drawing/2014/main" id="{86E525B0-90BB-4D9F-BE59-483C453160CA}"/>
+                <a16:creationId xmlns:a16="http://schemas.microsoft.com/office/drawing/2014/main" id="{95D504E0-5CC2-4C89-953B-3216773E8A78}"/>
               </a:ext>
             </a:extLst>
           </p:cNvPr>
@@ -24194,7 +24194,7 @@
           <p:cNvPr id="6" name="">
             <a:extLst xmlns:a="http://schemas.openxmlformats.org/drawingml/2006/main">
               <a:ext uri="{FF2B5EF4-FFF2-40B4-BE49-F238E27FC236}">
-                <a16:creationId xmlns:a16="http://schemas.microsoft.com/office/drawing/2014/main" id="{AEB7EFD0-20A1-47A5-88CB-1EAB3C6149FF}"/>
+                <a16:creationId xmlns:a16="http://schemas.microsoft.com/office/drawing/2014/main" id="{10705806-8748-4887-A12F-877B88A410A1}"/>
               </a:ext>
             </a:extLst>
           </p:cNvPr>
@@ -24351,7 +24351,7 @@
           <p:cNvPr id="7" name="">
             <a:extLst xmlns:a="http://schemas.openxmlformats.org/drawingml/2006/main">
               <a:ext uri="{FF2B5EF4-FFF2-40B4-BE49-F238E27FC236}">
-                <a16:creationId xmlns:a16="http://schemas.microsoft.com/office/drawing/2014/main" id="{7A581115-17AB-4526-9AD4-EBC310FD2592}"/>
+                <a16:creationId xmlns:a16="http://schemas.microsoft.com/office/drawing/2014/main" id="{3B22D172-9C45-4EF3-88D5-D0B44875B468}"/>
               </a:ext>
             </a:extLst>
           </p:cNvPr>
@@ -24508,7 +24508,7 @@
           <p:cNvPr id="8" name="">
             <a:extLst xmlns:a="http://schemas.openxmlformats.org/drawingml/2006/main">
               <a:ext uri="{FF2B5EF4-FFF2-40B4-BE49-F238E27FC236}">
-                <a16:creationId xmlns:a16="http://schemas.microsoft.com/office/drawing/2014/main" id="{019BDDDD-F8C3-4E10-8FEF-2DCFE5EA7CDB}"/>
+                <a16:creationId xmlns:a16="http://schemas.microsoft.com/office/drawing/2014/main" id="{F7F17176-A0B5-4CED-A06D-CAB2CED31D67}"/>
               </a:ext>
             </a:extLst>
           </p:cNvPr>
@@ -24665,7 +24665,7 @@
           <p:cNvPr id="9" name="">
             <a:extLst xmlns:a="http://schemas.openxmlformats.org/drawingml/2006/main">
               <a:ext uri="{FF2B5EF4-FFF2-40B4-BE49-F238E27FC236}">
-                <a16:creationId xmlns:a16="http://schemas.microsoft.com/office/drawing/2014/main" id="{97CA2593-5B13-4256-9DAE-C03C47D834A9}"/>
+                <a16:creationId xmlns:a16="http://schemas.microsoft.com/office/drawing/2014/main" id="{8F95EED6-6F62-4525-88BF-8B2DA978DEFC}"/>
               </a:ext>
             </a:extLst>
           </p:cNvPr>
@@ -24822,7 +24822,7 @@
           <p:cNvPr id="10" name="">
             <a:extLst xmlns:a="http://schemas.openxmlformats.org/drawingml/2006/main">
               <a:ext uri="{FF2B5EF4-FFF2-40B4-BE49-F238E27FC236}">
-                <a16:creationId xmlns:a16="http://schemas.microsoft.com/office/drawing/2014/main" id="{378B0D6F-9B3E-4463-8F97-9909AF99418E}"/>
+                <a16:creationId xmlns:a16="http://schemas.microsoft.com/office/drawing/2014/main" id="{C71ADBF3-5309-452F-ACA2-D8E99AF47302}"/>
               </a:ext>
             </a:extLst>
           </p:cNvPr>
@@ -24979,7 +24979,7 @@
           <p:cNvPr id="11" name="">
             <a:extLst xmlns:a="http://schemas.openxmlformats.org/drawingml/2006/main">
               <a:ext uri="{FF2B5EF4-FFF2-40B4-BE49-F238E27FC236}">
-                <a16:creationId xmlns:a16="http://schemas.microsoft.com/office/drawing/2014/main" id="{B2FABFFE-7F05-4F3F-A893-733A01673F43}"/>
+                <a16:creationId xmlns:a16="http://schemas.microsoft.com/office/drawing/2014/main" id="{4FAC40EA-EC80-4419-83E5-7AD57EDECDB3}"/>
               </a:ext>
             </a:extLst>
           </p:cNvPr>
@@ -25126,7 +25126,7 @@
                 <a:ea typeface="Helvetica Neue"/>
                 <a:cs typeface="Helvetica Neue"/>
               </a:rPr>
-              <a:t>No UGen300 video, latency, power or deployment result exists today.</a:t>
+              <a:t>Development will evaluate model support, runtime compatibility and pipeline performance.</a:t>
             </a:r>
           </a:p>
         </p:txBody>
@@ -25134,7 +25134,7 @@
     </p:spTree>
     <p:extLst>
       <p:ext uri="{BB962C8B-B14F-4D97-AF65-F5344CB8AC3E}">
-        <p14:creationId xmlns:p14="http://schemas.microsoft.com/office/powerpoint/2010/main" val="897912556"/>
+        <p14:creationId xmlns:p14="http://schemas.microsoft.com/office/powerpoint/2010/main" val="97930368"/>
       </p:ext>
     </p:extLst>
   </p:cSld>
@@ -25165,7 +25165,7 @@
           <p:cNvPr id="10" name="">
             <a:extLst xmlns:a="http://schemas.openxmlformats.org/drawingml/2006/main">
               <a:ext uri="{FF2B5EF4-FFF2-40B4-BE49-F238E27FC236}">
-                <a16:creationId xmlns:a16="http://schemas.microsoft.com/office/drawing/2014/main" id="{98E327BF-5F0A-4F1F-94EA-D05087F8B78A}"/>
+                <a16:creationId xmlns:a16="http://schemas.microsoft.com/office/drawing/2014/main" id="{433B879A-1BBD-461E-9B9A-B231F6F7230D}"/>
               </a:ext>
             </a:extLst>
           </p:cNvPr>
@@ -25312,7 +25312,7 @@
                 <a:ea typeface="Helvetica Neue"/>
                 <a:cs typeface="Helvetica Neue"/>
               </a:rPr>
-              <a:t>Prior work and new application scope</a:t>
+              <a:t>Reference material and planned development</a:t>
             </a:r>
           </a:p>
         </p:txBody>
@@ -25322,7 +25322,7 @@
           <p:cNvPr id="2" name="">
             <a:extLst xmlns:a="http://schemas.openxmlformats.org/drawingml/2006/main">
               <a:ext uri="{FF2B5EF4-FFF2-40B4-BE49-F238E27FC236}">
-                <a16:creationId xmlns:a16="http://schemas.microsoft.com/office/drawing/2014/main" id="{0DDCFE8C-2A74-4B0C-BAE1-3208C1334295}"/>
+                <a16:creationId xmlns:a16="http://schemas.microsoft.com/office/drawing/2014/main" id="{BEBDC342-1665-4DE4-BAE5-FA3E889E8EDA}"/>
               </a:ext>
             </a:extLst>
           </p:cNvPr>
@@ -25353,7 +25353,7 @@
           <p:cNvPr id="3" name="">
             <a:extLst xmlns:a="http://schemas.openxmlformats.org/drawingml/2006/main">
               <a:ext uri="{FF2B5EF4-FFF2-40B4-BE49-F238E27FC236}">
-                <a16:creationId xmlns:a16="http://schemas.microsoft.com/office/drawing/2014/main" id="{98D80A4F-5C18-4D11-8BD1-DE1229A08B38}"/>
+                <a16:creationId xmlns:a16="http://schemas.microsoft.com/office/drawing/2014/main" id="{1F04FEDD-C47E-444F-BCCC-37075C533681}"/>
               </a:ext>
             </a:extLst>
           </p:cNvPr>
@@ -25500,7 +25500,7 @@
                 <a:ea typeface="Helvetica Neue"/>
                 <a:cs typeface="Helvetica Neue"/>
               </a:rPr>
-              <a:t>STAGE I CONCEPT / NO PRODUCT IMPLEMENTATION</a:t>
+              <a:t>STAGE I / PROJECT PLAN</a:t>
             </a:r>
           </a:p>
         </p:txBody>
@@ -25510,7 +25510,7 @@
           <p:cNvPr id="4" name="">
             <a:extLst xmlns:a="http://schemas.openxmlformats.org/drawingml/2006/main">
               <a:ext uri="{FF2B5EF4-FFF2-40B4-BE49-F238E27FC236}">
-                <a16:creationId xmlns:a16="http://schemas.microsoft.com/office/drawing/2014/main" id="{BA3C5C9E-7EF4-4597-A777-B8F6EFEA088C}"/>
+                <a16:creationId xmlns:a16="http://schemas.microsoft.com/office/drawing/2014/main" id="{7026DA93-EBC0-44C9-8160-A41496A513BC}"/>
               </a:ext>
             </a:extLst>
           </p:cNvPr>
@@ -25667,7 +25667,7 @@
           <p:cNvPr id="5" name="">
             <a:extLst xmlns:a="http://schemas.openxmlformats.org/drawingml/2006/main">
               <a:ext uri="{FF2B5EF4-FFF2-40B4-BE49-F238E27FC236}">
-                <a16:creationId xmlns:a16="http://schemas.microsoft.com/office/drawing/2014/main" id="{163A1F43-E5DC-41BD-90B2-580EE9F1E54C}"/>
+                <a16:creationId xmlns:a16="http://schemas.microsoft.com/office/drawing/2014/main" id="{92E6FC50-8649-4D73-97D2-D2B8AB7A0F1D}"/>
               </a:ext>
             </a:extLst>
           </p:cNvPr>
@@ -25814,7 +25814,7 @@
                 <a:ea typeface="Helvetica Neue"/>
                 <a:cs typeface="Helvetica Neue"/>
               </a:rPr>
-              <a:t>Prior public material</a:t>
+              <a:t>Existing visual references</a:t>
             </a:r>
           </a:p>
         </p:txBody>
@@ -25824,7 +25824,7 @@
           <p:cNvPr id="6" name="">
             <a:extLst xmlns:a="http://schemas.openxmlformats.org/drawingml/2006/main">
               <a:ext uri="{FF2B5EF4-FFF2-40B4-BE49-F238E27FC236}">
-                <a16:creationId xmlns:a16="http://schemas.microsoft.com/office/drawing/2014/main" id="{A3685FB6-A00D-4BB7-AD1E-F19C690E7038}"/>
+                <a16:creationId xmlns:a16="http://schemas.microsoft.com/office/drawing/2014/main" id="{E63A3CD3-889D-4110-87F0-2E4E895B0F8B}"/>
               </a:ext>
             </a:extLst>
           </p:cNvPr>
@@ -25971,7 +25971,7 @@
                 <a:ea typeface="Helvetica Neue"/>
                 <a:cs typeface="Helvetica Neue"/>
               </a:rPr>
-              <a:t>New proposal work</a:t>
+              <a:t>Planned observation system</a:t>
             </a:r>
           </a:p>
         </p:txBody>
@@ -25981,7 +25981,7 @@
           <p:cNvPr id="7" name="">
             <a:extLst xmlns:a="http://schemas.openxmlformats.org/drawingml/2006/main">
               <a:ext uri="{FF2B5EF4-FFF2-40B4-BE49-F238E27FC236}">
-                <a16:creationId xmlns:a16="http://schemas.microsoft.com/office/drawing/2014/main" id="{3D158DB6-AEE2-49A5-BD90-33436AF2208F}"/>
+                <a16:creationId xmlns:a16="http://schemas.microsoft.com/office/drawing/2014/main" id="{4BE2DEFF-5175-4A8E-B2D3-5F85EA6C9F6F}"/>
               </a:ext>
             </a:extLst>
           </p:cNvPr>
@@ -26151,7 +26151,7 @@
                 <a:ea typeface="Helvetica Neue"/>
                 <a:cs typeface="Helvetica Neue"/>
               </a:rPr>
-              <a:t>Habitat imagery, species setting</a:t>
+              <a:t>Habitat artwork</a:t>
             </a:r>
           </a:p>
           <a:p xmlns:a="http://schemas.openxmlformats.org/drawingml/2006/main">
@@ -26174,12 +26174,7 @@
                 <a:ea typeface="Helvetica Neue"/>
                 <a:cs typeface="Helvetica Neue"/>
               </a:rPr>
-              <a:t>and pre-existing video clips</a:t>
-            </a:r>
-          </a:p>
-          <a:p xmlns:a="http://schemas.openxmlformats.org/drawingml/2006/main">
-            <a:r>
-              <a:t/>
+              <a:t>Species settings</a:t>
             </a:r>
           </a:p>
           <a:p xmlns:a="http://schemas.openxmlformats.org/drawingml/2006/main">
@@ -26202,30 +26197,7 @@
                 <a:ea typeface="Helvetica Neue"/>
                 <a:cs typeface="Helvetica Neue"/>
               </a:rPr>
-              <a:t>Separate Studio product</a:t>
-            </a:r>
-          </a:p>
-          <a:p xmlns:a="http://schemas.openxmlformats.org/drawingml/2006/main">
-            <a:pPr>
-              <a:defRPr sz="1950" b="0">
-                <a:solidFill>
-                  <a:srgbClr val="14362D"/>
-                </a:solidFill>
-                <a:latin typeface="Helvetica Neue"/>
-                <a:ea typeface="Helvetica Neue"/>
-                <a:cs typeface="Helvetica Neue"/>
-              </a:defRPr>
-            </a:pPr>
-            <a:r>
-              <a:rPr sz="1950" b="0">
-                <a:solidFill>
-                  <a:srgbClr val="14362D"/>
-                </a:solidFill>
-                <a:latin typeface="Helvetica Neue"/>
-                <a:ea typeface="Helvetica Neue"/>
-                <a:cs typeface="Helvetica Neue"/>
-              </a:rPr>
-              <a:t>Story-to-world authoring context</a:t>
+              <a:t>Published concept clips</a:t>
             </a:r>
           </a:p>
         </p:txBody>
@@ -26235,7 +26207,7 @@
           <p:cNvPr id="8" name="">
             <a:extLst xmlns:a="http://schemas.openxmlformats.org/drawingml/2006/main">
               <a:ext uri="{FF2B5EF4-FFF2-40B4-BE49-F238E27FC236}">
-                <a16:creationId xmlns:a16="http://schemas.microsoft.com/office/drawing/2014/main" id="{42677F9C-E22B-4397-A25F-DD7F4A606507}"/>
+                <a16:creationId xmlns:a16="http://schemas.microsoft.com/office/drawing/2014/main" id="{F982BFC5-696B-4F65-9FAF-16D7283EC6EF}"/>
               </a:ext>
             </a:extLst>
           </p:cNvPr>
@@ -26382,7 +26354,7 @@
                 <a:ea typeface="Helvetica Neue"/>
                 <a:cs typeface="Helvetica Neue"/>
               </a:rPr>
-              <a:t>Page-open observation design</a:t>
+              <a:t>Page-open observation requests</a:t>
             </a:r>
           </a:p>
           <a:p xmlns:a="http://schemas.openxmlformats.org/drawingml/2006/main">
@@ -26405,7 +26377,7 @@
                 <a:ea typeface="Helvetica Neue"/>
                 <a:cs typeface="Helvetica Neue"/>
               </a:rPr>
-              <a:t>Context and constraint interface</a:t>
+              <a:t>World rules and scenario planning</a:t>
             </a:r>
           </a:p>
           <a:p xmlns:a="http://schemas.openxmlformats.org/drawingml/2006/main">
@@ -26428,7 +26400,7 @@
                 <a:ea typeface="Helvetica Neue"/>
                 <a:cs typeface="Helvetica Neue"/>
               </a:rPr>
-              <a:t>Hand-authored payload examples</a:t>
+              <a:t>Reference-conditioned prompts</a:t>
             </a:r>
           </a:p>
           <a:p xmlns:a="http://schemas.openxmlformats.org/drawingml/2006/main">
@@ -26451,7 +26423,7 @@
                 <a:ea typeface="Helvetica Neue"/>
                 <a:cs typeface="Helvetica Neue"/>
               </a:rPr>
-              <a:t>Hardware evaluation plan</a:t>
+              <a:t>Video-service integration</a:t>
             </a:r>
           </a:p>
           <a:p xmlns:a="http://schemas.openxmlformats.org/drawingml/2006/main">
@@ -26474,7 +26446,7 @@
                 <a:ea typeface="Helvetica Neue"/>
                 <a:cs typeface="Helvetica Neue"/>
               </a:rPr>
-              <a:t>Proposal, slides and video script</a:t>
+              <a:t>Embeddable website component</a:t>
             </a:r>
           </a:p>
         </p:txBody>
@@ -26484,7 +26456,7 @@
           <p:cNvPr id="9" name="">
             <a:extLst xmlns:a="http://schemas.openxmlformats.org/drawingml/2006/main">
               <a:ext uri="{FF2B5EF4-FFF2-40B4-BE49-F238E27FC236}">
-                <a16:creationId xmlns:a16="http://schemas.microsoft.com/office/drawing/2014/main" id="{40EC2945-7F6C-4656-9527-93961C66C9AE}"/>
+                <a16:creationId xmlns:a16="http://schemas.microsoft.com/office/drawing/2014/main" id="{6486009B-99C4-47DD-A391-1DB35C6C5196}"/>
               </a:ext>
             </a:extLst>
           </p:cNvPr>
@@ -26631,7 +26603,7 @@
                 <a:ea typeface="Helvetica Neue"/>
                 <a:cs typeface="Helvetica Neue"/>
               </a:rPr>
-              <a:t>No Studio code copied. Disclosure does not establish originality eligibility.</a:t>
+              <a:t>Reference credits and rights information accompany the project materials.</a:t>
             </a:r>
           </a:p>
         </p:txBody>
@@ -26639,7 +26611,7 @@
     </p:spTree>
     <p:extLst>
       <p:ext uri="{BB962C8B-B14F-4D97-AF65-F5344CB8AC3E}">
-        <p14:creationId xmlns:p14="http://schemas.microsoft.com/office/powerpoint/2010/main" val="172958740"/>
+        <p14:creationId xmlns:p14="http://schemas.microsoft.com/office/powerpoint/2010/main" val="1084959994"/>
       </p:ext>
     </p:extLst>
   </p:cSld>
@@ -26670,7 +26642,7 @@
           <p:cNvPr id="14" name="">
             <a:extLst xmlns:a="http://schemas.openxmlformats.org/drawingml/2006/main">
               <a:ext uri="{FF2B5EF4-FFF2-40B4-BE49-F238E27FC236}">
-                <a16:creationId xmlns:a16="http://schemas.microsoft.com/office/drawing/2014/main" id="{1F532742-1466-48A4-904C-66CB859DF43F}"/>
+                <a16:creationId xmlns:a16="http://schemas.microsoft.com/office/drawing/2014/main" id="{2C970DC7-CFFD-4AB4-92AE-494EC129C384}"/>
               </a:ext>
             </a:extLst>
           </p:cNvPr>
@@ -26817,7 +26789,7 @@
                 <a:ea typeface="Helvetica Neue"/>
                 <a:cs typeface="Helvetica Neue"/>
               </a:rPr>
-              <a:t>What exists today</a:t>
+              <a:t>Website observation component</a:t>
             </a:r>
           </a:p>
         </p:txBody>
@@ -26827,7 +26799,7 @@
           <p:cNvPr id="2" name="">
             <a:extLst xmlns:a="http://schemas.openxmlformats.org/drawingml/2006/main">
               <a:ext uri="{FF2B5EF4-FFF2-40B4-BE49-F238E27FC236}">
-                <a16:creationId xmlns:a16="http://schemas.microsoft.com/office/drawing/2014/main" id="{C629D084-2DD6-4ADB-8F11-4E0A65605AC0}"/>
+                <a16:creationId xmlns:a16="http://schemas.microsoft.com/office/drawing/2014/main" id="{11E3360C-7544-4EB3-AAB2-0EBD562A6361}"/>
               </a:ext>
             </a:extLst>
           </p:cNvPr>
@@ -26858,7 +26830,7 @@
           <p:cNvPr id="3" name="">
             <a:extLst xmlns:a="http://schemas.openxmlformats.org/drawingml/2006/main">
               <a:ext uri="{FF2B5EF4-FFF2-40B4-BE49-F238E27FC236}">
-                <a16:creationId xmlns:a16="http://schemas.microsoft.com/office/drawing/2014/main" id="{84D4DDA7-313E-4E78-AD07-F472FF3E0BD0}"/>
+                <a16:creationId xmlns:a16="http://schemas.microsoft.com/office/drawing/2014/main" id="{B971E71C-3A2B-4778-A0C9-4260D1AA64FD}"/>
               </a:ext>
             </a:extLst>
           </p:cNvPr>
@@ -27005,7 +26977,7 @@
                 <a:ea typeface="Helvetica Neue"/>
                 <a:cs typeface="Helvetica Neue"/>
               </a:rPr>
-              <a:t>STAGE I CONCEPT / NO PRODUCT IMPLEMENTATION</a:t>
+              <a:t>STAGE I / PROJECT PLAN</a:t>
             </a:r>
           </a:p>
         </p:txBody>
@@ -27015,7 +26987,7 @@
           <p:cNvPr id="4" name="">
             <a:extLst xmlns:a="http://schemas.openxmlformats.org/drawingml/2006/main">
               <a:ext uri="{FF2B5EF4-FFF2-40B4-BE49-F238E27FC236}">
-                <a16:creationId xmlns:a16="http://schemas.microsoft.com/office/drawing/2014/main" id="{F7BDCEBA-8484-4F65-8554-EA6CBCBB4607}"/>
+                <a16:creationId xmlns:a16="http://schemas.microsoft.com/office/drawing/2014/main" id="{382B1562-D7ED-4138-8275-83715E727DB4}"/>
               </a:ext>
             </a:extLst>
           </p:cNvPr>
@@ -27172,7 +27144,7 @@
           <p:cNvPr id="5" name="">
             <a:extLst xmlns:a="http://schemas.openxmlformats.org/drawingml/2006/main">
               <a:ext uri="{FF2B5EF4-FFF2-40B4-BE49-F238E27FC236}">
-                <a16:creationId xmlns:a16="http://schemas.microsoft.com/office/drawing/2014/main" id="{58698572-CF57-4A30-A402-A1B7AA716F40}"/>
+                <a16:creationId xmlns:a16="http://schemas.microsoft.com/office/drawing/2014/main" id="{48796028-797E-4EE8-8C33-3AD2658DA6AE}"/>
               </a:ext>
             </a:extLst>
           </p:cNvPr>
@@ -27199,7 +27171,7 @@
           <a:bodyPr xmlns:a="http://schemas.openxmlformats.org/drawingml/2006/main"/>
           <a:lstStyle xmlns:a="http://schemas.openxmlformats.org/drawingml/2006/main">
             <a:defPPr>
-              <a:defRPr sz="1800" b="1">
+              <a:defRPr sz="2550" b="1">
                 <a:solidFill>
                   <a:srgbClr val="2F7760"/>
                 </a:solidFill>
@@ -27209,7 +27181,7 @@
               </a:defRPr>
             </a:defPPr>
             <a:lvl1pPr>
-              <a:defRPr sz="1800" b="1">
+              <a:defRPr sz="2550" b="1">
                 <a:solidFill>
                   <a:srgbClr val="2F7760"/>
                 </a:solidFill>
@@ -27219,7 +27191,7 @@
               </a:defRPr>
             </a:lvl1pPr>
             <a:lvl2pPr>
-              <a:defRPr sz="1800" b="1">
+              <a:defRPr sz="2550" b="1">
                 <a:solidFill>
                   <a:srgbClr val="2F7760"/>
                 </a:solidFill>
@@ -27229,7 +27201,7 @@
               </a:defRPr>
             </a:lvl2pPr>
             <a:lvl3pPr>
-              <a:defRPr sz="1800" b="1">
+              <a:defRPr sz="2550" b="1">
                 <a:solidFill>
                   <a:srgbClr val="2F7760"/>
                 </a:solidFill>
@@ -27239,7 +27211,7 @@
               </a:defRPr>
             </a:lvl3pPr>
             <a:lvl4pPr>
-              <a:defRPr sz="1800" b="1">
+              <a:defRPr sz="2550" b="1">
                 <a:solidFill>
                   <a:srgbClr val="2F7760"/>
                 </a:solidFill>
@@ -27249,7 +27221,7 @@
               </a:defRPr>
             </a:lvl4pPr>
             <a:lvl5pPr>
-              <a:defRPr sz="1800" b="1">
+              <a:defRPr sz="2550" b="1">
                 <a:solidFill>
                   <a:srgbClr val="2F7760"/>
                 </a:solidFill>
@@ -27259,7 +27231,7 @@
               </a:defRPr>
             </a:lvl5pPr>
             <a:lvl6pPr>
-              <a:defRPr sz="1800" b="1">
+              <a:defRPr sz="2550" b="1">
                 <a:solidFill>
                   <a:srgbClr val="2F7760"/>
                 </a:solidFill>
@@ -27269,7 +27241,7 @@
               </a:defRPr>
             </a:lvl6pPr>
             <a:lvl7pPr>
-              <a:defRPr sz="1800" b="1">
+              <a:defRPr sz="2550" b="1">
                 <a:solidFill>
                   <a:srgbClr val="2F7760"/>
                 </a:solidFill>
@@ -27279,7 +27251,7 @@
               </a:defRPr>
             </a:lvl7pPr>
             <a:lvl8pPr>
-              <a:defRPr sz="1800" b="1">
+              <a:defRPr sz="2550" b="1">
                 <a:solidFill>
                   <a:srgbClr val="2F7760"/>
                 </a:solidFill>
@@ -27289,7 +27261,7 @@
               </a:defRPr>
             </a:lvl8pPr>
             <a:lvl9pPr>
-              <a:defRPr sz="1800" b="1">
+              <a:defRPr sz="2550" b="1">
                 <a:solidFill>
                   <a:srgbClr val="2F7760"/>
                 </a:solidFill>
@@ -27301,7 +27273,7 @@
           </a:lstStyle>
           <a:p xmlns:a="http://schemas.openxmlformats.org/drawingml/2006/main">
             <a:pPr>
-              <a:defRPr sz="1800" b="1">
+              <a:defRPr sz="2550" b="1">
                 <a:solidFill>
                   <a:srgbClr val="2F7760"/>
                 </a:solidFill>
@@ -27311,7 +27283,7 @@
               </a:defRPr>
             </a:pPr>
             <a:r>
-              <a:rPr sz="1800" b="1">
+              <a:rPr sz="2550" b="1">
                 <a:solidFill>
                   <a:srgbClr val="2F7760"/>
                 </a:solidFill>
@@ -27319,7 +27291,7 @@
                 <a:ea typeface="Helvetica Neue"/>
                 <a:cs typeface="Helvetica Neue"/>
               </a:rPr>
-              <a:t>YES</a:t>
+              <a:t>01</a:t>
             </a:r>
           </a:p>
         </p:txBody>
@@ -27329,7 +27301,7 @@
           <p:cNvPr id="6" name="">
             <a:extLst xmlns:a="http://schemas.openxmlformats.org/drawingml/2006/main">
               <a:ext uri="{FF2B5EF4-FFF2-40B4-BE49-F238E27FC236}">
-                <a16:creationId xmlns:a16="http://schemas.microsoft.com/office/drawing/2014/main" id="{CFC6DE1A-51E1-4B84-8943-354505CBB1B2}"/>
+                <a16:creationId xmlns:a16="http://schemas.microsoft.com/office/drawing/2014/main" id="{DDCDE26E-8DC0-4E6C-BABC-528C23661B28}"/>
               </a:ext>
             </a:extLst>
           </p:cNvPr>
@@ -27476,7 +27448,7 @@
                 <a:ea typeface="Helvetica Neue"/>
                 <a:cs typeface="Helvetica Neue"/>
               </a:rPr>
-              <a:t>Reviewable application materials</a:t>
+              <a:t>Scene configuration</a:t>
             </a:r>
           </a:p>
         </p:txBody>
@@ -27486,7 +27458,7 @@
           <p:cNvPr id="7" name="">
             <a:extLst xmlns:a="http://schemas.openxmlformats.org/drawingml/2006/main">
               <a:ext uri="{FF2B5EF4-FFF2-40B4-BE49-F238E27FC236}">
-                <a16:creationId xmlns:a16="http://schemas.microsoft.com/office/drawing/2014/main" id="{AB80DB4F-56D1-400D-B701-7D8062ADA99D}"/>
+                <a16:creationId xmlns:a16="http://schemas.microsoft.com/office/drawing/2014/main" id="{6E2F6E7E-D785-4086-BFFE-8E579F405EBA}"/>
               </a:ext>
             </a:extLst>
           </p:cNvPr>
@@ -27633,7 +27605,7 @@
                 <a:ea typeface="Helvetica Neue"/>
                 <a:cs typeface="Helvetica Neue"/>
               </a:rPr>
-              <a:t>Proposal, editable deck, draft schemas, written examples and a source register.</a:t>
+              <a:t>Operators select the domain, references, eligible subjects, time and climate options.</a:t>
             </a:r>
           </a:p>
         </p:txBody>
@@ -27643,7 +27615,7 @@
           <p:cNvPr id="8" name="">
             <a:extLst xmlns:a="http://schemas.openxmlformats.org/drawingml/2006/main">
               <a:ext uri="{FF2B5EF4-FFF2-40B4-BE49-F238E27FC236}">
-                <a16:creationId xmlns:a16="http://schemas.microsoft.com/office/drawing/2014/main" id="{E059EF22-E9DE-4915-A676-44DDC78097B6}"/>
+                <a16:creationId xmlns:a16="http://schemas.microsoft.com/office/drawing/2014/main" id="{28EDA375-23EB-40BE-89F0-11C0405404F5}"/>
               </a:ext>
             </a:extLst>
           </p:cNvPr>
@@ -27790,7 +27762,7 @@
                 <a:ea typeface="Helvetica Neue"/>
                 <a:cs typeface="Helvetica Neue"/>
               </a:rPr>
-              <a:t>NO</a:t>
+              <a:t>02</a:t>
             </a:r>
           </a:p>
         </p:txBody>
@@ -27800,7 +27772,7 @@
           <p:cNvPr id="9" name="">
             <a:extLst xmlns:a="http://schemas.openxmlformats.org/drawingml/2006/main">
               <a:ext uri="{FF2B5EF4-FFF2-40B4-BE49-F238E27FC236}">
-                <a16:creationId xmlns:a16="http://schemas.microsoft.com/office/drawing/2014/main" id="{DBD93459-0946-44C1-BAF2-C6711C8A3E20}"/>
+                <a16:creationId xmlns:a16="http://schemas.microsoft.com/office/drawing/2014/main" id="{3A737620-7239-4CD6-8451-AEF796A15A3C}"/>
               </a:ext>
             </a:extLst>
           </p:cNvPr>
@@ -27947,7 +27919,7 @@
                 <a:ea typeface="Helvetica Neue"/>
                 <a:cs typeface="Helvetica Neue"/>
               </a:rPr>
-              <a:t>Operating product implementation</a:t>
+              <a:t>Observation experience</a:t>
             </a:r>
           </a:p>
         </p:txBody>
@@ -27957,7 +27929,7 @@
           <p:cNvPr id="10" name="">
             <a:extLst xmlns:a="http://schemas.openxmlformats.org/drawingml/2006/main">
               <a:ext uri="{FF2B5EF4-FFF2-40B4-BE49-F238E27FC236}">
-                <a16:creationId xmlns:a16="http://schemas.microsoft.com/office/drawing/2014/main" id="{A6C119D0-8611-4336-BE17-388BC0564D6F}"/>
+                <a16:creationId xmlns:a16="http://schemas.microsoft.com/office/drawing/2014/main" id="{533F78D6-CAF3-4A97-87A7-6873D6595D3E}"/>
               </a:ext>
             </a:extLst>
           </p:cNvPr>
@@ -28104,7 +28076,7 @@
                 <a:ea typeface="Helvetica Neue"/>
                 <a:cs typeface="Helvetica Neue"/>
               </a:rPr>
-              <a:t>No scenario model, video adapter, generated-on-open page or deployed service.</a:t>
+              <a:t>The component would show request status, video, context and another-observation controls.</a:t>
             </a:r>
           </a:p>
         </p:txBody>
@@ -28114,7 +28086,7 @@
           <p:cNvPr id="11" name="">
             <a:extLst xmlns:a="http://schemas.openxmlformats.org/drawingml/2006/main">
               <a:ext uri="{FF2B5EF4-FFF2-40B4-BE49-F238E27FC236}">
-                <a16:creationId xmlns:a16="http://schemas.microsoft.com/office/drawing/2014/main" id="{C3A1BAC4-0F46-45CE-8F0A-1CDF2C36DC59}"/>
+                <a16:creationId xmlns:a16="http://schemas.microsoft.com/office/drawing/2014/main" id="{25E17926-7E4A-4D1D-B33D-DB2373C71570}"/>
               </a:ext>
             </a:extLst>
           </p:cNvPr>
@@ -28261,7 +28233,7 @@
                 <a:ea typeface="Helvetica Neue"/>
                 <a:cs typeface="Helvetica Neue"/>
               </a:rPr>
-              <a:t>NO</a:t>
+              <a:t>03</a:t>
             </a:r>
           </a:p>
         </p:txBody>
@@ -28271,7 +28243,7 @@
           <p:cNvPr id="12" name="">
             <a:extLst xmlns:a="http://schemas.openxmlformats.org/drawingml/2006/main">
               <a:ext uri="{FF2B5EF4-FFF2-40B4-BE49-F238E27FC236}">
-                <a16:creationId xmlns:a16="http://schemas.microsoft.com/office/drawing/2014/main" id="{9158C58C-0C5D-427E-B16F-61C1EB7DE459}"/>
+                <a16:creationId xmlns:a16="http://schemas.microsoft.com/office/drawing/2014/main" id="{A3E69286-5BD8-4369-B0B8-D7E19C1E73D1}"/>
               </a:ext>
             </a:extLst>
           </p:cNvPr>
@@ -28418,7 +28390,7 @@
                 <a:ea typeface="Helvetica Neue"/>
                 <a:cs typeface="Helvetica Neue"/>
               </a:rPr>
-              <a:t>Hardware and performance evidence</a:t>
+              <a:t>Website integration</a:t>
             </a:r>
           </a:p>
         </p:txBody>
@@ -28428,7 +28400,7 @@
           <p:cNvPr id="13" name="">
             <a:extLst xmlns:a="http://schemas.openxmlformats.org/drawingml/2006/main">
               <a:ext uri="{FF2B5EF4-FFF2-40B4-BE49-F238E27FC236}">
-                <a16:creationId xmlns:a16="http://schemas.microsoft.com/office/drawing/2014/main" id="{C0D6DCF9-DD07-449A-94A4-180941978422}"/>
+                <a16:creationId xmlns:a16="http://schemas.microsoft.com/office/drawing/2014/main" id="{8B56BD7B-75A0-43B5-98CB-E7AD419FE2DD}"/>
               </a:ext>
             </a:extLst>
           </p:cNvPr>
@@ -28575,7 +28547,7 @@
                 <a:ea typeface="Helvetica Neue"/>
                 <a:cs typeface="Helvetica Neue"/>
               </a:rPr>
-              <a:t>No UGen300 integration, device-generated video, latency or power measurements.</a:t>
+              <a:t>The planned component would embed into story, character, location or brand pages.</a:t>
             </a:r>
           </a:p>
         </p:txBody>
@@ -28583,7 +28555,7 @@
     </p:spTree>
     <p:extLst>
       <p:ext uri="{BB962C8B-B14F-4D97-AF65-F5344CB8AC3E}">
-        <p14:creationId xmlns:p14="http://schemas.microsoft.com/office/powerpoint/2010/main" val="1635322556"/>
+        <p14:creationId xmlns:p14="http://schemas.microsoft.com/office/powerpoint/2010/main" val="2076979324"/>
       </p:ext>
     </p:extLst>
   </p:cSld>

</xml_diff>